<commit_message>
paper: flow diagram context
</commit_message>
<xml_diff>
--- a/paper/figures/HDSA_MD_Overview.pptx
+++ b/paper/figures/HDSA_MD_Overview.pptx
@@ -271,7 +271,7 @@
           <a:p>
             <a:fld id="{547A4ACA-080D-2846-BC7A-301AD37AA2EA}" type="datetimeFigureOut">
               <a:rPr lang="en-US" smtClean="0"/>
-              <a:t>5/5/25</a:t>
+              <a:t>5/6/25</a:t>
             </a:fld>
             <a:endParaRPr lang="en-US"/>
           </a:p>
@@ -469,7 +469,7 @@
           <a:p>
             <a:fld id="{547A4ACA-080D-2846-BC7A-301AD37AA2EA}" type="datetimeFigureOut">
               <a:rPr lang="en-US" smtClean="0"/>
-              <a:t>5/5/25</a:t>
+              <a:t>5/6/25</a:t>
             </a:fld>
             <a:endParaRPr lang="en-US"/>
           </a:p>
@@ -677,7 +677,7 @@
           <a:p>
             <a:fld id="{547A4ACA-080D-2846-BC7A-301AD37AA2EA}" type="datetimeFigureOut">
               <a:rPr lang="en-US" smtClean="0"/>
-              <a:t>5/5/25</a:t>
+              <a:t>5/6/25</a:t>
             </a:fld>
             <a:endParaRPr lang="en-US"/>
           </a:p>
@@ -875,7 +875,7 @@
           <a:p>
             <a:fld id="{547A4ACA-080D-2846-BC7A-301AD37AA2EA}" type="datetimeFigureOut">
               <a:rPr lang="en-US" smtClean="0"/>
-              <a:t>5/5/25</a:t>
+              <a:t>5/6/25</a:t>
             </a:fld>
             <a:endParaRPr lang="en-US"/>
           </a:p>
@@ -1150,7 +1150,7 @@
           <a:p>
             <a:fld id="{547A4ACA-080D-2846-BC7A-301AD37AA2EA}" type="datetimeFigureOut">
               <a:rPr lang="en-US" smtClean="0"/>
-              <a:t>5/5/25</a:t>
+              <a:t>5/6/25</a:t>
             </a:fld>
             <a:endParaRPr lang="en-US"/>
           </a:p>
@@ -1415,7 +1415,7 @@
           <a:p>
             <a:fld id="{547A4ACA-080D-2846-BC7A-301AD37AA2EA}" type="datetimeFigureOut">
               <a:rPr lang="en-US" smtClean="0"/>
-              <a:t>5/5/25</a:t>
+              <a:t>5/6/25</a:t>
             </a:fld>
             <a:endParaRPr lang="en-US"/>
           </a:p>
@@ -1827,7 +1827,7 @@
           <a:p>
             <a:fld id="{547A4ACA-080D-2846-BC7A-301AD37AA2EA}" type="datetimeFigureOut">
               <a:rPr lang="en-US" smtClean="0"/>
-              <a:t>5/5/25</a:t>
+              <a:t>5/6/25</a:t>
             </a:fld>
             <a:endParaRPr lang="en-US"/>
           </a:p>
@@ -1968,7 +1968,7 @@
           <a:p>
             <a:fld id="{547A4ACA-080D-2846-BC7A-301AD37AA2EA}" type="datetimeFigureOut">
               <a:rPr lang="en-US" smtClean="0"/>
-              <a:t>5/5/25</a:t>
+              <a:t>5/6/25</a:t>
             </a:fld>
             <a:endParaRPr lang="en-US"/>
           </a:p>
@@ -2081,7 +2081,7 @@
           <a:p>
             <a:fld id="{547A4ACA-080D-2846-BC7A-301AD37AA2EA}" type="datetimeFigureOut">
               <a:rPr lang="en-US" smtClean="0"/>
-              <a:t>5/5/25</a:t>
+              <a:t>5/6/25</a:t>
             </a:fld>
             <a:endParaRPr lang="en-US"/>
           </a:p>
@@ -2392,7 +2392,7 @@
           <a:p>
             <a:fld id="{547A4ACA-080D-2846-BC7A-301AD37AA2EA}" type="datetimeFigureOut">
               <a:rPr lang="en-US" smtClean="0"/>
-              <a:t>5/5/25</a:t>
+              <a:t>5/6/25</a:t>
             </a:fld>
             <a:endParaRPr lang="en-US"/>
           </a:p>
@@ -2680,7 +2680,7 @@
           <a:p>
             <a:fld id="{547A4ACA-080D-2846-BC7A-301AD37AA2EA}" type="datetimeFigureOut">
               <a:rPr lang="en-US" smtClean="0"/>
-              <a:t>5/5/25</a:t>
+              <a:t>5/6/25</a:t>
             </a:fld>
             <a:endParaRPr lang="en-US"/>
           </a:p>
@@ -2921,7 +2921,7 @@
           <a:p>
             <a:fld id="{547A4ACA-080D-2846-BC7A-301AD37AA2EA}" type="datetimeFigureOut">
               <a:rPr lang="en-US" smtClean="0"/>
-              <a:t>5/5/25</a:t>
+              <a:t>5/6/25</a:t>
             </a:fld>
             <a:endParaRPr lang="en-US"/>
           </a:p>
@@ -6166,7 +6166,7 @@
           </p:blipFill>
           <p:spPr>
             <a:xfrm>
-              <a:off x="932792" y="3080628"/>
+              <a:off x="932792" y="3068271"/>
               <a:ext cx="2590800" cy="330200"/>
             </a:xfrm>
             <a:prstGeom prst="rect">
@@ -6312,7 +6312,7 @@
           </p:blipFill>
           <p:spPr>
             <a:xfrm>
-              <a:off x="1205842" y="4089841"/>
+              <a:off x="1205842" y="4115241"/>
               <a:ext cx="2044700" cy="215900"/>
             </a:xfrm>
             <a:prstGeom prst="rect">
@@ -7014,12 +7014,258 @@
           </a:fontRef>
         </p:style>
       </p:cxnSp>
+      <p:cxnSp>
+        <p:nvCxnSpPr>
+          <p:cNvPr id="64" name="Straight Arrow Connector 63">
+            <a:extLst>
+              <a:ext uri="{FF2B5EF4-FFF2-40B4-BE49-F238E27FC236}">
+                <a16:creationId xmlns:a16="http://schemas.microsoft.com/office/drawing/2014/main" id="{40A74146-1B8E-9173-8386-0F1D3FE77AAA}"/>
+              </a:ext>
+            </a:extLst>
+          </p:cNvPr>
+          <p:cNvCxnSpPr>
+            <a:cxnSpLocks/>
+            <a:stCxn id="22" idx="2"/>
+            <a:endCxn id="20" idx="0"/>
+          </p:cNvCxnSpPr>
+          <p:nvPr/>
+        </p:nvCxnSpPr>
+        <p:spPr>
+          <a:xfrm>
+            <a:off x="5339910" y="2530658"/>
+            <a:ext cx="0" cy="1705093"/>
+          </a:xfrm>
+          <a:prstGeom prst="straightConnector1">
+            <a:avLst/>
+          </a:prstGeom>
+          <a:ln w="12700">
+            <a:solidFill>
+              <a:schemeClr val="tx1"/>
+            </a:solidFill>
+            <a:headEnd type="none" w="med" len="med"/>
+            <a:tailEnd type="arrow" w="med" len="med"/>
+          </a:ln>
+        </p:spPr>
+        <p:style>
+          <a:lnRef idx="2">
+            <a:schemeClr val="accent1"/>
+          </a:lnRef>
+          <a:fillRef idx="0">
+            <a:schemeClr val="accent1"/>
+          </a:fillRef>
+          <a:effectRef idx="1">
+            <a:schemeClr val="accent1"/>
+          </a:effectRef>
+          <a:fontRef idx="minor">
+            <a:schemeClr val="tx1"/>
+          </a:fontRef>
+        </p:style>
+      </p:cxnSp>
+      <p:sp>
+        <p:nvSpPr>
+          <p:cNvPr id="119" name="TextBox 118">
+            <a:extLst>
+              <a:ext uri="{FF2B5EF4-FFF2-40B4-BE49-F238E27FC236}">
+                <a16:creationId xmlns:a16="http://schemas.microsoft.com/office/drawing/2014/main" id="{CD0D19A2-B0F3-D181-5AA6-408678A394C3}"/>
+              </a:ext>
+            </a:extLst>
+          </p:cNvPr>
+          <p:cNvSpPr txBox="1"/>
+          <p:nvPr/>
+        </p:nvSpPr>
+        <p:spPr>
+          <a:xfrm>
+            <a:off x="700138" y="1203306"/>
+            <a:ext cx="2596801" cy="307777"/>
+          </a:xfrm>
+          <a:prstGeom prst="rect">
+            <a:avLst/>
+          </a:prstGeom>
+          <a:noFill/>
+        </p:spPr>
+        <p:txBody>
+          <a:bodyPr wrap="none" rtlCol="0">
+            <a:spAutoFit/>
+          </a:bodyPr>
+          <a:lstStyle/>
+          <a:p>
+            <a:r>
+              <a:rPr lang="en-US" sz="1400" i="1" dirty="0">
+                <a:latin typeface="Arial" panose="020B0604020202020204" pitchFamily="34" charset="0"/>
+                <a:cs typeface="Arial" panose="020B0604020202020204" pitchFamily="34" charset="0"/>
+              </a:rPr>
+              <a:t>Model discrepancy formulation</a:t>
+            </a:r>
+          </a:p>
+        </p:txBody>
+      </p:sp>
+      <p:sp>
+        <p:nvSpPr>
+          <p:cNvPr id="120" name="TextBox 119">
+            <a:extLst>
+              <a:ext uri="{FF2B5EF4-FFF2-40B4-BE49-F238E27FC236}">
+                <a16:creationId xmlns:a16="http://schemas.microsoft.com/office/drawing/2014/main" id="{5541AB3F-6E08-166D-D28D-9E8AAC5C6E14}"/>
+              </a:ext>
+            </a:extLst>
+          </p:cNvPr>
+          <p:cNvSpPr txBox="1"/>
+          <p:nvPr/>
+        </p:nvSpPr>
+        <p:spPr>
+          <a:xfrm>
+            <a:off x="5400994" y="1203306"/>
+            <a:ext cx="3376245" cy="307777"/>
+          </a:xfrm>
+          <a:prstGeom prst="rect">
+            <a:avLst/>
+          </a:prstGeom>
+          <a:noFill/>
+        </p:spPr>
+        <p:txBody>
+          <a:bodyPr wrap="none" rtlCol="0">
+            <a:spAutoFit/>
+          </a:bodyPr>
+          <a:lstStyle/>
+          <a:p>
+            <a:pPr algn="ctr"/>
+            <a:r>
+              <a:rPr lang="en-US" sz="1400" i="1" dirty="0">
+                <a:solidFill>
+                  <a:schemeClr val="accent4"/>
+                </a:solidFill>
+                <a:latin typeface="Arial" panose="020B0604020202020204" pitchFamily="34" charset="0"/>
+                <a:cs typeface="Arial" panose="020B0604020202020204" pitchFamily="34" charset="0"/>
+              </a:rPr>
+              <a:t>Data and surrogate problem information</a:t>
+            </a:r>
+          </a:p>
+        </p:txBody>
+      </p:sp>
+      <p:cxnSp>
+        <p:nvCxnSpPr>
+          <p:cNvPr id="137" name="Straight Arrow Connector 136">
+            <a:extLst>
+              <a:ext uri="{FF2B5EF4-FFF2-40B4-BE49-F238E27FC236}">
+                <a16:creationId xmlns:a16="http://schemas.microsoft.com/office/drawing/2014/main" id="{D1D31EC7-96B1-315B-4E65-11814D004D8F}"/>
+              </a:ext>
+            </a:extLst>
+          </p:cNvPr>
+          <p:cNvCxnSpPr>
+            <a:cxnSpLocks/>
+            <a:stCxn id="18" idx="3"/>
+            <a:endCxn id="20" idx="1"/>
+          </p:cNvCxnSpPr>
+          <p:nvPr/>
+        </p:nvCxnSpPr>
+        <p:spPr>
+          <a:xfrm>
+            <a:off x="3445966" y="4669522"/>
+            <a:ext cx="443516" cy="0"/>
+          </a:xfrm>
+          <a:prstGeom prst="straightConnector1">
+            <a:avLst/>
+          </a:prstGeom>
+          <a:ln w="12700">
+            <a:solidFill>
+              <a:schemeClr val="tx1"/>
+            </a:solidFill>
+            <a:headEnd type="none" w="med" len="med"/>
+            <a:tailEnd type="arrow" w="med" len="med"/>
+          </a:ln>
+        </p:spPr>
+        <p:style>
+          <a:lnRef idx="2">
+            <a:schemeClr val="accent1"/>
+          </a:lnRef>
+          <a:fillRef idx="0">
+            <a:schemeClr val="accent1"/>
+          </a:fillRef>
+          <a:effectRef idx="1">
+            <a:schemeClr val="accent1"/>
+          </a:effectRef>
+          <a:fontRef idx="minor">
+            <a:schemeClr val="tx1"/>
+          </a:fontRef>
+        </p:style>
+      </p:cxnSp>
+      <p:sp>
+        <p:nvSpPr>
+          <p:cNvPr id="155" name="TextBox 154">
+            <a:extLst>
+              <a:ext uri="{FF2B5EF4-FFF2-40B4-BE49-F238E27FC236}">
+                <a16:creationId xmlns:a16="http://schemas.microsoft.com/office/drawing/2014/main" id="{C00E477B-4CCC-ED24-B39A-22327BF745BA}"/>
+              </a:ext>
+            </a:extLst>
+          </p:cNvPr>
+          <p:cNvSpPr txBox="1"/>
+          <p:nvPr/>
+        </p:nvSpPr>
+        <p:spPr>
+          <a:xfrm>
+            <a:off x="6021365" y="5269796"/>
+            <a:ext cx="2135521" cy="307777"/>
+          </a:xfrm>
+          <a:prstGeom prst="rect">
+            <a:avLst/>
+          </a:prstGeom>
+          <a:noFill/>
+        </p:spPr>
+        <p:txBody>
+          <a:bodyPr wrap="none" rtlCol="0">
+            <a:spAutoFit/>
+          </a:bodyPr>
+          <a:lstStyle/>
+          <a:p>
+            <a:pPr algn="ctr"/>
+            <a:r>
+              <a:rPr lang="en-US" sz="1400" i="1" dirty="0">
+                <a:solidFill>
+                  <a:schemeClr val="accent5"/>
+                </a:solidFill>
+                <a:latin typeface="Arial" panose="020B0604020202020204" pitchFamily="34" charset="0"/>
+                <a:cs typeface="Arial" panose="020B0604020202020204" pitchFamily="34" charset="0"/>
+              </a:rPr>
+              <a:t>Sensitivity-based update</a:t>
+            </a:r>
+          </a:p>
+        </p:txBody>
+      </p:sp>
+      <p:pic>
+        <p:nvPicPr>
+          <p:cNvPr id="4" name="Picture 3">
+            <a:extLst>
+              <a:ext uri="{FF2B5EF4-FFF2-40B4-BE49-F238E27FC236}">
+                <a16:creationId xmlns:a16="http://schemas.microsoft.com/office/drawing/2014/main" id="{500BCDE1-EAB5-E23F-69D1-A906BDFEAD97}"/>
+              </a:ext>
+            </a:extLst>
+          </p:cNvPr>
+          <p:cNvPicPr>
+            <a:picLocks noChangeAspect="1"/>
+          </p:cNvPicPr>
+          <p:nvPr/>
+        </p:nvPicPr>
+        <p:blipFill>
+          <a:blip r:embed="rId8"/>
+          <a:stretch>
+            <a:fillRect/>
+          </a:stretch>
+        </p:blipFill>
+        <p:spPr>
+          <a:xfrm>
+            <a:off x="1227188" y="2124481"/>
+            <a:ext cx="1536700" cy="215900"/>
+          </a:xfrm>
+          <a:prstGeom prst="rect">
+            <a:avLst/>
+          </a:prstGeom>
+        </p:spPr>
+      </p:pic>
       <p:grpSp>
         <p:nvGrpSpPr>
-          <p:cNvPr id="40" name="Group 39">
-            <a:extLst>
-              <a:ext uri="{FF2B5EF4-FFF2-40B4-BE49-F238E27FC236}">
-                <a16:creationId xmlns:a16="http://schemas.microsoft.com/office/drawing/2014/main" id="{1377E5DB-4472-FA35-C0CE-912656E37204}"/>
+          <p:cNvPr id="6" name="Group 5">
+            <a:extLst>
+              <a:ext uri="{FF2B5EF4-FFF2-40B4-BE49-F238E27FC236}">
+                <a16:creationId xmlns:a16="http://schemas.microsoft.com/office/drawing/2014/main" id="{1ED93D4A-B5D2-A427-14BE-F6CF8CDE220D}"/>
               </a:ext>
             </a:extLst>
           </p:cNvPr>
@@ -7030,7 +7276,7 @@
           <a:xfrm>
             <a:off x="3889482" y="1663116"/>
             <a:ext cx="2900856" cy="867542"/>
-            <a:chOff x="4645572" y="890750"/>
+            <a:chOff x="3889482" y="1663116"/>
             <a:chExt cx="2900856" cy="867542"/>
           </a:xfrm>
         </p:grpSpPr>
@@ -7048,7 +7294,7 @@
           </p:nvSpPr>
           <p:spPr>
             <a:xfrm>
-              <a:off x="4645572" y="890750"/>
+              <a:off x="3889482" y="1663116"/>
               <a:ext cx="2900856" cy="867542"/>
             </a:xfrm>
             <a:prstGeom prst="roundRect">
@@ -7124,17 +7370,17 @@
                   <a:latin typeface="Arial" panose="020B0604020202020204" pitchFamily="34" charset="0"/>
                   <a:cs typeface="Arial" panose="020B0604020202020204" pitchFamily="34" charset="0"/>
                 </a:rPr>
-                <a:t>Full / surrogate data</a:t>
+                <a:t>Large-scale / surrogate data</a:t>
               </a:r>
             </a:p>
           </p:txBody>
         </p:sp>
         <p:pic>
           <p:nvPicPr>
-            <p:cNvPr id="33" name="Picture 32">
+            <p:cNvPr id="5" name="Picture 4">
               <a:extLst>
                 <a:ext uri="{FF2B5EF4-FFF2-40B4-BE49-F238E27FC236}">
-                  <a16:creationId xmlns:a16="http://schemas.microsoft.com/office/drawing/2014/main" id="{7A27402C-CBCD-0D2A-85CA-9C2963FFDF7E}"/>
+                  <a16:creationId xmlns:a16="http://schemas.microsoft.com/office/drawing/2014/main" id="{5FF794BE-49AD-FA7B-6FE0-731BFA935ECE}"/>
                 </a:ext>
               </a:extLst>
             </p:cNvPr>
@@ -7144,15 +7390,15 @@
             <p:nvPr/>
           </p:nvPicPr>
           <p:blipFill>
-            <a:blip r:embed="rId8"/>
+            <a:blip r:embed="rId9"/>
             <a:stretch>
               <a:fillRect/>
             </a:stretch>
           </p:blipFill>
           <p:spPr>
             <a:xfrm>
-              <a:off x="4972050" y="1372679"/>
-              <a:ext cx="2247900" cy="190500"/>
+              <a:off x="4336610" y="2131849"/>
+              <a:ext cx="2006600" cy="190500"/>
             </a:xfrm>
             <a:prstGeom prst="rect">
               <a:avLst/>
@@ -7160,252 +7406,6 @@
           </p:spPr>
         </p:pic>
       </p:grpSp>
-      <p:cxnSp>
-        <p:nvCxnSpPr>
-          <p:cNvPr id="64" name="Straight Arrow Connector 63">
-            <a:extLst>
-              <a:ext uri="{FF2B5EF4-FFF2-40B4-BE49-F238E27FC236}">
-                <a16:creationId xmlns:a16="http://schemas.microsoft.com/office/drawing/2014/main" id="{40A74146-1B8E-9173-8386-0F1D3FE77AAA}"/>
-              </a:ext>
-            </a:extLst>
-          </p:cNvPr>
-          <p:cNvCxnSpPr>
-            <a:cxnSpLocks/>
-            <a:stCxn id="22" idx="2"/>
-            <a:endCxn id="20" idx="0"/>
-          </p:cNvCxnSpPr>
-          <p:nvPr/>
-        </p:nvCxnSpPr>
-        <p:spPr>
-          <a:xfrm>
-            <a:off x="5339910" y="2530658"/>
-            <a:ext cx="0" cy="1705093"/>
-          </a:xfrm>
-          <a:prstGeom prst="straightConnector1">
-            <a:avLst/>
-          </a:prstGeom>
-          <a:ln w="12700">
-            <a:solidFill>
-              <a:schemeClr val="tx1"/>
-            </a:solidFill>
-            <a:headEnd type="none" w="med" len="med"/>
-            <a:tailEnd type="arrow" w="med" len="med"/>
-          </a:ln>
-        </p:spPr>
-        <p:style>
-          <a:lnRef idx="2">
-            <a:schemeClr val="accent1"/>
-          </a:lnRef>
-          <a:fillRef idx="0">
-            <a:schemeClr val="accent1"/>
-          </a:fillRef>
-          <a:effectRef idx="1">
-            <a:schemeClr val="accent1"/>
-          </a:effectRef>
-          <a:fontRef idx="minor">
-            <a:schemeClr val="tx1"/>
-          </a:fontRef>
-        </p:style>
-      </p:cxnSp>
-      <p:sp>
-        <p:nvSpPr>
-          <p:cNvPr id="119" name="TextBox 118">
-            <a:extLst>
-              <a:ext uri="{FF2B5EF4-FFF2-40B4-BE49-F238E27FC236}">
-                <a16:creationId xmlns:a16="http://schemas.microsoft.com/office/drawing/2014/main" id="{CD0D19A2-B0F3-D181-5AA6-408678A394C3}"/>
-              </a:ext>
-            </a:extLst>
-          </p:cNvPr>
-          <p:cNvSpPr txBox="1"/>
-          <p:nvPr/>
-        </p:nvSpPr>
-        <p:spPr>
-          <a:xfrm>
-            <a:off x="700138" y="1203306"/>
-            <a:ext cx="2596801" cy="307777"/>
-          </a:xfrm>
-          <a:prstGeom prst="rect">
-            <a:avLst/>
-          </a:prstGeom>
-          <a:noFill/>
-        </p:spPr>
-        <p:txBody>
-          <a:bodyPr wrap="none" rtlCol="0">
-            <a:spAutoFit/>
-          </a:bodyPr>
-          <a:lstStyle/>
-          <a:p>
-            <a:r>
-              <a:rPr lang="en-US" sz="1400" i="1" dirty="0">
-                <a:latin typeface="Arial" panose="020B0604020202020204" pitchFamily="34" charset="0"/>
-                <a:cs typeface="Arial" panose="020B0604020202020204" pitchFamily="34" charset="0"/>
-              </a:rPr>
-              <a:t>Model discrepancy formulation</a:t>
-            </a:r>
-          </a:p>
-        </p:txBody>
-      </p:sp>
-      <p:sp>
-        <p:nvSpPr>
-          <p:cNvPr id="120" name="TextBox 119">
-            <a:extLst>
-              <a:ext uri="{FF2B5EF4-FFF2-40B4-BE49-F238E27FC236}">
-                <a16:creationId xmlns:a16="http://schemas.microsoft.com/office/drawing/2014/main" id="{5541AB3F-6E08-166D-D28D-9E8AAC5C6E14}"/>
-              </a:ext>
-            </a:extLst>
-          </p:cNvPr>
-          <p:cNvSpPr txBox="1"/>
-          <p:nvPr/>
-        </p:nvSpPr>
-        <p:spPr>
-          <a:xfrm>
-            <a:off x="5400994" y="1203306"/>
-            <a:ext cx="3376245" cy="307777"/>
-          </a:xfrm>
-          <a:prstGeom prst="rect">
-            <a:avLst/>
-          </a:prstGeom>
-          <a:noFill/>
-        </p:spPr>
-        <p:txBody>
-          <a:bodyPr wrap="none" rtlCol="0">
-            <a:spAutoFit/>
-          </a:bodyPr>
-          <a:lstStyle/>
-          <a:p>
-            <a:pPr algn="ctr"/>
-            <a:r>
-              <a:rPr lang="en-US" sz="1400" i="1" dirty="0">
-                <a:solidFill>
-                  <a:schemeClr val="accent4"/>
-                </a:solidFill>
-                <a:latin typeface="Arial" panose="020B0604020202020204" pitchFamily="34" charset="0"/>
-                <a:cs typeface="Arial" panose="020B0604020202020204" pitchFamily="34" charset="0"/>
-              </a:rPr>
-              <a:t>Data and surrogate problem information</a:t>
-            </a:r>
-          </a:p>
-        </p:txBody>
-      </p:sp>
-      <p:cxnSp>
-        <p:nvCxnSpPr>
-          <p:cNvPr id="137" name="Straight Arrow Connector 136">
-            <a:extLst>
-              <a:ext uri="{FF2B5EF4-FFF2-40B4-BE49-F238E27FC236}">
-                <a16:creationId xmlns:a16="http://schemas.microsoft.com/office/drawing/2014/main" id="{D1D31EC7-96B1-315B-4E65-11814D004D8F}"/>
-              </a:ext>
-            </a:extLst>
-          </p:cNvPr>
-          <p:cNvCxnSpPr>
-            <a:cxnSpLocks/>
-            <a:stCxn id="18" idx="3"/>
-            <a:endCxn id="20" idx="1"/>
-          </p:cNvCxnSpPr>
-          <p:nvPr/>
-        </p:nvCxnSpPr>
-        <p:spPr>
-          <a:xfrm>
-            <a:off x="3445966" y="4669522"/>
-            <a:ext cx="443516" cy="0"/>
-          </a:xfrm>
-          <a:prstGeom prst="straightConnector1">
-            <a:avLst/>
-          </a:prstGeom>
-          <a:ln w="12700">
-            <a:solidFill>
-              <a:schemeClr val="tx1"/>
-            </a:solidFill>
-            <a:headEnd type="none" w="med" len="med"/>
-            <a:tailEnd type="arrow" w="med" len="med"/>
-          </a:ln>
-        </p:spPr>
-        <p:style>
-          <a:lnRef idx="2">
-            <a:schemeClr val="accent1"/>
-          </a:lnRef>
-          <a:fillRef idx="0">
-            <a:schemeClr val="accent1"/>
-          </a:fillRef>
-          <a:effectRef idx="1">
-            <a:schemeClr val="accent1"/>
-          </a:effectRef>
-          <a:fontRef idx="minor">
-            <a:schemeClr val="tx1"/>
-          </a:fontRef>
-        </p:style>
-      </p:cxnSp>
-      <p:sp>
-        <p:nvSpPr>
-          <p:cNvPr id="155" name="TextBox 154">
-            <a:extLst>
-              <a:ext uri="{FF2B5EF4-FFF2-40B4-BE49-F238E27FC236}">
-                <a16:creationId xmlns:a16="http://schemas.microsoft.com/office/drawing/2014/main" id="{C00E477B-4CCC-ED24-B39A-22327BF745BA}"/>
-              </a:ext>
-            </a:extLst>
-          </p:cNvPr>
-          <p:cNvSpPr txBox="1"/>
-          <p:nvPr/>
-        </p:nvSpPr>
-        <p:spPr>
-          <a:xfrm>
-            <a:off x="6021365" y="5269796"/>
-            <a:ext cx="2135521" cy="307777"/>
-          </a:xfrm>
-          <a:prstGeom prst="rect">
-            <a:avLst/>
-          </a:prstGeom>
-          <a:noFill/>
-        </p:spPr>
-        <p:txBody>
-          <a:bodyPr wrap="none" rtlCol="0">
-            <a:spAutoFit/>
-          </a:bodyPr>
-          <a:lstStyle/>
-          <a:p>
-            <a:pPr algn="ctr"/>
-            <a:r>
-              <a:rPr lang="en-US" sz="1400" i="1" dirty="0">
-                <a:solidFill>
-                  <a:schemeClr val="accent5"/>
-                </a:solidFill>
-                <a:latin typeface="Arial" panose="020B0604020202020204" pitchFamily="34" charset="0"/>
-                <a:cs typeface="Arial" panose="020B0604020202020204" pitchFamily="34" charset="0"/>
-              </a:rPr>
-              <a:t>Sensitivity-based update</a:t>
-            </a:r>
-          </a:p>
-        </p:txBody>
-      </p:sp>
-      <p:pic>
-        <p:nvPicPr>
-          <p:cNvPr id="4" name="Picture 3">
-            <a:extLst>
-              <a:ext uri="{FF2B5EF4-FFF2-40B4-BE49-F238E27FC236}">
-                <a16:creationId xmlns:a16="http://schemas.microsoft.com/office/drawing/2014/main" id="{500BCDE1-EAB5-E23F-69D1-A906BDFEAD97}"/>
-              </a:ext>
-            </a:extLst>
-          </p:cNvPr>
-          <p:cNvPicPr>
-            <a:picLocks noChangeAspect="1"/>
-          </p:cNvPicPr>
-          <p:nvPr/>
-        </p:nvPicPr>
-        <p:blipFill>
-          <a:blip r:embed="rId9"/>
-          <a:stretch>
-            <a:fillRect/>
-          </a:stretch>
-        </p:blipFill>
-        <p:spPr>
-          <a:xfrm>
-            <a:off x="1227188" y="2099767"/>
-            <a:ext cx="1536700" cy="215900"/>
-          </a:xfrm>
-          <a:prstGeom prst="rect">
-            <a:avLst/>
-          </a:prstGeom>
-        </p:spPr>
-      </p:pic>
     </p:spTree>
     <p:extLst>
       <p:ext uri="{BB962C8B-B14F-4D97-AF65-F5344CB8AC3E}">

</xml_diff>

<commit_message>
paper: draft for Bart
</commit_message>
<xml_diff>
--- a/paper/figures/HDSA_MD_Overview.pptx
+++ b/paper/figures/HDSA_MD_Overview.pptx
@@ -7,6 +7,8 @@
   <p:sldIdLst>
     <p:sldId id="257" r:id="rId2"/>
     <p:sldId id="258" r:id="rId3"/>
+    <p:sldId id="261" r:id="rId4"/>
+    <p:sldId id="259" r:id="rId5"/>
   </p:sldIdLst>
   <p:sldSz cx="12192000" cy="6858000"/>
   <p:notesSz cx="6858000" cy="9144000"/>
@@ -271,7 +273,7 @@
           <a:p>
             <a:fld id="{547A4ACA-080D-2846-BC7A-301AD37AA2EA}" type="datetimeFigureOut">
               <a:rPr lang="en-US" smtClean="0"/>
-              <a:t>5/6/25</a:t>
+              <a:t>6/16/25</a:t>
             </a:fld>
             <a:endParaRPr lang="en-US"/>
           </a:p>
@@ -469,7 +471,7 @@
           <a:p>
             <a:fld id="{547A4ACA-080D-2846-BC7A-301AD37AA2EA}" type="datetimeFigureOut">
               <a:rPr lang="en-US" smtClean="0"/>
-              <a:t>5/6/25</a:t>
+              <a:t>6/16/25</a:t>
             </a:fld>
             <a:endParaRPr lang="en-US"/>
           </a:p>
@@ -677,7 +679,7 @@
           <a:p>
             <a:fld id="{547A4ACA-080D-2846-BC7A-301AD37AA2EA}" type="datetimeFigureOut">
               <a:rPr lang="en-US" smtClean="0"/>
-              <a:t>5/6/25</a:t>
+              <a:t>6/16/25</a:t>
             </a:fld>
             <a:endParaRPr lang="en-US"/>
           </a:p>
@@ -875,7 +877,7 @@
           <a:p>
             <a:fld id="{547A4ACA-080D-2846-BC7A-301AD37AA2EA}" type="datetimeFigureOut">
               <a:rPr lang="en-US" smtClean="0"/>
-              <a:t>5/6/25</a:t>
+              <a:t>6/16/25</a:t>
             </a:fld>
             <a:endParaRPr lang="en-US"/>
           </a:p>
@@ -1150,7 +1152,7 @@
           <a:p>
             <a:fld id="{547A4ACA-080D-2846-BC7A-301AD37AA2EA}" type="datetimeFigureOut">
               <a:rPr lang="en-US" smtClean="0"/>
-              <a:t>5/6/25</a:t>
+              <a:t>6/16/25</a:t>
             </a:fld>
             <a:endParaRPr lang="en-US"/>
           </a:p>
@@ -1415,7 +1417,7 @@
           <a:p>
             <a:fld id="{547A4ACA-080D-2846-BC7A-301AD37AA2EA}" type="datetimeFigureOut">
               <a:rPr lang="en-US" smtClean="0"/>
-              <a:t>5/6/25</a:t>
+              <a:t>6/16/25</a:t>
             </a:fld>
             <a:endParaRPr lang="en-US"/>
           </a:p>
@@ -1827,7 +1829,7 @@
           <a:p>
             <a:fld id="{547A4ACA-080D-2846-BC7A-301AD37AA2EA}" type="datetimeFigureOut">
               <a:rPr lang="en-US" smtClean="0"/>
-              <a:t>5/6/25</a:t>
+              <a:t>6/16/25</a:t>
             </a:fld>
             <a:endParaRPr lang="en-US"/>
           </a:p>
@@ -1968,7 +1970,7 @@
           <a:p>
             <a:fld id="{547A4ACA-080D-2846-BC7A-301AD37AA2EA}" type="datetimeFigureOut">
               <a:rPr lang="en-US" smtClean="0"/>
-              <a:t>5/6/25</a:t>
+              <a:t>6/16/25</a:t>
             </a:fld>
             <a:endParaRPr lang="en-US"/>
           </a:p>
@@ -2081,7 +2083,7 @@
           <a:p>
             <a:fld id="{547A4ACA-080D-2846-BC7A-301AD37AA2EA}" type="datetimeFigureOut">
               <a:rPr lang="en-US" smtClean="0"/>
-              <a:t>5/6/25</a:t>
+              <a:t>6/16/25</a:t>
             </a:fld>
             <a:endParaRPr lang="en-US"/>
           </a:p>
@@ -2392,7 +2394,7 @@
           <a:p>
             <a:fld id="{547A4ACA-080D-2846-BC7A-301AD37AA2EA}" type="datetimeFigureOut">
               <a:rPr lang="en-US" smtClean="0"/>
-              <a:t>5/6/25</a:t>
+              <a:t>6/16/25</a:t>
             </a:fld>
             <a:endParaRPr lang="en-US"/>
           </a:p>
@@ -2680,7 +2682,7 @@
           <a:p>
             <a:fld id="{547A4ACA-080D-2846-BC7A-301AD37AA2EA}" type="datetimeFigureOut">
               <a:rPr lang="en-US" smtClean="0"/>
-              <a:t>5/6/25</a:t>
+              <a:t>6/16/25</a:t>
             </a:fld>
             <a:endParaRPr lang="en-US"/>
           </a:p>
@@ -2921,7 +2923,7 @@
           <a:p>
             <a:fld id="{547A4ACA-080D-2846-BC7A-301AD37AA2EA}" type="datetimeFigureOut">
               <a:rPr lang="en-US" smtClean="0"/>
-              <a:t>5/6/25</a:t>
+              <a:t>6/16/25</a:t>
             </a:fld>
             <a:endParaRPr lang="en-US"/>
           </a:p>
@@ -5748,7 +5750,7 @@
 </file>
 
 <file path=ppt/slides/slide2.xml><?xml version="1.0" encoding="utf-8"?>
-<p:sld xmlns:a="http://schemas.openxmlformats.org/drawingml/2006/main" xmlns:r="http://schemas.openxmlformats.org/officeDocument/2006/relationships" xmlns:p="http://schemas.openxmlformats.org/presentationml/2006/main">
+<p:sld xmlns:a="http://schemas.openxmlformats.org/drawingml/2006/main" xmlns:r="http://schemas.openxmlformats.org/officeDocument/2006/relationships" xmlns:p="http://schemas.openxmlformats.org/presentationml/2006/main" show="0">
   <p:cSld>
     <p:spTree>
       <p:nvGrpSpPr>
@@ -5993,7 +5995,6 @@
           </p:cNvPr>
           <p:cNvCxnSpPr>
             <a:cxnSpLocks/>
-            <a:stCxn id="23" idx="2"/>
             <a:endCxn id="25" idx="0"/>
           </p:cNvCxnSpPr>
           <p:nvPr/>
@@ -6043,7 +6044,7 @@
         </p:nvGrpSpPr>
         <p:grpSpPr>
           <a:xfrm>
-            <a:off x="545110" y="2958004"/>
+            <a:off x="545110" y="2940399"/>
             <a:ext cx="2900856" cy="867542"/>
             <a:chOff x="777764" y="2661745"/>
             <a:chExt cx="2900856" cy="867542"/>
@@ -6545,120 +6546,6 @@
       </p:grpSp>
       <p:grpSp>
         <p:nvGrpSpPr>
-          <p:cNvPr id="45" name="Group 44">
-            <a:extLst>
-              <a:ext uri="{FF2B5EF4-FFF2-40B4-BE49-F238E27FC236}">
-                <a16:creationId xmlns:a16="http://schemas.microsoft.com/office/drawing/2014/main" id="{C3D69103-0DA7-F484-2D50-B608A2490871}"/>
-              </a:ext>
-            </a:extLst>
-          </p:cNvPr>
-          <p:cNvGrpSpPr/>
-          <p:nvPr/>
-        </p:nvGrpSpPr>
-        <p:grpSpPr>
-          <a:xfrm>
-            <a:off x="7233854" y="1663116"/>
-            <a:ext cx="2900856" cy="867542"/>
-            <a:chOff x="8513380" y="890750"/>
-            <a:chExt cx="2900856" cy="867542"/>
-          </a:xfrm>
-        </p:grpSpPr>
-        <p:sp>
-          <p:nvSpPr>
-            <p:cNvPr id="23" name="Rounded Rectangle 22">
-              <a:extLst>
-                <a:ext uri="{FF2B5EF4-FFF2-40B4-BE49-F238E27FC236}">
-                  <a16:creationId xmlns:a16="http://schemas.microsoft.com/office/drawing/2014/main" id="{2ADD15CE-E3B1-810E-F66E-AD7133BEEACF}"/>
-                </a:ext>
-              </a:extLst>
-            </p:cNvPr>
-            <p:cNvSpPr/>
-            <p:nvPr/>
-          </p:nvSpPr>
-          <p:spPr>
-            <a:xfrm>
-              <a:off x="8513380" y="890750"/>
-              <a:ext cx="2900856" cy="867542"/>
-            </a:xfrm>
-            <a:prstGeom prst="roundRect">
-              <a:avLst/>
-            </a:prstGeom>
-            <a:solidFill>
-              <a:schemeClr val="bg1"/>
-            </a:solidFill>
-            <a:ln w="12700">
-              <a:solidFill>
-                <a:schemeClr val="tx1"/>
-              </a:solidFill>
-            </a:ln>
-          </p:spPr>
-          <p:style>
-            <a:lnRef idx="2">
-              <a:schemeClr val="accent1">
-                <a:shade val="15000"/>
-              </a:schemeClr>
-            </a:lnRef>
-            <a:fillRef idx="1">
-              <a:schemeClr val="accent1"/>
-            </a:fillRef>
-            <a:effectRef idx="0">
-              <a:schemeClr val="accent1"/>
-            </a:effectRef>
-            <a:fontRef idx="minor">
-              <a:schemeClr val="lt1"/>
-            </a:fontRef>
-          </p:style>
-          <p:txBody>
-            <a:bodyPr rtlCol="0" anchor="t"/>
-            <a:lstStyle/>
-            <a:p>
-              <a:pPr algn="ctr"/>
-              <a:r>
-                <a:rPr lang="en-US" sz="1400" dirty="0">
-                  <a:solidFill>
-                    <a:schemeClr val="tx1"/>
-                  </a:solidFill>
-                  <a:latin typeface="Arial" panose="020B0604020202020204" pitchFamily="34" charset="0"/>
-                  <a:cs typeface="Arial" panose="020B0604020202020204" pitchFamily="34" charset="0"/>
-                </a:rPr>
-                <a:t>Solution to surrogate-constrained optimization problem</a:t>
-              </a:r>
-            </a:p>
-          </p:txBody>
-        </p:sp>
-        <p:pic>
-          <p:nvPicPr>
-            <p:cNvPr id="34" name="Picture 33">
-              <a:extLst>
-                <a:ext uri="{FF2B5EF4-FFF2-40B4-BE49-F238E27FC236}">
-                  <a16:creationId xmlns:a16="http://schemas.microsoft.com/office/drawing/2014/main" id="{5BD23DA7-4C3B-D3F2-B1C3-CCCA7451A483}"/>
-                </a:ext>
-              </a:extLst>
-            </p:cNvPr>
-            <p:cNvPicPr>
-              <a:picLocks noChangeAspect="1"/>
-            </p:cNvPicPr>
-            <p:nvPr/>
-          </p:nvPicPr>
-          <p:blipFill>
-            <a:blip r:embed="rId5"/>
-            <a:stretch>
-              <a:fillRect/>
-            </a:stretch>
-          </p:blipFill>
-          <p:spPr>
-            <a:xfrm>
-              <a:off x="9722508" y="1480199"/>
-              <a:ext cx="482600" cy="190500"/>
-            </a:xfrm>
-            <a:prstGeom prst="rect">
-              <a:avLst/>
-            </a:prstGeom>
-          </p:spPr>
-        </p:pic>
-      </p:grpSp>
-      <p:grpSp>
-        <p:nvGrpSpPr>
           <p:cNvPr id="60" name="Group 59">
             <a:extLst>
               <a:ext uri="{FF2B5EF4-FFF2-40B4-BE49-F238E27FC236}">
@@ -6784,7 +6671,7 @@
                   <a:latin typeface="Arial" panose="020B0604020202020204" pitchFamily="34" charset="0"/>
                   <a:cs typeface="Arial" panose="020B0604020202020204" pitchFamily="34" charset="0"/>
                 </a:rPr>
-                <a:t>Optimization solution update</a:t>
+                <a:t>Post-optimality sensitivity update</a:t>
               </a:r>
             </a:p>
           </p:txBody>
@@ -6804,7 +6691,7 @@
             <p:nvPr/>
           </p:nvPicPr>
           <p:blipFill>
-            <a:blip r:embed="rId6"/>
+            <a:blip r:embed="rId5"/>
             <a:stretch>
               <a:fillRect/>
             </a:stretch>
@@ -6818,152 +6705,6 @@
               <a:avLst/>
             </a:prstGeom>
             <a:grpFill/>
-          </p:spPr>
-        </p:pic>
-      </p:grpSp>
-      <p:grpSp>
-        <p:nvGrpSpPr>
-          <p:cNvPr id="46" name="Group 45">
-            <a:extLst>
-              <a:ext uri="{FF2B5EF4-FFF2-40B4-BE49-F238E27FC236}">
-                <a16:creationId xmlns:a16="http://schemas.microsoft.com/office/drawing/2014/main" id="{0F8798DD-758A-C61F-A28F-6ED4F738C99B}"/>
-              </a:ext>
-            </a:extLst>
-          </p:cNvPr>
-          <p:cNvGrpSpPr/>
-          <p:nvPr/>
-        </p:nvGrpSpPr>
-        <p:grpSpPr>
-          <a:xfrm>
-            <a:off x="7233854" y="2943116"/>
-            <a:ext cx="2900856" cy="867542"/>
-            <a:chOff x="8513380" y="4248531"/>
-            <a:chExt cx="2900856" cy="867542"/>
-          </a:xfrm>
-        </p:grpSpPr>
-        <p:sp>
-          <p:nvSpPr>
-            <p:cNvPr id="26" name="Rounded Rectangle 25">
-              <a:extLst>
-                <a:ext uri="{FF2B5EF4-FFF2-40B4-BE49-F238E27FC236}">
-                  <a16:creationId xmlns:a16="http://schemas.microsoft.com/office/drawing/2014/main" id="{1677ED4E-61DD-D31D-890A-79859C156F1F}"/>
-                </a:ext>
-              </a:extLst>
-            </p:cNvPr>
-            <p:cNvSpPr/>
-            <p:nvPr/>
-          </p:nvSpPr>
-          <p:spPr>
-            <a:xfrm>
-              <a:off x="8513380" y="4248531"/>
-              <a:ext cx="2900856" cy="867542"/>
-            </a:xfrm>
-            <a:prstGeom prst="roundRect">
-              <a:avLst/>
-            </a:prstGeom>
-            <a:solidFill>
-              <a:schemeClr val="bg1"/>
-            </a:solidFill>
-            <a:ln w="12700">
-              <a:solidFill>
-                <a:schemeClr val="tx1"/>
-              </a:solidFill>
-            </a:ln>
-          </p:spPr>
-          <p:style>
-            <a:lnRef idx="2">
-              <a:schemeClr val="accent1">
-                <a:shade val="15000"/>
-              </a:schemeClr>
-            </a:lnRef>
-            <a:fillRef idx="1">
-              <a:schemeClr val="accent1"/>
-            </a:fillRef>
-            <a:effectRef idx="0">
-              <a:schemeClr val="accent1"/>
-            </a:effectRef>
-            <a:fontRef idx="minor">
-              <a:schemeClr val="lt1"/>
-            </a:fontRef>
-          </p:style>
-          <p:txBody>
-            <a:bodyPr rtlCol="0" anchor="t"/>
-            <a:lstStyle/>
-            <a:p>
-              <a:pPr algn="ctr">
-                <a:lnSpc>
-                  <a:spcPts val="600"/>
-                </a:lnSpc>
-              </a:pPr>
-              <a:endParaRPr lang="en-US" sz="1400" dirty="0">
-                <a:solidFill>
-                  <a:schemeClr val="tx1"/>
-                </a:solidFill>
-                <a:latin typeface="Arial" panose="020B0604020202020204" pitchFamily="34" charset="0"/>
-                <a:cs typeface="Arial" panose="020B0604020202020204" pitchFamily="34" charset="0"/>
-              </a:endParaRPr>
-            </a:p>
-            <a:p>
-              <a:pPr algn="ctr">
-                <a:lnSpc>
-                  <a:spcPts val="600"/>
-                </a:lnSpc>
-              </a:pPr>
-              <a:endParaRPr lang="en-US" sz="1400" dirty="0">
-                <a:solidFill>
-                  <a:schemeClr val="tx1"/>
-                </a:solidFill>
-                <a:latin typeface="Arial" panose="020B0604020202020204" pitchFamily="34" charset="0"/>
-                <a:cs typeface="Arial" panose="020B0604020202020204" pitchFamily="34" charset="0"/>
-              </a:endParaRPr>
-            </a:p>
-            <a:p>
-              <a:pPr algn="ctr">
-                <a:lnSpc>
-                  <a:spcPts val="600"/>
-                </a:lnSpc>
-              </a:pPr>
-              <a:r>
-                <a:rPr lang="en-US" sz="1400" dirty="0">
-                  <a:solidFill>
-                    <a:schemeClr val="tx1"/>
-                  </a:solidFill>
-                  <a:latin typeface="Arial" panose="020B0604020202020204" pitchFamily="34" charset="0"/>
-                  <a:cs typeface="Arial" panose="020B0604020202020204" pitchFamily="34" charset="0"/>
-                </a:rPr>
-                <a:t>Surrogate problem derivatives</a:t>
-              </a:r>
-            </a:p>
-          </p:txBody>
-        </p:sp>
-        <p:pic>
-          <p:nvPicPr>
-            <p:cNvPr id="39" name="Picture 38">
-              <a:extLst>
-                <a:ext uri="{FF2B5EF4-FFF2-40B4-BE49-F238E27FC236}">
-                  <a16:creationId xmlns:a16="http://schemas.microsoft.com/office/drawing/2014/main" id="{F26D9879-1623-2E51-68AC-916A97E3E0EB}"/>
-                </a:ext>
-              </a:extLst>
-            </p:cNvPr>
-            <p:cNvPicPr>
-              <a:picLocks noChangeAspect="1"/>
-            </p:cNvPicPr>
-            <p:nvPr/>
-          </p:nvPicPr>
-          <p:blipFill>
-            <a:blip r:embed="rId7"/>
-            <a:stretch>
-              <a:fillRect/>
-            </a:stretch>
-          </p:blipFill>
-          <p:spPr>
-            <a:xfrm>
-              <a:off x="8681108" y="4686466"/>
-              <a:ext cx="2565400" cy="215900"/>
-            </a:xfrm>
-            <a:prstGeom prst="rect">
-              <a:avLst/>
-            </a:prstGeom>
           </p:spPr>
         </p:pic>
       </p:grpSp>
@@ -7245,7 +6986,7 @@
           <p:nvPr/>
         </p:nvPicPr>
         <p:blipFill>
-          <a:blip r:embed="rId8"/>
+          <a:blip r:embed="rId6"/>
           <a:stretch>
             <a:fillRect/>
           </a:stretch>
@@ -7390,6 +7131,3361 @@
             <p:nvPr/>
           </p:nvPicPr>
           <p:blipFill>
+            <a:blip r:embed="rId7"/>
+            <a:stretch>
+              <a:fillRect/>
+            </a:stretch>
+          </p:blipFill>
+          <p:spPr>
+            <a:xfrm>
+              <a:off x="4336610" y="2131849"/>
+              <a:ext cx="2006600" cy="190500"/>
+            </a:xfrm>
+            <a:prstGeom prst="rect">
+              <a:avLst/>
+            </a:prstGeom>
+          </p:spPr>
+        </p:pic>
+      </p:grpSp>
+      <p:grpSp>
+        <p:nvGrpSpPr>
+          <p:cNvPr id="12" name="Group 11">
+            <a:extLst>
+              <a:ext uri="{FF2B5EF4-FFF2-40B4-BE49-F238E27FC236}">
+                <a16:creationId xmlns:a16="http://schemas.microsoft.com/office/drawing/2014/main" id="{06A0FBC6-A435-9305-66BD-B7A11116284B}"/>
+              </a:ext>
+            </a:extLst>
+          </p:cNvPr>
+          <p:cNvGrpSpPr/>
+          <p:nvPr/>
+        </p:nvGrpSpPr>
+        <p:grpSpPr>
+          <a:xfrm>
+            <a:off x="7233854" y="1663116"/>
+            <a:ext cx="2900856" cy="867542"/>
+            <a:chOff x="8513380" y="4248531"/>
+            <a:chExt cx="2900856" cy="867542"/>
+          </a:xfrm>
+        </p:grpSpPr>
+        <p:sp>
+          <p:nvSpPr>
+            <p:cNvPr id="13" name="Rounded Rectangle 12">
+              <a:extLst>
+                <a:ext uri="{FF2B5EF4-FFF2-40B4-BE49-F238E27FC236}">
+                  <a16:creationId xmlns:a16="http://schemas.microsoft.com/office/drawing/2014/main" id="{5BAA6298-6068-C52A-98FF-73A37A1E0551}"/>
+                </a:ext>
+              </a:extLst>
+            </p:cNvPr>
+            <p:cNvSpPr/>
+            <p:nvPr/>
+          </p:nvSpPr>
+          <p:spPr>
+            <a:xfrm>
+              <a:off x="8513380" y="4248531"/>
+              <a:ext cx="2900856" cy="867542"/>
+            </a:xfrm>
+            <a:prstGeom prst="roundRect">
+              <a:avLst/>
+            </a:prstGeom>
+            <a:solidFill>
+              <a:schemeClr val="bg1"/>
+            </a:solidFill>
+            <a:ln w="12700">
+              <a:solidFill>
+                <a:schemeClr val="tx1"/>
+              </a:solidFill>
+            </a:ln>
+          </p:spPr>
+          <p:style>
+            <a:lnRef idx="2">
+              <a:schemeClr val="accent1">
+                <a:shade val="15000"/>
+              </a:schemeClr>
+            </a:lnRef>
+            <a:fillRef idx="1">
+              <a:schemeClr val="accent1"/>
+            </a:fillRef>
+            <a:effectRef idx="0">
+              <a:schemeClr val="accent1"/>
+            </a:effectRef>
+            <a:fontRef idx="minor">
+              <a:schemeClr val="lt1"/>
+            </a:fontRef>
+          </p:style>
+          <p:txBody>
+            <a:bodyPr rtlCol="0" anchor="t"/>
+            <a:lstStyle/>
+            <a:p>
+              <a:pPr algn="ctr">
+                <a:lnSpc>
+                  <a:spcPts val="600"/>
+                </a:lnSpc>
+              </a:pPr>
+              <a:endParaRPr lang="en-US" sz="1400" dirty="0">
+                <a:solidFill>
+                  <a:schemeClr val="tx1"/>
+                </a:solidFill>
+                <a:latin typeface="Arial" panose="020B0604020202020204" pitchFamily="34" charset="0"/>
+                <a:cs typeface="Arial" panose="020B0604020202020204" pitchFamily="34" charset="0"/>
+              </a:endParaRPr>
+            </a:p>
+            <a:p>
+              <a:pPr algn="ctr">
+                <a:lnSpc>
+                  <a:spcPts val="600"/>
+                </a:lnSpc>
+              </a:pPr>
+              <a:endParaRPr lang="en-US" sz="1400" dirty="0">
+                <a:solidFill>
+                  <a:schemeClr val="tx1"/>
+                </a:solidFill>
+                <a:latin typeface="Arial" panose="020B0604020202020204" pitchFamily="34" charset="0"/>
+                <a:cs typeface="Arial" panose="020B0604020202020204" pitchFamily="34" charset="0"/>
+              </a:endParaRPr>
+            </a:p>
+            <a:p>
+              <a:pPr algn="ctr">
+                <a:lnSpc>
+                  <a:spcPts val="600"/>
+                </a:lnSpc>
+              </a:pPr>
+              <a:r>
+                <a:rPr lang="en-US" sz="1400" dirty="0">
+                  <a:solidFill>
+                    <a:schemeClr val="tx1"/>
+                  </a:solidFill>
+                  <a:latin typeface="Arial" panose="020B0604020202020204" pitchFamily="34" charset="0"/>
+                  <a:cs typeface="Arial" panose="020B0604020202020204" pitchFamily="34" charset="0"/>
+                </a:rPr>
+                <a:t>Surrogate problem derivatives</a:t>
+              </a:r>
+            </a:p>
+          </p:txBody>
+        </p:sp>
+        <p:pic>
+          <p:nvPicPr>
+            <p:cNvPr id="14" name="Picture 13">
+              <a:extLst>
+                <a:ext uri="{FF2B5EF4-FFF2-40B4-BE49-F238E27FC236}">
+                  <a16:creationId xmlns:a16="http://schemas.microsoft.com/office/drawing/2014/main" id="{FE8114ED-7B8E-5F9C-5E71-50C3673D9DF1}"/>
+                </a:ext>
+              </a:extLst>
+            </p:cNvPr>
+            <p:cNvPicPr>
+              <a:picLocks noChangeAspect="1"/>
+            </p:cNvPicPr>
+            <p:nvPr/>
+          </p:nvPicPr>
+          <p:blipFill>
+            <a:blip r:embed="rId8"/>
+            <a:stretch>
+              <a:fillRect/>
+            </a:stretch>
+          </p:blipFill>
+          <p:spPr>
+            <a:xfrm>
+              <a:off x="8681108" y="4686466"/>
+              <a:ext cx="2565400" cy="215900"/>
+            </a:xfrm>
+            <a:prstGeom prst="rect">
+              <a:avLst/>
+            </a:prstGeom>
+          </p:spPr>
+        </p:pic>
+      </p:grpSp>
+      <p:grpSp>
+        <p:nvGrpSpPr>
+          <p:cNvPr id="28" name="Group 27">
+            <a:extLst>
+              <a:ext uri="{FF2B5EF4-FFF2-40B4-BE49-F238E27FC236}">
+                <a16:creationId xmlns:a16="http://schemas.microsoft.com/office/drawing/2014/main" id="{1B56C27C-31ED-FCE8-37C1-9294CC70CA84}"/>
+              </a:ext>
+            </a:extLst>
+          </p:cNvPr>
+          <p:cNvGrpSpPr/>
+          <p:nvPr/>
+        </p:nvGrpSpPr>
+        <p:grpSpPr>
+          <a:xfrm>
+            <a:off x="7233854" y="2940399"/>
+            <a:ext cx="2900856" cy="867542"/>
+            <a:chOff x="7233854" y="2940399"/>
+            <a:chExt cx="2900856" cy="867542"/>
+          </a:xfrm>
+        </p:grpSpPr>
+        <p:sp>
+          <p:nvSpPr>
+            <p:cNvPr id="17" name="Rounded Rectangle 16">
+              <a:extLst>
+                <a:ext uri="{FF2B5EF4-FFF2-40B4-BE49-F238E27FC236}">
+                  <a16:creationId xmlns:a16="http://schemas.microsoft.com/office/drawing/2014/main" id="{F6101FED-1F07-977A-C671-E93348DFCAA7}"/>
+                </a:ext>
+              </a:extLst>
+            </p:cNvPr>
+            <p:cNvSpPr/>
+            <p:nvPr/>
+          </p:nvSpPr>
+          <p:spPr>
+            <a:xfrm>
+              <a:off x="7233854" y="2940399"/>
+              <a:ext cx="2900856" cy="867542"/>
+            </a:xfrm>
+            <a:prstGeom prst="roundRect">
+              <a:avLst/>
+            </a:prstGeom>
+            <a:solidFill>
+              <a:schemeClr val="bg1"/>
+            </a:solidFill>
+            <a:ln w="12700">
+              <a:solidFill>
+                <a:schemeClr val="tx1"/>
+              </a:solidFill>
+            </a:ln>
+          </p:spPr>
+          <p:style>
+            <a:lnRef idx="2">
+              <a:schemeClr val="accent1">
+                <a:shade val="15000"/>
+              </a:schemeClr>
+            </a:lnRef>
+            <a:fillRef idx="1">
+              <a:schemeClr val="accent1"/>
+            </a:fillRef>
+            <a:effectRef idx="0">
+              <a:schemeClr val="accent1"/>
+            </a:effectRef>
+            <a:fontRef idx="minor">
+              <a:schemeClr val="lt1"/>
+            </a:fontRef>
+          </p:style>
+          <p:txBody>
+            <a:bodyPr rtlCol="0" anchor="t"/>
+            <a:lstStyle/>
+            <a:p>
+              <a:pPr algn="ctr"/>
+              <a:r>
+                <a:rPr lang="en-US" sz="1400" dirty="0">
+                  <a:solidFill>
+                    <a:schemeClr val="tx1"/>
+                  </a:solidFill>
+                  <a:latin typeface="Arial" panose="020B0604020202020204" pitchFamily="34" charset="0"/>
+                  <a:cs typeface="Arial" panose="020B0604020202020204" pitchFamily="34" charset="0"/>
+                </a:rPr>
+                <a:t>Solution to surrogate-constrained optimization problem</a:t>
+              </a:r>
+            </a:p>
+          </p:txBody>
+        </p:sp>
+        <p:pic>
+          <p:nvPicPr>
+            <p:cNvPr id="27" name="Picture 26">
+              <a:extLst>
+                <a:ext uri="{FF2B5EF4-FFF2-40B4-BE49-F238E27FC236}">
+                  <a16:creationId xmlns:a16="http://schemas.microsoft.com/office/drawing/2014/main" id="{1E531D5D-B1E3-9F35-E916-761F7952DCD4}"/>
+                </a:ext>
+              </a:extLst>
+            </p:cNvPr>
+            <p:cNvPicPr>
+              <a:picLocks noChangeAspect="1"/>
+            </p:cNvPicPr>
+            <p:nvPr/>
+          </p:nvPicPr>
+          <p:blipFill>
+            <a:blip r:embed="rId9"/>
+            <a:stretch>
+              <a:fillRect/>
+            </a:stretch>
+          </p:blipFill>
+          <p:spPr>
+            <a:xfrm>
+              <a:off x="7839732" y="3527455"/>
+              <a:ext cx="1689100" cy="190500"/>
+            </a:xfrm>
+            <a:prstGeom prst="rect">
+              <a:avLst/>
+            </a:prstGeom>
+          </p:spPr>
+        </p:pic>
+      </p:grpSp>
+    </p:spTree>
+    <p:extLst>
+      <p:ext uri="{BB962C8B-B14F-4D97-AF65-F5344CB8AC3E}">
+        <p14:creationId xmlns:p14="http://schemas.microsoft.com/office/powerpoint/2010/main" val="3600111524"/>
+      </p:ext>
+    </p:extLst>
+  </p:cSld>
+  <p:clrMapOvr>
+    <a:masterClrMapping/>
+  </p:clrMapOvr>
+</p:sld>
+</file>
+
+<file path=ppt/slides/slide3.xml><?xml version="1.0" encoding="utf-8"?>
+<p:sld xmlns:a="http://schemas.openxmlformats.org/drawingml/2006/main" xmlns:r="http://schemas.openxmlformats.org/officeDocument/2006/relationships" xmlns:p="http://schemas.openxmlformats.org/presentationml/2006/main">
+  <p:cSld>
+    <p:spTree>
+      <p:nvGrpSpPr>
+        <p:cNvPr id="1" name="">
+          <a:extLst>
+            <a:ext uri="{FF2B5EF4-FFF2-40B4-BE49-F238E27FC236}">
+              <a16:creationId xmlns:a16="http://schemas.microsoft.com/office/drawing/2014/main" id="{BB69076B-B4F9-0FCA-093C-64003F0BEDE5}"/>
+            </a:ext>
+          </a:extLst>
+        </p:cNvPr>
+        <p:cNvGrpSpPr/>
+        <p:nvPr/>
+      </p:nvGrpSpPr>
+      <p:grpSpPr>
+        <a:xfrm>
+          <a:off x="0" y="0"/>
+          <a:ext cx="0" cy="0"/>
+          <a:chOff x="0" y="0"/>
+          <a:chExt cx="0" cy="0"/>
+        </a:xfrm>
+      </p:grpSpPr>
+      <p:sp>
+        <p:nvSpPr>
+          <p:cNvPr id="148" name="Rectangle 147">
+            <a:extLst>
+              <a:ext uri="{FF2B5EF4-FFF2-40B4-BE49-F238E27FC236}">
+                <a16:creationId xmlns:a16="http://schemas.microsoft.com/office/drawing/2014/main" id="{50127C5D-927F-8BFC-12F1-C16E1ED22772}"/>
+              </a:ext>
+            </a:extLst>
+          </p:cNvPr>
+          <p:cNvSpPr/>
+          <p:nvPr/>
+        </p:nvSpPr>
+        <p:spPr>
+          <a:xfrm>
+            <a:off x="3699641" y="4096297"/>
+            <a:ext cx="6643239" cy="1174205"/>
+          </a:xfrm>
+          <a:prstGeom prst="rect">
+            <a:avLst/>
+          </a:prstGeom>
+          <a:solidFill>
+            <a:schemeClr val="accent5">
+              <a:alpha val="10196"/>
+            </a:schemeClr>
+          </a:solidFill>
+          <a:ln w="12700">
+            <a:noFill/>
+            <a:prstDash val="lgDashDot"/>
+          </a:ln>
+        </p:spPr>
+        <p:style>
+          <a:lnRef idx="2">
+            <a:schemeClr val="accent1">
+              <a:shade val="15000"/>
+            </a:schemeClr>
+          </a:lnRef>
+          <a:fillRef idx="1">
+            <a:schemeClr val="accent1"/>
+          </a:fillRef>
+          <a:effectRef idx="0">
+            <a:schemeClr val="accent1"/>
+          </a:effectRef>
+          <a:fontRef idx="minor">
+            <a:schemeClr val="lt1"/>
+          </a:fontRef>
+        </p:style>
+        <p:txBody>
+          <a:bodyPr rtlCol="0" anchor="ctr"/>
+          <a:lstStyle/>
+          <a:p>
+            <a:pPr algn="ctr"/>
+            <a:endParaRPr lang="en-US"/>
+          </a:p>
+        </p:txBody>
+      </p:sp>
+      <p:sp>
+        <p:nvSpPr>
+          <p:cNvPr id="136" name="Rectangle 135">
+            <a:extLst>
+              <a:ext uri="{FF2B5EF4-FFF2-40B4-BE49-F238E27FC236}">
+                <a16:creationId xmlns:a16="http://schemas.microsoft.com/office/drawing/2014/main" id="{7B6506C6-9944-CB2C-BD49-636505106304}"/>
+              </a:ext>
+            </a:extLst>
+          </p:cNvPr>
+          <p:cNvSpPr/>
+          <p:nvPr/>
+        </p:nvSpPr>
+        <p:spPr>
+          <a:xfrm>
+            <a:off x="3699641" y="2742984"/>
+            <a:ext cx="6643239" cy="1282477"/>
+          </a:xfrm>
+          <a:prstGeom prst="rect">
+            <a:avLst/>
+          </a:prstGeom>
+          <a:solidFill>
+            <a:srgbClr val="0F9ED5">
+              <a:alpha val="10196"/>
+            </a:srgbClr>
+          </a:solidFill>
+          <a:ln w="12700">
+            <a:noFill/>
+            <a:prstDash val="lgDashDot"/>
+          </a:ln>
+        </p:spPr>
+        <p:style>
+          <a:lnRef idx="2">
+            <a:schemeClr val="accent1">
+              <a:shade val="15000"/>
+            </a:schemeClr>
+          </a:lnRef>
+          <a:fillRef idx="1">
+            <a:schemeClr val="accent1"/>
+          </a:fillRef>
+          <a:effectRef idx="0">
+            <a:schemeClr val="accent1"/>
+          </a:effectRef>
+          <a:fontRef idx="minor">
+            <a:schemeClr val="lt1"/>
+          </a:fontRef>
+        </p:style>
+        <p:txBody>
+          <a:bodyPr rtlCol="0" anchor="ctr"/>
+          <a:lstStyle/>
+          <a:p>
+            <a:pPr algn="ctr"/>
+            <a:endParaRPr lang="en-US"/>
+          </a:p>
+        </p:txBody>
+      </p:sp>
+      <p:sp>
+        <p:nvSpPr>
+          <p:cNvPr id="49" name="Rectangle 48">
+            <a:extLst>
+              <a:ext uri="{FF2B5EF4-FFF2-40B4-BE49-F238E27FC236}">
+                <a16:creationId xmlns:a16="http://schemas.microsoft.com/office/drawing/2014/main" id="{071971A1-E001-502B-0CC7-2346A09D282B}"/>
+              </a:ext>
+            </a:extLst>
+          </p:cNvPr>
+          <p:cNvSpPr/>
+          <p:nvPr/>
+        </p:nvSpPr>
+        <p:spPr>
+          <a:xfrm>
+            <a:off x="391069" y="2742984"/>
+            <a:ext cx="3208938" cy="2527518"/>
+          </a:xfrm>
+          <a:prstGeom prst="rect">
+            <a:avLst/>
+          </a:prstGeom>
+          <a:solidFill>
+            <a:schemeClr val="bg1">
+              <a:lumMod val="95000"/>
+            </a:schemeClr>
+          </a:solidFill>
+          <a:ln w="12700">
+            <a:noFill/>
+            <a:prstDash val="dash"/>
+          </a:ln>
+        </p:spPr>
+        <p:style>
+          <a:lnRef idx="2">
+            <a:schemeClr val="accent1">
+              <a:shade val="15000"/>
+            </a:schemeClr>
+          </a:lnRef>
+          <a:fillRef idx="1">
+            <a:schemeClr val="accent1"/>
+          </a:fillRef>
+          <a:effectRef idx="0">
+            <a:schemeClr val="accent1"/>
+          </a:effectRef>
+          <a:fontRef idx="minor">
+            <a:schemeClr val="lt1"/>
+          </a:fontRef>
+        </p:style>
+        <p:txBody>
+          <a:bodyPr rtlCol="0" anchor="b"/>
+          <a:lstStyle/>
+          <a:p>
+            <a:pPr algn="r"/>
+            <a:endParaRPr lang="en-US" sz="1400" i="1" dirty="0">
+              <a:solidFill>
+                <a:schemeClr val="tx1"/>
+              </a:solidFill>
+              <a:latin typeface="Arial" panose="020B0604020202020204" pitchFamily="34" charset="0"/>
+              <a:cs typeface="Arial" panose="020B0604020202020204" pitchFamily="34" charset="0"/>
+            </a:endParaRPr>
+          </a:p>
+        </p:txBody>
+      </p:sp>
+      <p:cxnSp>
+        <p:nvCxnSpPr>
+          <p:cNvPr id="141" name="Straight Arrow Connector 140">
+            <a:extLst>
+              <a:ext uri="{FF2B5EF4-FFF2-40B4-BE49-F238E27FC236}">
+                <a16:creationId xmlns:a16="http://schemas.microsoft.com/office/drawing/2014/main" id="{DD587270-E39F-094A-200E-C153C3AC6B49}"/>
+              </a:ext>
+            </a:extLst>
+          </p:cNvPr>
+          <p:cNvCxnSpPr>
+            <a:cxnSpLocks/>
+            <a:stCxn id="17" idx="2"/>
+            <a:endCxn id="25" idx="0"/>
+          </p:cNvCxnSpPr>
+          <p:nvPr/>
+        </p:nvCxnSpPr>
+        <p:spPr>
+          <a:xfrm>
+            <a:off x="8684282" y="3807941"/>
+            <a:ext cx="0" cy="427810"/>
+          </a:xfrm>
+          <a:prstGeom prst="straightConnector1">
+            <a:avLst/>
+          </a:prstGeom>
+          <a:ln w="12700">
+            <a:solidFill>
+              <a:schemeClr val="tx1"/>
+            </a:solidFill>
+            <a:headEnd type="none" w="med" len="med"/>
+            <a:tailEnd type="arrow" w="med" len="med"/>
+          </a:ln>
+        </p:spPr>
+        <p:style>
+          <a:lnRef idx="2">
+            <a:schemeClr val="accent1"/>
+          </a:lnRef>
+          <a:fillRef idx="0">
+            <a:schemeClr val="accent1"/>
+          </a:fillRef>
+          <a:effectRef idx="1">
+            <a:schemeClr val="accent1"/>
+          </a:effectRef>
+          <a:fontRef idx="minor">
+            <a:schemeClr val="tx1"/>
+          </a:fontRef>
+        </p:style>
+      </p:cxnSp>
+      <p:grpSp>
+        <p:nvGrpSpPr>
+          <p:cNvPr id="42" name="Group 41">
+            <a:extLst>
+              <a:ext uri="{FF2B5EF4-FFF2-40B4-BE49-F238E27FC236}">
+                <a16:creationId xmlns:a16="http://schemas.microsoft.com/office/drawing/2014/main" id="{4C55A592-9449-7380-B630-AF7FB42C8F13}"/>
+              </a:ext>
+            </a:extLst>
+          </p:cNvPr>
+          <p:cNvGrpSpPr/>
+          <p:nvPr/>
+        </p:nvGrpSpPr>
+        <p:grpSpPr>
+          <a:xfrm>
+            <a:off x="545110" y="2934439"/>
+            <a:ext cx="2900856" cy="867542"/>
+            <a:chOff x="777764" y="2661745"/>
+            <a:chExt cx="2900856" cy="867542"/>
+          </a:xfrm>
+        </p:grpSpPr>
+        <p:sp>
+          <p:nvSpPr>
+            <p:cNvPr id="16" name="Rounded Rectangle 15">
+              <a:extLst>
+                <a:ext uri="{FF2B5EF4-FFF2-40B4-BE49-F238E27FC236}">
+                  <a16:creationId xmlns:a16="http://schemas.microsoft.com/office/drawing/2014/main" id="{99DE0F33-EB75-38FF-433D-74F31C077A44}"/>
+                </a:ext>
+              </a:extLst>
+            </p:cNvPr>
+            <p:cNvSpPr/>
+            <p:nvPr/>
+          </p:nvSpPr>
+          <p:spPr>
+            <a:xfrm>
+              <a:off x="777764" y="2661745"/>
+              <a:ext cx="2900856" cy="867542"/>
+            </a:xfrm>
+            <a:prstGeom prst="roundRect">
+              <a:avLst/>
+            </a:prstGeom>
+            <a:solidFill>
+              <a:schemeClr val="bg1"/>
+            </a:solidFill>
+            <a:ln w="12700">
+              <a:solidFill>
+                <a:schemeClr val="tx1"/>
+              </a:solidFill>
+            </a:ln>
+          </p:spPr>
+          <p:style>
+            <a:lnRef idx="2">
+              <a:schemeClr val="accent1">
+                <a:shade val="15000"/>
+              </a:schemeClr>
+            </a:lnRef>
+            <a:fillRef idx="1">
+              <a:schemeClr val="accent1"/>
+            </a:fillRef>
+            <a:effectRef idx="0">
+              <a:schemeClr val="accent1"/>
+            </a:effectRef>
+            <a:fontRef idx="minor">
+              <a:schemeClr val="lt1"/>
+            </a:fontRef>
+          </p:style>
+          <p:txBody>
+            <a:bodyPr rtlCol="0" anchor="t"/>
+            <a:lstStyle/>
+            <a:p>
+              <a:pPr algn="ctr">
+                <a:lnSpc>
+                  <a:spcPts val="600"/>
+                </a:lnSpc>
+              </a:pPr>
+              <a:endParaRPr lang="en-US" sz="1400" dirty="0">
+                <a:solidFill>
+                  <a:schemeClr val="tx1"/>
+                </a:solidFill>
+                <a:latin typeface="Arial" panose="020B0604020202020204" pitchFamily="34" charset="0"/>
+                <a:cs typeface="Arial" panose="020B0604020202020204" pitchFamily="34" charset="0"/>
+              </a:endParaRPr>
+            </a:p>
+            <a:p>
+              <a:pPr algn="ctr">
+                <a:lnSpc>
+                  <a:spcPts val="600"/>
+                </a:lnSpc>
+              </a:pPr>
+              <a:endParaRPr lang="en-US" sz="1400" dirty="0">
+                <a:solidFill>
+                  <a:schemeClr val="tx1"/>
+                </a:solidFill>
+                <a:latin typeface="Arial" panose="020B0604020202020204" pitchFamily="34" charset="0"/>
+                <a:cs typeface="Arial" panose="020B0604020202020204" pitchFamily="34" charset="0"/>
+              </a:endParaRPr>
+            </a:p>
+            <a:p>
+              <a:pPr algn="ctr">
+                <a:lnSpc>
+                  <a:spcPts val="600"/>
+                </a:lnSpc>
+              </a:pPr>
+              <a:r>
+                <a:rPr lang="en-US" sz="1400" dirty="0">
+                  <a:solidFill>
+                    <a:schemeClr val="tx1"/>
+                  </a:solidFill>
+                  <a:latin typeface="Arial" panose="020B0604020202020204" pitchFamily="34" charset="0"/>
+                  <a:cs typeface="Arial" panose="020B0604020202020204" pitchFamily="34" charset="0"/>
+                </a:rPr>
+                <a:t>Discrepancy parameterization</a:t>
+              </a:r>
+            </a:p>
+          </p:txBody>
+        </p:sp>
+        <p:pic>
+          <p:nvPicPr>
+            <p:cNvPr id="29" name="Picture 28">
+              <a:extLst>
+                <a:ext uri="{FF2B5EF4-FFF2-40B4-BE49-F238E27FC236}">
+                  <a16:creationId xmlns:a16="http://schemas.microsoft.com/office/drawing/2014/main" id="{2A3FCE8B-A12A-C7AD-B494-10EDDF675D5E}"/>
+                </a:ext>
+              </a:extLst>
+            </p:cNvPr>
+            <p:cNvPicPr>
+              <a:picLocks noChangeAspect="1"/>
+            </p:cNvPicPr>
+            <p:nvPr/>
+          </p:nvPicPr>
+          <p:blipFill>
+            <a:blip r:embed="rId2"/>
+            <a:stretch>
+              <a:fillRect/>
+            </a:stretch>
+          </p:blipFill>
+          <p:spPr>
+            <a:xfrm>
+              <a:off x="932792" y="3068271"/>
+              <a:ext cx="2590800" cy="330200"/>
+            </a:xfrm>
+            <a:prstGeom prst="rect">
+              <a:avLst/>
+            </a:prstGeom>
+          </p:spPr>
+        </p:pic>
+      </p:grpSp>
+      <p:grpSp>
+        <p:nvGrpSpPr>
+          <p:cNvPr id="60" name="Group 59">
+            <a:extLst>
+              <a:ext uri="{FF2B5EF4-FFF2-40B4-BE49-F238E27FC236}">
+                <a16:creationId xmlns:a16="http://schemas.microsoft.com/office/drawing/2014/main" id="{8AB81CC6-9679-5364-D276-849FBC147D62}"/>
+              </a:ext>
+            </a:extLst>
+          </p:cNvPr>
+          <p:cNvGrpSpPr/>
+          <p:nvPr/>
+        </p:nvGrpSpPr>
+        <p:grpSpPr>
+          <a:xfrm>
+            <a:off x="7233854" y="4235751"/>
+            <a:ext cx="2900856" cy="867542"/>
+            <a:chOff x="8479791" y="3656070"/>
+            <a:chExt cx="2900856" cy="867542"/>
+          </a:xfrm>
+          <a:solidFill>
+            <a:schemeClr val="bg1"/>
+          </a:solidFill>
+        </p:grpSpPr>
+        <p:sp>
+          <p:nvSpPr>
+            <p:cNvPr id="25" name="Rounded Rectangle 24">
+              <a:extLst>
+                <a:ext uri="{FF2B5EF4-FFF2-40B4-BE49-F238E27FC236}">
+                  <a16:creationId xmlns:a16="http://schemas.microsoft.com/office/drawing/2014/main" id="{264B3922-CC5F-1702-075B-71F742E5ACFE}"/>
+                </a:ext>
+              </a:extLst>
+            </p:cNvPr>
+            <p:cNvSpPr/>
+            <p:nvPr/>
+          </p:nvSpPr>
+          <p:spPr>
+            <a:xfrm>
+              <a:off x="8479791" y="3656070"/>
+              <a:ext cx="2900856" cy="867542"/>
+            </a:xfrm>
+            <a:prstGeom prst="roundRect">
+              <a:avLst>
+                <a:gd name="adj" fmla="val 0"/>
+              </a:avLst>
+            </a:prstGeom>
+            <a:grpFill/>
+            <a:ln w="28575">
+              <a:solidFill>
+                <a:schemeClr val="tx1"/>
+              </a:solidFill>
+            </a:ln>
+          </p:spPr>
+          <p:style>
+            <a:lnRef idx="2">
+              <a:schemeClr val="accent1">
+                <a:shade val="15000"/>
+              </a:schemeClr>
+            </a:lnRef>
+            <a:fillRef idx="1">
+              <a:schemeClr val="accent1"/>
+            </a:fillRef>
+            <a:effectRef idx="0">
+              <a:schemeClr val="accent1"/>
+            </a:effectRef>
+            <a:fontRef idx="minor">
+              <a:schemeClr val="lt1"/>
+            </a:fontRef>
+          </p:style>
+          <p:txBody>
+            <a:bodyPr rtlCol="0" anchor="t"/>
+            <a:lstStyle/>
+            <a:p>
+              <a:pPr algn="ctr">
+                <a:lnSpc>
+                  <a:spcPts val="600"/>
+                </a:lnSpc>
+              </a:pPr>
+              <a:endParaRPr lang="en-US" sz="1400" dirty="0">
+                <a:solidFill>
+                  <a:schemeClr val="tx1"/>
+                </a:solidFill>
+                <a:latin typeface="Arial" panose="020B0604020202020204" pitchFamily="34" charset="0"/>
+                <a:cs typeface="Arial" panose="020B0604020202020204" pitchFamily="34" charset="0"/>
+              </a:endParaRPr>
+            </a:p>
+            <a:p>
+              <a:pPr algn="ctr">
+                <a:lnSpc>
+                  <a:spcPts val="600"/>
+                </a:lnSpc>
+              </a:pPr>
+              <a:endParaRPr lang="en-US" sz="1400" dirty="0">
+                <a:solidFill>
+                  <a:schemeClr val="tx1"/>
+                </a:solidFill>
+                <a:latin typeface="Arial" panose="020B0604020202020204" pitchFamily="34" charset="0"/>
+                <a:cs typeface="Arial" panose="020B0604020202020204" pitchFamily="34" charset="0"/>
+              </a:endParaRPr>
+            </a:p>
+            <a:p>
+              <a:pPr algn="ctr">
+                <a:lnSpc>
+                  <a:spcPts val="600"/>
+                </a:lnSpc>
+              </a:pPr>
+              <a:endParaRPr lang="en-US" sz="1400" dirty="0">
+                <a:solidFill>
+                  <a:schemeClr val="tx1"/>
+                </a:solidFill>
+                <a:latin typeface="Arial" panose="020B0604020202020204" pitchFamily="34" charset="0"/>
+                <a:cs typeface="Arial" panose="020B0604020202020204" pitchFamily="34" charset="0"/>
+              </a:endParaRPr>
+            </a:p>
+            <a:p>
+              <a:pPr algn="ctr">
+                <a:lnSpc>
+                  <a:spcPts val="400"/>
+                </a:lnSpc>
+              </a:pPr>
+              <a:r>
+                <a:rPr lang="en-US" sz="1400" dirty="0">
+                  <a:solidFill>
+                    <a:schemeClr val="tx1"/>
+                  </a:solidFill>
+                  <a:latin typeface="Arial" panose="020B0604020202020204" pitchFamily="34" charset="0"/>
+                  <a:cs typeface="Arial" panose="020B0604020202020204" pitchFamily="34" charset="0"/>
+                </a:rPr>
+                <a:t>Post-optimality sensitivity update</a:t>
+              </a:r>
+            </a:p>
+          </p:txBody>
+        </p:sp>
+        <p:pic>
+          <p:nvPicPr>
+            <p:cNvPr id="36" name="Picture 35">
+              <a:extLst>
+                <a:ext uri="{FF2B5EF4-FFF2-40B4-BE49-F238E27FC236}">
+                  <a16:creationId xmlns:a16="http://schemas.microsoft.com/office/drawing/2014/main" id="{F5AE298A-7C83-753A-8F8B-363326733360}"/>
+                </a:ext>
+              </a:extLst>
+            </p:cNvPr>
+            <p:cNvPicPr>
+              <a:picLocks noChangeAspect="1"/>
+            </p:cNvPicPr>
+            <p:nvPr/>
+          </p:nvPicPr>
+          <p:blipFill>
+            <a:blip r:embed="rId3"/>
+            <a:stretch>
+              <a:fillRect/>
+            </a:stretch>
+          </p:blipFill>
+          <p:spPr>
+            <a:xfrm>
+              <a:off x="9297058" y="4115241"/>
+              <a:ext cx="1333500" cy="165100"/>
+            </a:xfrm>
+            <a:prstGeom prst="rect">
+              <a:avLst/>
+            </a:prstGeom>
+            <a:grpFill/>
+          </p:spPr>
+        </p:pic>
+      </p:grpSp>
+      <p:cxnSp>
+        <p:nvCxnSpPr>
+          <p:cNvPr id="61" name="Straight Arrow Connector 60">
+            <a:extLst>
+              <a:ext uri="{FF2B5EF4-FFF2-40B4-BE49-F238E27FC236}">
+                <a16:creationId xmlns:a16="http://schemas.microsoft.com/office/drawing/2014/main" id="{6905389C-EF75-4A70-6BCF-5CABBDF38038}"/>
+              </a:ext>
+            </a:extLst>
+          </p:cNvPr>
+          <p:cNvCxnSpPr>
+            <a:cxnSpLocks/>
+            <a:stCxn id="20" idx="3"/>
+            <a:endCxn id="25" idx="1"/>
+          </p:cNvCxnSpPr>
+          <p:nvPr/>
+        </p:nvCxnSpPr>
+        <p:spPr>
+          <a:xfrm>
+            <a:off x="6790338" y="4669522"/>
+            <a:ext cx="443516" cy="0"/>
+          </a:xfrm>
+          <a:prstGeom prst="straightConnector1">
+            <a:avLst/>
+          </a:prstGeom>
+          <a:ln w="12700">
+            <a:solidFill>
+              <a:schemeClr val="tx1"/>
+            </a:solidFill>
+            <a:headEnd type="none" w="med" len="med"/>
+            <a:tailEnd type="arrow" w="med" len="med"/>
+          </a:ln>
+        </p:spPr>
+        <p:style>
+          <a:lnRef idx="2">
+            <a:schemeClr val="accent1"/>
+          </a:lnRef>
+          <a:fillRef idx="0">
+            <a:schemeClr val="accent1"/>
+          </a:fillRef>
+          <a:effectRef idx="1">
+            <a:schemeClr val="accent1"/>
+          </a:effectRef>
+          <a:fontRef idx="minor">
+            <a:schemeClr val="tx1"/>
+          </a:fontRef>
+        </p:style>
+      </p:cxnSp>
+      <p:cxnSp>
+        <p:nvCxnSpPr>
+          <p:cNvPr id="64" name="Straight Arrow Connector 63">
+            <a:extLst>
+              <a:ext uri="{FF2B5EF4-FFF2-40B4-BE49-F238E27FC236}">
+                <a16:creationId xmlns:a16="http://schemas.microsoft.com/office/drawing/2014/main" id="{30ED7BE4-B35F-AC66-E6F8-1223199669B0}"/>
+              </a:ext>
+            </a:extLst>
+          </p:cNvPr>
+          <p:cNvCxnSpPr>
+            <a:cxnSpLocks/>
+            <a:stCxn id="22" idx="2"/>
+            <a:endCxn id="20" idx="0"/>
+          </p:cNvCxnSpPr>
+          <p:nvPr/>
+        </p:nvCxnSpPr>
+        <p:spPr>
+          <a:xfrm>
+            <a:off x="5339910" y="3801981"/>
+            <a:ext cx="0" cy="433770"/>
+          </a:xfrm>
+          <a:prstGeom prst="straightConnector1">
+            <a:avLst/>
+          </a:prstGeom>
+          <a:ln w="12700">
+            <a:solidFill>
+              <a:schemeClr val="tx1"/>
+            </a:solidFill>
+            <a:headEnd type="none" w="med" len="med"/>
+            <a:tailEnd type="arrow" w="med" len="med"/>
+          </a:ln>
+        </p:spPr>
+        <p:style>
+          <a:lnRef idx="2">
+            <a:schemeClr val="accent1"/>
+          </a:lnRef>
+          <a:fillRef idx="0">
+            <a:schemeClr val="accent1"/>
+          </a:fillRef>
+          <a:effectRef idx="1">
+            <a:schemeClr val="accent1"/>
+          </a:effectRef>
+          <a:fontRef idx="minor">
+            <a:schemeClr val="tx1"/>
+          </a:fontRef>
+        </p:style>
+      </p:cxnSp>
+      <p:sp>
+        <p:nvSpPr>
+          <p:cNvPr id="119" name="TextBox 118">
+            <a:extLst>
+              <a:ext uri="{FF2B5EF4-FFF2-40B4-BE49-F238E27FC236}">
+                <a16:creationId xmlns:a16="http://schemas.microsoft.com/office/drawing/2014/main" id="{C93736E4-2A15-8194-B43E-E43A60C5964A}"/>
+              </a:ext>
+            </a:extLst>
+          </p:cNvPr>
+          <p:cNvSpPr txBox="1"/>
+          <p:nvPr/>
+        </p:nvSpPr>
+        <p:spPr>
+          <a:xfrm>
+            <a:off x="700138" y="2421886"/>
+            <a:ext cx="2596801" cy="307777"/>
+          </a:xfrm>
+          <a:prstGeom prst="rect">
+            <a:avLst/>
+          </a:prstGeom>
+          <a:noFill/>
+        </p:spPr>
+        <p:txBody>
+          <a:bodyPr wrap="none" rtlCol="0">
+            <a:spAutoFit/>
+          </a:bodyPr>
+          <a:lstStyle/>
+          <a:p>
+            <a:r>
+              <a:rPr lang="en-US" sz="1400" i="1" dirty="0">
+                <a:latin typeface="Arial" panose="020B0604020202020204" pitchFamily="34" charset="0"/>
+                <a:cs typeface="Arial" panose="020B0604020202020204" pitchFamily="34" charset="0"/>
+              </a:rPr>
+              <a:t>Model discrepancy formulation</a:t>
+            </a:r>
+          </a:p>
+        </p:txBody>
+      </p:sp>
+      <p:sp>
+        <p:nvSpPr>
+          <p:cNvPr id="120" name="TextBox 119">
+            <a:extLst>
+              <a:ext uri="{FF2B5EF4-FFF2-40B4-BE49-F238E27FC236}">
+                <a16:creationId xmlns:a16="http://schemas.microsoft.com/office/drawing/2014/main" id="{A6BD513B-0188-83A4-0683-CF1FFDA6C697}"/>
+              </a:ext>
+            </a:extLst>
+          </p:cNvPr>
+          <p:cNvSpPr txBox="1"/>
+          <p:nvPr/>
+        </p:nvSpPr>
+        <p:spPr>
+          <a:xfrm>
+            <a:off x="5400994" y="2421886"/>
+            <a:ext cx="3376245" cy="307777"/>
+          </a:xfrm>
+          <a:prstGeom prst="rect">
+            <a:avLst/>
+          </a:prstGeom>
+          <a:noFill/>
+        </p:spPr>
+        <p:txBody>
+          <a:bodyPr wrap="none" rtlCol="0">
+            <a:spAutoFit/>
+          </a:bodyPr>
+          <a:lstStyle/>
+          <a:p>
+            <a:pPr algn="ctr"/>
+            <a:r>
+              <a:rPr lang="en-US" sz="1400" i="1" dirty="0">
+                <a:solidFill>
+                  <a:schemeClr val="accent4"/>
+                </a:solidFill>
+                <a:latin typeface="Arial" panose="020B0604020202020204" pitchFamily="34" charset="0"/>
+                <a:cs typeface="Arial" panose="020B0604020202020204" pitchFamily="34" charset="0"/>
+              </a:rPr>
+              <a:t>Data and surrogate problem information</a:t>
+            </a:r>
+          </a:p>
+        </p:txBody>
+      </p:sp>
+      <p:cxnSp>
+        <p:nvCxnSpPr>
+          <p:cNvPr id="137" name="Straight Arrow Connector 136">
+            <a:extLst>
+              <a:ext uri="{FF2B5EF4-FFF2-40B4-BE49-F238E27FC236}">
+                <a16:creationId xmlns:a16="http://schemas.microsoft.com/office/drawing/2014/main" id="{7878A44F-A3A1-12A0-04E1-685B808BB1CD}"/>
+              </a:ext>
+            </a:extLst>
+          </p:cNvPr>
+          <p:cNvCxnSpPr>
+            <a:cxnSpLocks/>
+            <a:stCxn id="18" idx="3"/>
+            <a:endCxn id="20" idx="1"/>
+          </p:cNvCxnSpPr>
+          <p:nvPr/>
+        </p:nvCxnSpPr>
+        <p:spPr>
+          <a:xfrm>
+            <a:off x="3445966" y="4669522"/>
+            <a:ext cx="443516" cy="0"/>
+          </a:xfrm>
+          <a:prstGeom prst="straightConnector1">
+            <a:avLst/>
+          </a:prstGeom>
+          <a:ln w="12700">
+            <a:solidFill>
+              <a:schemeClr val="tx1"/>
+            </a:solidFill>
+            <a:headEnd type="none" w="med" len="med"/>
+            <a:tailEnd type="arrow" w="med" len="med"/>
+          </a:ln>
+        </p:spPr>
+        <p:style>
+          <a:lnRef idx="2">
+            <a:schemeClr val="accent1"/>
+          </a:lnRef>
+          <a:fillRef idx="0">
+            <a:schemeClr val="accent1"/>
+          </a:fillRef>
+          <a:effectRef idx="1">
+            <a:schemeClr val="accent1"/>
+          </a:effectRef>
+          <a:fontRef idx="minor">
+            <a:schemeClr val="tx1"/>
+          </a:fontRef>
+        </p:style>
+      </p:cxnSp>
+      <p:sp>
+        <p:nvSpPr>
+          <p:cNvPr id="155" name="TextBox 154">
+            <a:extLst>
+              <a:ext uri="{FF2B5EF4-FFF2-40B4-BE49-F238E27FC236}">
+                <a16:creationId xmlns:a16="http://schemas.microsoft.com/office/drawing/2014/main" id="{E770801E-18E3-AFAC-42EA-AD6C6C714F48}"/>
+              </a:ext>
+            </a:extLst>
+          </p:cNvPr>
+          <p:cNvSpPr txBox="1"/>
+          <p:nvPr/>
+        </p:nvSpPr>
+        <p:spPr>
+          <a:xfrm>
+            <a:off x="6021365" y="5269796"/>
+            <a:ext cx="2135521" cy="307777"/>
+          </a:xfrm>
+          <a:prstGeom prst="rect">
+            <a:avLst/>
+          </a:prstGeom>
+          <a:noFill/>
+        </p:spPr>
+        <p:txBody>
+          <a:bodyPr wrap="none" rtlCol="0">
+            <a:spAutoFit/>
+          </a:bodyPr>
+          <a:lstStyle/>
+          <a:p>
+            <a:pPr algn="ctr"/>
+            <a:r>
+              <a:rPr lang="en-US" sz="1400" i="1" dirty="0">
+                <a:solidFill>
+                  <a:schemeClr val="accent5"/>
+                </a:solidFill>
+                <a:latin typeface="Arial" panose="020B0604020202020204" pitchFamily="34" charset="0"/>
+                <a:cs typeface="Arial" panose="020B0604020202020204" pitchFamily="34" charset="0"/>
+              </a:rPr>
+              <a:t>Sensitivity-based update</a:t>
+            </a:r>
+          </a:p>
+        </p:txBody>
+      </p:sp>
+      <p:grpSp>
+        <p:nvGrpSpPr>
+          <p:cNvPr id="6" name="Group 5">
+            <a:extLst>
+              <a:ext uri="{FF2B5EF4-FFF2-40B4-BE49-F238E27FC236}">
+                <a16:creationId xmlns:a16="http://schemas.microsoft.com/office/drawing/2014/main" id="{BA5E3E25-8D57-7ABA-6A21-BDDC33D2D985}"/>
+              </a:ext>
+            </a:extLst>
+          </p:cNvPr>
+          <p:cNvGrpSpPr/>
+          <p:nvPr/>
+        </p:nvGrpSpPr>
+        <p:grpSpPr>
+          <a:xfrm>
+            <a:off x="3889482" y="2934439"/>
+            <a:ext cx="2900856" cy="867542"/>
+            <a:chOff x="3889482" y="1663116"/>
+            <a:chExt cx="2900856" cy="867542"/>
+          </a:xfrm>
+        </p:grpSpPr>
+        <p:sp>
+          <p:nvSpPr>
+            <p:cNvPr id="22" name="Rounded Rectangle 21">
+              <a:extLst>
+                <a:ext uri="{FF2B5EF4-FFF2-40B4-BE49-F238E27FC236}">
+                  <a16:creationId xmlns:a16="http://schemas.microsoft.com/office/drawing/2014/main" id="{FD51650F-F894-23B6-391D-F28B22F01131}"/>
+                </a:ext>
+              </a:extLst>
+            </p:cNvPr>
+            <p:cNvSpPr/>
+            <p:nvPr/>
+          </p:nvSpPr>
+          <p:spPr>
+            <a:xfrm>
+              <a:off x="3889482" y="1663116"/>
+              <a:ext cx="2900856" cy="867542"/>
+            </a:xfrm>
+            <a:prstGeom prst="roundRect">
+              <a:avLst/>
+            </a:prstGeom>
+            <a:solidFill>
+              <a:schemeClr val="bg1"/>
+            </a:solidFill>
+            <a:ln w="12700">
+              <a:solidFill>
+                <a:schemeClr val="tx1"/>
+              </a:solidFill>
+            </a:ln>
+          </p:spPr>
+          <p:style>
+            <a:lnRef idx="2">
+              <a:schemeClr val="accent1">
+                <a:shade val="15000"/>
+              </a:schemeClr>
+            </a:lnRef>
+            <a:fillRef idx="1">
+              <a:schemeClr val="accent1"/>
+            </a:fillRef>
+            <a:effectRef idx="0">
+              <a:schemeClr val="accent1"/>
+            </a:effectRef>
+            <a:fontRef idx="minor">
+              <a:schemeClr val="lt1"/>
+            </a:fontRef>
+          </p:style>
+          <p:txBody>
+            <a:bodyPr rtlCol="0" anchor="t"/>
+            <a:lstStyle/>
+            <a:p>
+              <a:pPr algn="ctr">
+                <a:lnSpc>
+                  <a:spcPts val="600"/>
+                </a:lnSpc>
+              </a:pPr>
+              <a:endParaRPr lang="en-US" sz="1400" dirty="0">
+                <a:solidFill>
+                  <a:schemeClr val="tx1"/>
+                </a:solidFill>
+                <a:latin typeface="Arial" panose="020B0604020202020204" pitchFamily="34" charset="0"/>
+                <a:cs typeface="Arial" panose="020B0604020202020204" pitchFamily="34" charset="0"/>
+              </a:endParaRPr>
+            </a:p>
+            <a:p>
+              <a:pPr algn="ctr">
+                <a:lnSpc>
+                  <a:spcPts val="600"/>
+                </a:lnSpc>
+              </a:pPr>
+              <a:endParaRPr lang="en-US" sz="1400" dirty="0">
+                <a:solidFill>
+                  <a:schemeClr val="tx1"/>
+                </a:solidFill>
+                <a:latin typeface="Arial" panose="020B0604020202020204" pitchFamily="34" charset="0"/>
+                <a:cs typeface="Arial" panose="020B0604020202020204" pitchFamily="34" charset="0"/>
+              </a:endParaRPr>
+            </a:p>
+            <a:p>
+              <a:pPr algn="ctr">
+                <a:lnSpc>
+                  <a:spcPts val="600"/>
+                </a:lnSpc>
+              </a:pPr>
+              <a:r>
+                <a:rPr lang="en-US" sz="1400" dirty="0">
+                  <a:solidFill>
+                    <a:schemeClr val="tx1"/>
+                  </a:solidFill>
+                  <a:latin typeface="Arial" panose="020B0604020202020204" pitchFamily="34" charset="0"/>
+                  <a:cs typeface="Arial" panose="020B0604020202020204" pitchFamily="34" charset="0"/>
+                </a:rPr>
+                <a:t>Large-scale / surrogate data</a:t>
+              </a:r>
+            </a:p>
+          </p:txBody>
+        </p:sp>
+        <p:pic>
+          <p:nvPicPr>
+            <p:cNvPr id="5" name="Picture 4">
+              <a:extLst>
+                <a:ext uri="{FF2B5EF4-FFF2-40B4-BE49-F238E27FC236}">
+                  <a16:creationId xmlns:a16="http://schemas.microsoft.com/office/drawing/2014/main" id="{C9E7C893-83A3-71DD-61F1-0956517B80DD}"/>
+                </a:ext>
+              </a:extLst>
+            </p:cNvPr>
+            <p:cNvPicPr>
+              <a:picLocks noChangeAspect="1"/>
+            </p:cNvPicPr>
+            <p:nvPr/>
+          </p:nvPicPr>
+          <p:blipFill>
+            <a:blip r:embed="rId4"/>
+            <a:stretch>
+              <a:fillRect/>
+            </a:stretch>
+          </p:blipFill>
+          <p:spPr>
+            <a:xfrm>
+              <a:off x="4336610" y="2131849"/>
+              <a:ext cx="2006600" cy="190500"/>
+            </a:xfrm>
+            <a:prstGeom prst="rect">
+              <a:avLst/>
+            </a:prstGeom>
+          </p:spPr>
+        </p:pic>
+      </p:grpSp>
+      <p:grpSp>
+        <p:nvGrpSpPr>
+          <p:cNvPr id="28" name="Group 27">
+            <a:extLst>
+              <a:ext uri="{FF2B5EF4-FFF2-40B4-BE49-F238E27FC236}">
+                <a16:creationId xmlns:a16="http://schemas.microsoft.com/office/drawing/2014/main" id="{BD0027E4-6439-AA2A-82E9-B762B53EB605}"/>
+              </a:ext>
+            </a:extLst>
+          </p:cNvPr>
+          <p:cNvGrpSpPr/>
+          <p:nvPr/>
+        </p:nvGrpSpPr>
+        <p:grpSpPr>
+          <a:xfrm>
+            <a:off x="7233854" y="2940399"/>
+            <a:ext cx="2900856" cy="867542"/>
+            <a:chOff x="7233854" y="2940399"/>
+            <a:chExt cx="2900856" cy="867542"/>
+          </a:xfrm>
+        </p:grpSpPr>
+        <p:sp>
+          <p:nvSpPr>
+            <p:cNvPr id="17" name="Rounded Rectangle 16">
+              <a:extLst>
+                <a:ext uri="{FF2B5EF4-FFF2-40B4-BE49-F238E27FC236}">
+                  <a16:creationId xmlns:a16="http://schemas.microsoft.com/office/drawing/2014/main" id="{624C7208-8360-2CD8-880A-99C7F57AB916}"/>
+                </a:ext>
+              </a:extLst>
+            </p:cNvPr>
+            <p:cNvSpPr/>
+            <p:nvPr/>
+          </p:nvSpPr>
+          <p:spPr>
+            <a:xfrm>
+              <a:off x="7233854" y="2940399"/>
+              <a:ext cx="2900856" cy="867542"/>
+            </a:xfrm>
+            <a:prstGeom prst="roundRect">
+              <a:avLst/>
+            </a:prstGeom>
+            <a:solidFill>
+              <a:schemeClr val="bg1"/>
+            </a:solidFill>
+            <a:ln w="12700">
+              <a:solidFill>
+                <a:schemeClr val="tx1"/>
+              </a:solidFill>
+            </a:ln>
+          </p:spPr>
+          <p:style>
+            <a:lnRef idx="2">
+              <a:schemeClr val="accent1">
+                <a:shade val="15000"/>
+              </a:schemeClr>
+            </a:lnRef>
+            <a:fillRef idx="1">
+              <a:schemeClr val="accent1"/>
+            </a:fillRef>
+            <a:effectRef idx="0">
+              <a:schemeClr val="accent1"/>
+            </a:effectRef>
+            <a:fontRef idx="minor">
+              <a:schemeClr val="lt1"/>
+            </a:fontRef>
+          </p:style>
+          <p:txBody>
+            <a:bodyPr rtlCol="0" anchor="t"/>
+            <a:lstStyle/>
+            <a:p>
+              <a:pPr algn="ctr"/>
+              <a:r>
+                <a:rPr lang="en-US" sz="1400" dirty="0">
+                  <a:solidFill>
+                    <a:schemeClr val="tx1"/>
+                  </a:solidFill>
+                  <a:latin typeface="Arial" panose="020B0604020202020204" pitchFamily="34" charset="0"/>
+                  <a:cs typeface="Arial" panose="020B0604020202020204" pitchFamily="34" charset="0"/>
+                </a:rPr>
+                <a:t>Solution to surrogate-constrained optimization problem</a:t>
+              </a:r>
+            </a:p>
+          </p:txBody>
+        </p:sp>
+        <p:pic>
+          <p:nvPicPr>
+            <p:cNvPr id="27" name="Picture 26">
+              <a:extLst>
+                <a:ext uri="{FF2B5EF4-FFF2-40B4-BE49-F238E27FC236}">
+                  <a16:creationId xmlns:a16="http://schemas.microsoft.com/office/drawing/2014/main" id="{2CF936A8-57F8-6460-43F9-9B51DD7335EB}"/>
+                </a:ext>
+              </a:extLst>
+            </p:cNvPr>
+            <p:cNvPicPr>
+              <a:picLocks noChangeAspect="1"/>
+            </p:cNvPicPr>
+            <p:nvPr/>
+          </p:nvPicPr>
+          <p:blipFill>
+            <a:blip r:embed="rId5"/>
+            <a:stretch>
+              <a:fillRect/>
+            </a:stretch>
+          </p:blipFill>
+          <p:spPr>
+            <a:xfrm>
+              <a:off x="7839732" y="3527455"/>
+              <a:ext cx="1689100" cy="190500"/>
+            </a:xfrm>
+            <a:prstGeom prst="rect">
+              <a:avLst/>
+            </a:prstGeom>
+          </p:spPr>
+        </p:pic>
+      </p:grpSp>
+      <p:grpSp>
+        <p:nvGrpSpPr>
+          <p:cNvPr id="23" name="Group 22">
+            <a:extLst>
+              <a:ext uri="{FF2B5EF4-FFF2-40B4-BE49-F238E27FC236}">
+                <a16:creationId xmlns:a16="http://schemas.microsoft.com/office/drawing/2014/main" id="{E0EFC25A-35AC-E169-7D22-1AD16E3DFEFE}"/>
+              </a:ext>
+            </a:extLst>
+          </p:cNvPr>
+          <p:cNvGrpSpPr/>
+          <p:nvPr/>
+        </p:nvGrpSpPr>
+        <p:grpSpPr>
+          <a:xfrm>
+            <a:off x="545110" y="4235751"/>
+            <a:ext cx="2900856" cy="867542"/>
+            <a:chOff x="545110" y="4235751"/>
+            <a:chExt cx="2900856" cy="867542"/>
+          </a:xfrm>
+        </p:grpSpPr>
+        <p:sp>
+          <p:nvSpPr>
+            <p:cNvPr id="18" name="Rounded Rectangle 17">
+              <a:extLst>
+                <a:ext uri="{FF2B5EF4-FFF2-40B4-BE49-F238E27FC236}">
+                  <a16:creationId xmlns:a16="http://schemas.microsoft.com/office/drawing/2014/main" id="{DF39C4F9-9E6D-2A92-E61F-823A74A683A5}"/>
+                </a:ext>
+              </a:extLst>
+            </p:cNvPr>
+            <p:cNvSpPr/>
+            <p:nvPr/>
+          </p:nvSpPr>
+          <p:spPr>
+            <a:xfrm>
+              <a:off x="545110" y="4235751"/>
+              <a:ext cx="2900856" cy="867542"/>
+            </a:xfrm>
+            <a:prstGeom prst="roundRect">
+              <a:avLst/>
+            </a:prstGeom>
+            <a:solidFill>
+              <a:schemeClr val="bg1"/>
+            </a:solidFill>
+            <a:ln w="12700">
+              <a:solidFill>
+                <a:schemeClr val="tx1"/>
+              </a:solidFill>
+            </a:ln>
+          </p:spPr>
+          <p:style>
+            <a:lnRef idx="2">
+              <a:schemeClr val="accent1">
+                <a:shade val="15000"/>
+              </a:schemeClr>
+            </a:lnRef>
+            <a:fillRef idx="1">
+              <a:schemeClr val="accent1"/>
+            </a:fillRef>
+            <a:effectRef idx="0">
+              <a:schemeClr val="accent1"/>
+            </a:effectRef>
+            <a:fontRef idx="minor">
+              <a:schemeClr val="lt1"/>
+            </a:fontRef>
+          </p:style>
+          <p:txBody>
+            <a:bodyPr rtlCol="0" anchor="t"/>
+            <a:lstStyle/>
+            <a:p>
+              <a:pPr algn="ctr">
+                <a:lnSpc>
+                  <a:spcPts val="600"/>
+                </a:lnSpc>
+              </a:pPr>
+              <a:endParaRPr lang="en-US" sz="1400" dirty="0">
+                <a:solidFill>
+                  <a:schemeClr val="tx1"/>
+                </a:solidFill>
+                <a:latin typeface="Arial" panose="020B0604020202020204" pitchFamily="34" charset="0"/>
+                <a:cs typeface="Arial" panose="020B0604020202020204" pitchFamily="34" charset="0"/>
+              </a:endParaRPr>
+            </a:p>
+            <a:p>
+              <a:pPr algn="ctr">
+                <a:lnSpc>
+                  <a:spcPts val="600"/>
+                </a:lnSpc>
+              </a:pPr>
+              <a:r>
+                <a:rPr lang="en-US" sz="1400" dirty="0">
+                  <a:solidFill>
+                    <a:schemeClr val="tx1"/>
+                  </a:solidFill>
+                  <a:latin typeface="Arial" panose="020B0604020202020204" pitchFamily="34" charset="0"/>
+                  <a:cs typeface="Arial" panose="020B0604020202020204" pitchFamily="34" charset="0"/>
+                </a:rPr>
+                <a:t>Discrepancy prior, noise model</a:t>
+              </a:r>
+            </a:p>
+          </p:txBody>
+        </p:sp>
+        <p:pic>
+          <p:nvPicPr>
+            <p:cNvPr id="15" name="Picture 14">
+              <a:extLst>
+                <a:ext uri="{FF2B5EF4-FFF2-40B4-BE49-F238E27FC236}">
+                  <a16:creationId xmlns:a16="http://schemas.microsoft.com/office/drawing/2014/main" id="{19813F93-84D7-F186-9AB8-2D53F33D9682}"/>
+                </a:ext>
+              </a:extLst>
+            </p:cNvPr>
+            <p:cNvPicPr>
+              <a:picLocks noChangeAspect="1"/>
+            </p:cNvPicPr>
+            <p:nvPr/>
+          </p:nvPicPr>
+          <p:blipFill>
+            <a:blip r:embed="rId6"/>
+            <a:stretch>
+              <a:fillRect/>
+            </a:stretch>
+          </p:blipFill>
+          <p:spPr>
+            <a:xfrm>
+              <a:off x="1181227" y="4552754"/>
+              <a:ext cx="1612900" cy="457200"/>
+            </a:xfrm>
+            <a:prstGeom prst="rect">
+              <a:avLst/>
+            </a:prstGeom>
+          </p:spPr>
+        </p:pic>
+      </p:grpSp>
+      <p:grpSp>
+        <p:nvGrpSpPr>
+          <p:cNvPr id="24" name="Group 23">
+            <a:extLst>
+              <a:ext uri="{FF2B5EF4-FFF2-40B4-BE49-F238E27FC236}">
+                <a16:creationId xmlns:a16="http://schemas.microsoft.com/office/drawing/2014/main" id="{1BECBC64-CA44-4A69-624F-8D0101CCE50D}"/>
+              </a:ext>
+            </a:extLst>
+          </p:cNvPr>
+          <p:cNvGrpSpPr/>
+          <p:nvPr/>
+        </p:nvGrpSpPr>
+        <p:grpSpPr>
+          <a:xfrm>
+            <a:off x="3889482" y="4235751"/>
+            <a:ext cx="2900856" cy="867542"/>
+            <a:chOff x="3889482" y="4235751"/>
+            <a:chExt cx="2900856" cy="867542"/>
+          </a:xfrm>
+        </p:grpSpPr>
+        <p:sp>
+          <p:nvSpPr>
+            <p:cNvPr id="20" name="Rounded Rectangle 19">
+              <a:extLst>
+                <a:ext uri="{FF2B5EF4-FFF2-40B4-BE49-F238E27FC236}">
+                  <a16:creationId xmlns:a16="http://schemas.microsoft.com/office/drawing/2014/main" id="{F125A8B2-24EE-007C-D3CA-F8D874957E3C}"/>
+                </a:ext>
+              </a:extLst>
+            </p:cNvPr>
+            <p:cNvSpPr/>
+            <p:nvPr/>
+          </p:nvSpPr>
+          <p:spPr>
+            <a:xfrm>
+              <a:off x="3889482" y="4235751"/>
+              <a:ext cx="2900856" cy="867542"/>
+            </a:xfrm>
+            <a:prstGeom prst="roundRect">
+              <a:avLst/>
+            </a:prstGeom>
+            <a:solidFill>
+              <a:schemeClr val="bg1"/>
+            </a:solidFill>
+            <a:ln w="12700">
+              <a:solidFill>
+                <a:schemeClr val="tx1"/>
+              </a:solidFill>
+            </a:ln>
+          </p:spPr>
+          <p:style>
+            <a:lnRef idx="2">
+              <a:schemeClr val="accent1">
+                <a:shade val="15000"/>
+              </a:schemeClr>
+            </a:lnRef>
+            <a:fillRef idx="1">
+              <a:schemeClr val="accent1"/>
+            </a:fillRef>
+            <a:effectRef idx="0">
+              <a:schemeClr val="accent1"/>
+            </a:effectRef>
+            <a:fontRef idx="minor">
+              <a:schemeClr val="lt1"/>
+            </a:fontRef>
+          </p:style>
+          <p:txBody>
+            <a:bodyPr rtlCol="0" anchor="t"/>
+            <a:lstStyle/>
+            <a:p>
+              <a:pPr algn="ctr">
+                <a:lnSpc>
+                  <a:spcPts val="600"/>
+                </a:lnSpc>
+              </a:pPr>
+              <a:endParaRPr lang="en-US" sz="1400" dirty="0">
+                <a:solidFill>
+                  <a:schemeClr val="tx1"/>
+                </a:solidFill>
+                <a:latin typeface="Arial" panose="020B0604020202020204" pitchFamily="34" charset="0"/>
+                <a:cs typeface="Arial" panose="020B0604020202020204" pitchFamily="34" charset="0"/>
+              </a:endParaRPr>
+            </a:p>
+            <a:p>
+              <a:pPr algn="ctr">
+                <a:lnSpc>
+                  <a:spcPts val="600"/>
+                </a:lnSpc>
+              </a:pPr>
+              <a:endParaRPr lang="en-US" sz="1400" dirty="0">
+                <a:solidFill>
+                  <a:schemeClr val="tx1"/>
+                </a:solidFill>
+                <a:latin typeface="Arial" panose="020B0604020202020204" pitchFamily="34" charset="0"/>
+                <a:cs typeface="Arial" panose="020B0604020202020204" pitchFamily="34" charset="0"/>
+              </a:endParaRPr>
+            </a:p>
+            <a:p>
+              <a:pPr algn="ctr">
+                <a:lnSpc>
+                  <a:spcPts val="600"/>
+                </a:lnSpc>
+              </a:pPr>
+              <a:r>
+                <a:rPr lang="en-US" sz="1400" dirty="0">
+                  <a:solidFill>
+                    <a:schemeClr val="tx1"/>
+                  </a:solidFill>
+                  <a:latin typeface="Arial" panose="020B0604020202020204" pitchFamily="34" charset="0"/>
+                  <a:cs typeface="Arial" panose="020B0604020202020204" pitchFamily="34" charset="0"/>
+                </a:rPr>
+                <a:t>Bayesian discrepancy calibration</a:t>
+              </a:r>
+            </a:p>
+          </p:txBody>
+        </p:sp>
+        <p:pic>
+          <p:nvPicPr>
+            <p:cNvPr id="21" name="Picture 20">
+              <a:extLst>
+                <a:ext uri="{FF2B5EF4-FFF2-40B4-BE49-F238E27FC236}">
+                  <a16:creationId xmlns:a16="http://schemas.microsoft.com/office/drawing/2014/main" id="{D57C8936-64E7-A1C1-6DD8-2272ABEE0C55}"/>
+                </a:ext>
+              </a:extLst>
+            </p:cNvPr>
+            <p:cNvPicPr>
+              <a:picLocks noChangeAspect="1"/>
+            </p:cNvPicPr>
+            <p:nvPr/>
+          </p:nvPicPr>
+          <p:blipFill>
+            <a:blip r:embed="rId7"/>
+            <a:stretch>
+              <a:fillRect/>
+            </a:stretch>
+          </p:blipFill>
+          <p:spPr>
+            <a:xfrm>
+              <a:off x="4266760" y="4701154"/>
+              <a:ext cx="2146300" cy="203200"/>
+            </a:xfrm>
+            <a:prstGeom prst="rect">
+              <a:avLst/>
+            </a:prstGeom>
+          </p:spPr>
+        </p:pic>
+      </p:grpSp>
+      <p:cxnSp>
+        <p:nvCxnSpPr>
+          <p:cNvPr id="2" name="Straight Arrow Connector 1">
+            <a:extLst>
+              <a:ext uri="{FF2B5EF4-FFF2-40B4-BE49-F238E27FC236}">
+                <a16:creationId xmlns:a16="http://schemas.microsoft.com/office/drawing/2014/main" id="{FB33625B-AB8D-14B2-4B55-58865E0AFA28}"/>
+              </a:ext>
+            </a:extLst>
+          </p:cNvPr>
+          <p:cNvCxnSpPr>
+            <a:cxnSpLocks/>
+            <a:stCxn id="16" idx="3"/>
+          </p:cNvCxnSpPr>
+          <p:nvPr/>
+        </p:nvCxnSpPr>
+        <p:spPr>
+          <a:xfrm>
+            <a:off x="3445966" y="3368210"/>
+            <a:ext cx="535315" cy="867541"/>
+          </a:xfrm>
+          <a:prstGeom prst="straightConnector1">
+            <a:avLst/>
+          </a:prstGeom>
+          <a:ln w="12700">
+            <a:solidFill>
+              <a:schemeClr val="tx1"/>
+            </a:solidFill>
+            <a:headEnd type="none" w="med" len="med"/>
+            <a:tailEnd type="arrow" w="med" len="med"/>
+          </a:ln>
+        </p:spPr>
+        <p:style>
+          <a:lnRef idx="2">
+            <a:schemeClr val="accent1"/>
+          </a:lnRef>
+          <a:fillRef idx="0">
+            <a:schemeClr val="accent1"/>
+          </a:fillRef>
+          <a:effectRef idx="1">
+            <a:schemeClr val="accent1"/>
+          </a:effectRef>
+          <a:fontRef idx="minor">
+            <a:schemeClr val="tx1"/>
+          </a:fontRef>
+        </p:style>
+      </p:cxnSp>
+    </p:spTree>
+    <p:extLst>
+      <p:ext uri="{BB962C8B-B14F-4D97-AF65-F5344CB8AC3E}">
+        <p14:creationId xmlns:p14="http://schemas.microsoft.com/office/powerpoint/2010/main" val="3041916857"/>
+      </p:ext>
+    </p:extLst>
+  </p:cSld>
+  <p:clrMapOvr>
+    <a:masterClrMapping/>
+  </p:clrMapOvr>
+</p:sld>
+</file>
+
+<file path=ppt/slides/slide4.xml><?xml version="1.0" encoding="utf-8"?>
+<p:sld xmlns:a="http://schemas.openxmlformats.org/drawingml/2006/main" xmlns:r="http://schemas.openxmlformats.org/officeDocument/2006/relationships" xmlns:p="http://schemas.openxmlformats.org/presentationml/2006/main" show="0">
+  <p:cSld>
+    <p:spTree>
+      <p:nvGrpSpPr>
+        <p:cNvPr id="1" name="">
+          <a:extLst>
+            <a:ext uri="{FF2B5EF4-FFF2-40B4-BE49-F238E27FC236}">
+              <a16:creationId xmlns:a16="http://schemas.microsoft.com/office/drawing/2014/main" id="{C40A534B-EEB4-13F6-B255-D5000D4048C6}"/>
+            </a:ext>
+          </a:extLst>
+        </p:cNvPr>
+        <p:cNvGrpSpPr/>
+        <p:nvPr/>
+      </p:nvGrpSpPr>
+      <p:grpSpPr>
+        <a:xfrm>
+          <a:off x="0" y="0"/>
+          <a:ext cx="0" cy="0"/>
+          <a:chOff x="0" y="0"/>
+          <a:chExt cx="0" cy="0"/>
+        </a:xfrm>
+      </p:grpSpPr>
+      <p:sp>
+        <p:nvSpPr>
+          <p:cNvPr id="148" name="Rectangle 147">
+            <a:extLst>
+              <a:ext uri="{FF2B5EF4-FFF2-40B4-BE49-F238E27FC236}">
+                <a16:creationId xmlns:a16="http://schemas.microsoft.com/office/drawing/2014/main" id="{F906E1AB-0E8E-ACB4-310E-94D71F5AD099}"/>
+              </a:ext>
+            </a:extLst>
+          </p:cNvPr>
+          <p:cNvSpPr/>
+          <p:nvPr/>
+        </p:nvSpPr>
+        <p:spPr>
+          <a:xfrm>
+            <a:off x="3699641" y="4096297"/>
+            <a:ext cx="6643239" cy="1174205"/>
+          </a:xfrm>
+          <a:prstGeom prst="rect">
+            <a:avLst/>
+          </a:prstGeom>
+          <a:solidFill>
+            <a:schemeClr val="accent5">
+              <a:alpha val="10196"/>
+            </a:schemeClr>
+          </a:solidFill>
+          <a:ln w="12700">
+            <a:noFill/>
+            <a:prstDash val="lgDashDot"/>
+          </a:ln>
+        </p:spPr>
+        <p:style>
+          <a:lnRef idx="2">
+            <a:schemeClr val="accent1">
+              <a:shade val="15000"/>
+            </a:schemeClr>
+          </a:lnRef>
+          <a:fillRef idx="1">
+            <a:schemeClr val="accent1"/>
+          </a:fillRef>
+          <a:effectRef idx="0">
+            <a:schemeClr val="accent1"/>
+          </a:effectRef>
+          <a:fontRef idx="minor">
+            <a:schemeClr val="lt1"/>
+          </a:fontRef>
+        </p:style>
+        <p:txBody>
+          <a:bodyPr rtlCol="0" anchor="ctr"/>
+          <a:lstStyle/>
+          <a:p>
+            <a:pPr algn="ctr"/>
+            <a:endParaRPr lang="en-US"/>
+          </a:p>
+        </p:txBody>
+      </p:sp>
+      <p:sp>
+        <p:nvSpPr>
+          <p:cNvPr id="136" name="Rectangle 135">
+            <a:extLst>
+              <a:ext uri="{FF2B5EF4-FFF2-40B4-BE49-F238E27FC236}">
+                <a16:creationId xmlns:a16="http://schemas.microsoft.com/office/drawing/2014/main" id="{5DF0B468-9606-2297-5379-7AAD5A68B282}"/>
+              </a:ext>
+            </a:extLst>
+          </p:cNvPr>
+          <p:cNvSpPr/>
+          <p:nvPr/>
+        </p:nvSpPr>
+        <p:spPr>
+          <a:xfrm>
+            <a:off x="3699641" y="1497944"/>
+            <a:ext cx="6643239" cy="2527518"/>
+          </a:xfrm>
+          <a:prstGeom prst="rect">
+            <a:avLst/>
+          </a:prstGeom>
+          <a:solidFill>
+            <a:srgbClr val="0F9ED5">
+              <a:alpha val="10196"/>
+            </a:srgbClr>
+          </a:solidFill>
+          <a:ln w="12700">
+            <a:noFill/>
+            <a:prstDash val="lgDashDot"/>
+          </a:ln>
+        </p:spPr>
+        <p:style>
+          <a:lnRef idx="2">
+            <a:schemeClr val="accent1">
+              <a:shade val="15000"/>
+            </a:schemeClr>
+          </a:lnRef>
+          <a:fillRef idx="1">
+            <a:schemeClr val="accent1"/>
+          </a:fillRef>
+          <a:effectRef idx="0">
+            <a:schemeClr val="accent1"/>
+          </a:effectRef>
+          <a:fontRef idx="minor">
+            <a:schemeClr val="lt1"/>
+          </a:fontRef>
+        </p:style>
+        <p:txBody>
+          <a:bodyPr rtlCol="0" anchor="ctr"/>
+          <a:lstStyle/>
+          <a:p>
+            <a:pPr algn="ctr"/>
+            <a:endParaRPr lang="en-US"/>
+          </a:p>
+        </p:txBody>
+      </p:sp>
+      <p:sp>
+        <p:nvSpPr>
+          <p:cNvPr id="49" name="Rectangle 48">
+            <a:extLst>
+              <a:ext uri="{FF2B5EF4-FFF2-40B4-BE49-F238E27FC236}">
+                <a16:creationId xmlns:a16="http://schemas.microsoft.com/office/drawing/2014/main" id="{DB949787-CD45-C308-9A1E-59789648A7E1}"/>
+              </a:ext>
+            </a:extLst>
+          </p:cNvPr>
+          <p:cNvSpPr/>
+          <p:nvPr/>
+        </p:nvSpPr>
+        <p:spPr>
+          <a:xfrm>
+            <a:off x="391069" y="1497944"/>
+            <a:ext cx="3208938" cy="3772558"/>
+          </a:xfrm>
+          <a:prstGeom prst="rect">
+            <a:avLst/>
+          </a:prstGeom>
+          <a:solidFill>
+            <a:schemeClr val="bg1">
+              <a:lumMod val="95000"/>
+            </a:schemeClr>
+          </a:solidFill>
+          <a:ln w="12700">
+            <a:noFill/>
+            <a:prstDash val="dash"/>
+          </a:ln>
+        </p:spPr>
+        <p:style>
+          <a:lnRef idx="2">
+            <a:schemeClr val="accent1">
+              <a:shade val="15000"/>
+            </a:schemeClr>
+          </a:lnRef>
+          <a:fillRef idx="1">
+            <a:schemeClr val="accent1"/>
+          </a:fillRef>
+          <a:effectRef idx="0">
+            <a:schemeClr val="accent1"/>
+          </a:effectRef>
+          <a:fontRef idx="minor">
+            <a:schemeClr val="lt1"/>
+          </a:fontRef>
+        </p:style>
+        <p:txBody>
+          <a:bodyPr rtlCol="0" anchor="b"/>
+          <a:lstStyle/>
+          <a:p>
+            <a:pPr algn="r"/>
+            <a:endParaRPr lang="en-US" sz="1400" i="1" dirty="0">
+              <a:solidFill>
+                <a:schemeClr val="tx1"/>
+              </a:solidFill>
+              <a:latin typeface="Arial" panose="020B0604020202020204" pitchFamily="34" charset="0"/>
+              <a:cs typeface="Arial" panose="020B0604020202020204" pitchFamily="34" charset="0"/>
+            </a:endParaRPr>
+          </a:p>
+        </p:txBody>
+      </p:sp>
+      <p:cxnSp>
+        <p:nvCxnSpPr>
+          <p:cNvPr id="144" name="Straight Arrow Connector 143">
+            <a:extLst>
+              <a:ext uri="{FF2B5EF4-FFF2-40B4-BE49-F238E27FC236}">
+                <a16:creationId xmlns:a16="http://schemas.microsoft.com/office/drawing/2014/main" id="{138134EB-B020-D251-39F7-90F7D1B35CF5}"/>
+              </a:ext>
+            </a:extLst>
+          </p:cNvPr>
+          <p:cNvCxnSpPr>
+            <a:cxnSpLocks/>
+            <a:stCxn id="2" idx="0"/>
+            <a:endCxn id="18" idx="2"/>
+          </p:cNvCxnSpPr>
+          <p:nvPr/>
+        </p:nvCxnSpPr>
+        <p:spPr>
+          <a:xfrm>
+            <a:off x="1995538" y="1667420"/>
+            <a:ext cx="0" cy="3435873"/>
+          </a:xfrm>
+          <a:prstGeom prst="straightConnector1">
+            <a:avLst/>
+          </a:prstGeom>
+          <a:ln w="12700">
+            <a:solidFill>
+              <a:schemeClr val="tx1"/>
+            </a:solidFill>
+            <a:headEnd type="none" w="med" len="med"/>
+            <a:tailEnd type="none" w="med" len="med"/>
+          </a:ln>
+        </p:spPr>
+        <p:style>
+          <a:lnRef idx="2">
+            <a:schemeClr val="accent1"/>
+          </a:lnRef>
+          <a:fillRef idx="0">
+            <a:schemeClr val="accent1"/>
+          </a:fillRef>
+          <a:effectRef idx="1">
+            <a:schemeClr val="accent1"/>
+          </a:effectRef>
+          <a:fontRef idx="minor">
+            <a:schemeClr val="tx1"/>
+          </a:fontRef>
+        </p:style>
+      </p:cxnSp>
+      <p:cxnSp>
+        <p:nvCxnSpPr>
+          <p:cNvPr id="141" name="Straight Arrow Connector 140">
+            <a:extLst>
+              <a:ext uri="{FF2B5EF4-FFF2-40B4-BE49-F238E27FC236}">
+                <a16:creationId xmlns:a16="http://schemas.microsoft.com/office/drawing/2014/main" id="{FF04DF65-DD77-1823-3BF8-2B7613560E5F}"/>
+              </a:ext>
+            </a:extLst>
+          </p:cNvPr>
+          <p:cNvCxnSpPr>
+            <a:cxnSpLocks/>
+            <a:stCxn id="23" idx="2"/>
+            <a:endCxn id="25" idx="0"/>
+          </p:cNvCxnSpPr>
+          <p:nvPr/>
+        </p:nvCxnSpPr>
+        <p:spPr>
+          <a:xfrm>
+            <a:off x="8684282" y="2530658"/>
+            <a:ext cx="0" cy="1705093"/>
+          </a:xfrm>
+          <a:prstGeom prst="straightConnector1">
+            <a:avLst/>
+          </a:prstGeom>
+          <a:ln w="12700">
+            <a:solidFill>
+              <a:schemeClr val="tx1"/>
+            </a:solidFill>
+            <a:headEnd type="none" w="med" len="med"/>
+            <a:tailEnd type="arrow" w="med" len="med"/>
+          </a:ln>
+        </p:spPr>
+        <p:style>
+          <a:lnRef idx="2">
+            <a:schemeClr val="accent1"/>
+          </a:lnRef>
+          <a:fillRef idx="0">
+            <a:schemeClr val="accent1"/>
+          </a:fillRef>
+          <a:effectRef idx="1">
+            <a:schemeClr val="accent1"/>
+          </a:effectRef>
+          <a:fontRef idx="minor">
+            <a:schemeClr val="tx1"/>
+          </a:fontRef>
+        </p:style>
+      </p:cxnSp>
+      <p:grpSp>
+        <p:nvGrpSpPr>
+          <p:cNvPr id="42" name="Group 41">
+            <a:extLst>
+              <a:ext uri="{FF2B5EF4-FFF2-40B4-BE49-F238E27FC236}">
+                <a16:creationId xmlns:a16="http://schemas.microsoft.com/office/drawing/2014/main" id="{7BADF578-7882-1F46-F116-4405EFF17DBE}"/>
+              </a:ext>
+            </a:extLst>
+          </p:cNvPr>
+          <p:cNvGrpSpPr/>
+          <p:nvPr/>
+        </p:nvGrpSpPr>
+        <p:grpSpPr>
+          <a:xfrm>
+            <a:off x="545110" y="2943116"/>
+            <a:ext cx="2900856" cy="867542"/>
+            <a:chOff x="777764" y="2661745"/>
+            <a:chExt cx="2900856" cy="867542"/>
+          </a:xfrm>
+        </p:grpSpPr>
+        <p:sp>
+          <p:nvSpPr>
+            <p:cNvPr id="16" name="Rounded Rectangle 15">
+              <a:extLst>
+                <a:ext uri="{FF2B5EF4-FFF2-40B4-BE49-F238E27FC236}">
+                  <a16:creationId xmlns:a16="http://schemas.microsoft.com/office/drawing/2014/main" id="{400D2ED9-E931-A7C0-8C59-F74CD9E2B0CF}"/>
+                </a:ext>
+              </a:extLst>
+            </p:cNvPr>
+            <p:cNvSpPr/>
+            <p:nvPr/>
+          </p:nvSpPr>
+          <p:spPr>
+            <a:xfrm>
+              <a:off x="777764" y="2661745"/>
+              <a:ext cx="2900856" cy="867542"/>
+            </a:xfrm>
+            <a:prstGeom prst="roundRect">
+              <a:avLst/>
+            </a:prstGeom>
+            <a:solidFill>
+              <a:schemeClr val="bg2">
+                <a:lumMod val="90000"/>
+              </a:schemeClr>
+            </a:solidFill>
+            <a:ln w="12700">
+              <a:solidFill>
+                <a:schemeClr val="tx1"/>
+              </a:solidFill>
+            </a:ln>
+          </p:spPr>
+          <p:style>
+            <a:lnRef idx="2">
+              <a:schemeClr val="accent1">
+                <a:shade val="15000"/>
+              </a:schemeClr>
+            </a:lnRef>
+            <a:fillRef idx="1">
+              <a:schemeClr val="accent1"/>
+            </a:fillRef>
+            <a:effectRef idx="0">
+              <a:schemeClr val="accent1"/>
+            </a:effectRef>
+            <a:fontRef idx="minor">
+              <a:schemeClr val="lt1"/>
+            </a:fontRef>
+          </p:style>
+          <p:txBody>
+            <a:bodyPr rtlCol="0" anchor="t"/>
+            <a:lstStyle/>
+            <a:p>
+              <a:pPr algn="ctr">
+                <a:lnSpc>
+                  <a:spcPts val="600"/>
+                </a:lnSpc>
+              </a:pPr>
+              <a:endParaRPr lang="en-US" sz="1400" dirty="0">
+                <a:solidFill>
+                  <a:schemeClr val="tx1"/>
+                </a:solidFill>
+                <a:latin typeface="Arial" panose="020B0604020202020204" pitchFamily="34" charset="0"/>
+                <a:cs typeface="Arial" panose="020B0604020202020204" pitchFamily="34" charset="0"/>
+              </a:endParaRPr>
+            </a:p>
+            <a:p>
+              <a:pPr algn="ctr">
+                <a:lnSpc>
+                  <a:spcPts val="600"/>
+                </a:lnSpc>
+              </a:pPr>
+              <a:endParaRPr lang="en-US" sz="1400" dirty="0">
+                <a:solidFill>
+                  <a:schemeClr val="tx1"/>
+                </a:solidFill>
+                <a:latin typeface="Arial" panose="020B0604020202020204" pitchFamily="34" charset="0"/>
+                <a:cs typeface="Arial" panose="020B0604020202020204" pitchFamily="34" charset="0"/>
+              </a:endParaRPr>
+            </a:p>
+            <a:p>
+              <a:pPr algn="ctr">
+                <a:lnSpc>
+                  <a:spcPts val="600"/>
+                </a:lnSpc>
+              </a:pPr>
+              <a:r>
+                <a:rPr lang="en-US" sz="1400" dirty="0">
+                  <a:solidFill>
+                    <a:schemeClr val="tx1"/>
+                  </a:solidFill>
+                  <a:latin typeface="Arial" panose="020B0604020202020204" pitchFamily="34" charset="0"/>
+                  <a:cs typeface="Arial" panose="020B0604020202020204" pitchFamily="34" charset="0"/>
+                </a:rPr>
+                <a:t>Discrepancy parameterization</a:t>
+              </a:r>
+            </a:p>
+          </p:txBody>
+        </p:sp>
+        <p:pic>
+          <p:nvPicPr>
+            <p:cNvPr id="29" name="Picture 28">
+              <a:extLst>
+                <a:ext uri="{FF2B5EF4-FFF2-40B4-BE49-F238E27FC236}">
+                  <a16:creationId xmlns:a16="http://schemas.microsoft.com/office/drawing/2014/main" id="{0BC34141-DAB0-9FE8-431A-25286310D3E2}"/>
+                </a:ext>
+              </a:extLst>
+            </p:cNvPr>
+            <p:cNvPicPr>
+              <a:picLocks noChangeAspect="1"/>
+            </p:cNvPicPr>
+            <p:nvPr/>
+          </p:nvPicPr>
+          <p:blipFill>
+            <a:blip r:embed="rId2"/>
+            <a:stretch>
+              <a:fillRect/>
+            </a:stretch>
+          </p:blipFill>
+          <p:spPr>
+            <a:xfrm>
+              <a:off x="932792" y="3068271"/>
+              <a:ext cx="2590800" cy="330200"/>
+            </a:xfrm>
+            <a:prstGeom prst="rect">
+              <a:avLst/>
+            </a:prstGeom>
+          </p:spPr>
+        </p:pic>
+      </p:grpSp>
+      <p:grpSp>
+        <p:nvGrpSpPr>
+          <p:cNvPr id="43" name="Group 42">
+            <a:extLst>
+              <a:ext uri="{FF2B5EF4-FFF2-40B4-BE49-F238E27FC236}">
+                <a16:creationId xmlns:a16="http://schemas.microsoft.com/office/drawing/2014/main" id="{0D453389-C456-B54A-F082-F56B6616A553}"/>
+              </a:ext>
+            </a:extLst>
+          </p:cNvPr>
+          <p:cNvGrpSpPr/>
+          <p:nvPr/>
+        </p:nvGrpSpPr>
+        <p:grpSpPr>
+          <a:xfrm>
+            <a:off x="545110" y="4235751"/>
+            <a:ext cx="2900856" cy="867542"/>
+            <a:chOff x="777764" y="3656070"/>
+            <a:chExt cx="2900856" cy="867542"/>
+          </a:xfrm>
+        </p:grpSpPr>
+        <p:sp>
+          <p:nvSpPr>
+            <p:cNvPr id="18" name="Rounded Rectangle 17">
+              <a:extLst>
+                <a:ext uri="{FF2B5EF4-FFF2-40B4-BE49-F238E27FC236}">
+                  <a16:creationId xmlns:a16="http://schemas.microsoft.com/office/drawing/2014/main" id="{80AF853C-247B-BFFB-329C-211958BC122B}"/>
+                </a:ext>
+              </a:extLst>
+            </p:cNvPr>
+            <p:cNvSpPr/>
+            <p:nvPr/>
+          </p:nvSpPr>
+          <p:spPr>
+            <a:xfrm>
+              <a:off x="777764" y="3656070"/>
+              <a:ext cx="2900856" cy="867542"/>
+            </a:xfrm>
+            <a:prstGeom prst="roundRect">
+              <a:avLst/>
+            </a:prstGeom>
+            <a:solidFill>
+              <a:schemeClr val="bg1"/>
+            </a:solidFill>
+            <a:ln w="12700">
+              <a:solidFill>
+                <a:schemeClr val="tx1"/>
+              </a:solidFill>
+            </a:ln>
+          </p:spPr>
+          <p:style>
+            <a:lnRef idx="2">
+              <a:schemeClr val="accent1">
+                <a:shade val="15000"/>
+              </a:schemeClr>
+            </a:lnRef>
+            <a:fillRef idx="1">
+              <a:schemeClr val="accent1"/>
+            </a:fillRef>
+            <a:effectRef idx="0">
+              <a:schemeClr val="accent1"/>
+            </a:effectRef>
+            <a:fontRef idx="minor">
+              <a:schemeClr val="lt1"/>
+            </a:fontRef>
+          </p:style>
+          <p:txBody>
+            <a:bodyPr rtlCol="0" anchor="t"/>
+            <a:lstStyle/>
+            <a:p>
+              <a:pPr algn="ctr">
+                <a:lnSpc>
+                  <a:spcPts val="600"/>
+                </a:lnSpc>
+              </a:pPr>
+              <a:endParaRPr lang="en-US" sz="1400" dirty="0">
+                <a:solidFill>
+                  <a:schemeClr val="tx1"/>
+                </a:solidFill>
+                <a:latin typeface="Arial" panose="020B0604020202020204" pitchFamily="34" charset="0"/>
+                <a:cs typeface="Arial" panose="020B0604020202020204" pitchFamily="34" charset="0"/>
+              </a:endParaRPr>
+            </a:p>
+            <a:p>
+              <a:pPr algn="ctr">
+                <a:lnSpc>
+                  <a:spcPts val="600"/>
+                </a:lnSpc>
+              </a:pPr>
+              <a:endParaRPr lang="en-US" sz="1400" dirty="0">
+                <a:solidFill>
+                  <a:schemeClr val="tx1"/>
+                </a:solidFill>
+                <a:latin typeface="Arial" panose="020B0604020202020204" pitchFamily="34" charset="0"/>
+                <a:cs typeface="Arial" panose="020B0604020202020204" pitchFamily="34" charset="0"/>
+              </a:endParaRPr>
+            </a:p>
+            <a:p>
+              <a:pPr algn="ctr">
+                <a:lnSpc>
+                  <a:spcPts val="600"/>
+                </a:lnSpc>
+              </a:pPr>
+              <a:r>
+                <a:rPr lang="en-US" sz="1400" dirty="0">
+                  <a:solidFill>
+                    <a:schemeClr val="tx1"/>
+                  </a:solidFill>
+                  <a:latin typeface="Arial" panose="020B0604020202020204" pitchFamily="34" charset="0"/>
+                  <a:cs typeface="Arial" panose="020B0604020202020204" pitchFamily="34" charset="0"/>
+                </a:rPr>
+                <a:t>Discrepancy noise model</a:t>
+              </a:r>
+            </a:p>
+          </p:txBody>
+        </p:sp>
+        <p:pic>
+          <p:nvPicPr>
+            <p:cNvPr id="30" name="Picture 29">
+              <a:extLst>
+                <a:ext uri="{FF2B5EF4-FFF2-40B4-BE49-F238E27FC236}">
+                  <a16:creationId xmlns:a16="http://schemas.microsoft.com/office/drawing/2014/main" id="{F2416ECB-ECAD-AC6A-1FA6-76B95C9C9A3F}"/>
+                </a:ext>
+              </a:extLst>
+            </p:cNvPr>
+            <p:cNvPicPr>
+              <a:picLocks noChangeAspect="1"/>
+            </p:cNvPicPr>
+            <p:nvPr/>
+          </p:nvPicPr>
+          <p:blipFill>
+            <a:blip r:embed="rId3"/>
+            <a:stretch>
+              <a:fillRect/>
+            </a:stretch>
+          </p:blipFill>
+          <p:spPr>
+            <a:xfrm>
+              <a:off x="1205842" y="4115241"/>
+              <a:ext cx="2044700" cy="215900"/>
+            </a:xfrm>
+            <a:prstGeom prst="rect">
+              <a:avLst/>
+            </a:prstGeom>
+          </p:spPr>
+        </p:pic>
+      </p:grpSp>
+      <p:sp>
+        <p:nvSpPr>
+          <p:cNvPr id="2" name="Rounded Rectangle 1">
+            <a:extLst>
+              <a:ext uri="{FF2B5EF4-FFF2-40B4-BE49-F238E27FC236}">
+                <a16:creationId xmlns:a16="http://schemas.microsoft.com/office/drawing/2014/main" id="{1C4FABC6-2DFC-8A9F-3936-DBCBAA15B58A}"/>
+              </a:ext>
+            </a:extLst>
+          </p:cNvPr>
+          <p:cNvSpPr/>
+          <p:nvPr/>
+        </p:nvSpPr>
+        <p:spPr>
+          <a:xfrm>
+            <a:off x="545110" y="1667420"/>
+            <a:ext cx="2900856" cy="867542"/>
+          </a:xfrm>
+          <a:prstGeom prst="roundRect">
+            <a:avLst/>
+          </a:prstGeom>
+          <a:solidFill>
+            <a:srgbClr val="6CFFE4"/>
+          </a:solidFill>
+          <a:ln w="12700">
+            <a:solidFill>
+              <a:schemeClr val="tx1"/>
+            </a:solidFill>
+          </a:ln>
+        </p:spPr>
+        <p:style>
+          <a:lnRef idx="2">
+            <a:schemeClr val="accent1">
+              <a:shade val="15000"/>
+            </a:schemeClr>
+          </a:lnRef>
+          <a:fillRef idx="1">
+            <a:schemeClr val="accent1"/>
+          </a:fillRef>
+          <a:effectRef idx="0">
+            <a:schemeClr val="accent1"/>
+          </a:effectRef>
+          <a:fontRef idx="minor">
+            <a:schemeClr val="lt1"/>
+          </a:fontRef>
+        </p:style>
+        <p:txBody>
+          <a:bodyPr rtlCol="0" anchor="t"/>
+          <a:lstStyle/>
+          <a:p>
+            <a:pPr algn="ctr">
+              <a:lnSpc>
+                <a:spcPts val="600"/>
+              </a:lnSpc>
+            </a:pPr>
+            <a:endParaRPr lang="en-US" sz="1400" dirty="0">
+              <a:solidFill>
+                <a:schemeClr val="tx1"/>
+              </a:solidFill>
+              <a:latin typeface="Arial" panose="020B0604020202020204" pitchFamily="34" charset="0"/>
+              <a:cs typeface="Arial" panose="020B0604020202020204" pitchFamily="34" charset="0"/>
+            </a:endParaRPr>
+          </a:p>
+          <a:p>
+            <a:pPr algn="ctr">
+              <a:lnSpc>
+                <a:spcPts val="600"/>
+              </a:lnSpc>
+            </a:pPr>
+            <a:endParaRPr lang="en-US" sz="1400" dirty="0">
+              <a:solidFill>
+                <a:schemeClr val="tx1"/>
+              </a:solidFill>
+              <a:latin typeface="Arial" panose="020B0604020202020204" pitchFamily="34" charset="0"/>
+              <a:cs typeface="Arial" panose="020B0604020202020204" pitchFamily="34" charset="0"/>
+            </a:endParaRPr>
+          </a:p>
+          <a:p>
+            <a:pPr algn="ctr">
+              <a:lnSpc>
+                <a:spcPts val="600"/>
+              </a:lnSpc>
+            </a:pPr>
+            <a:r>
+              <a:rPr lang="en-US" sz="1400" dirty="0">
+                <a:solidFill>
+                  <a:schemeClr val="tx1"/>
+                </a:solidFill>
+                <a:latin typeface="Arial" panose="020B0604020202020204" pitchFamily="34" charset="0"/>
+                <a:cs typeface="Arial" panose="020B0604020202020204" pitchFamily="34" charset="0"/>
+              </a:rPr>
+              <a:t>Prior parameter distribution</a:t>
+            </a:r>
+          </a:p>
+        </p:txBody>
+      </p:sp>
+      <p:grpSp>
+        <p:nvGrpSpPr>
+          <p:cNvPr id="44" name="Group 43">
+            <a:extLst>
+              <a:ext uri="{FF2B5EF4-FFF2-40B4-BE49-F238E27FC236}">
+                <a16:creationId xmlns:a16="http://schemas.microsoft.com/office/drawing/2014/main" id="{8139EF72-C653-96E9-BBDA-A2733AA5D894}"/>
+              </a:ext>
+            </a:extLst>
+          </p:cNvPr>
+          <p:cNvGrpSpPr/>
+          <p:nvPr/>
+        </p:nvGrpSpPr>
+        <p:grpSpPr>
+          <a:xfrm>
+            <a:off x="3889482" y="4235751"/>
+            <a:ext cx="2900856" cy="867542"/>
+            <a:chOff x="4307270" y="2661745"/>
+            <a:chExt cx="2900856" cy="867542"/>
+          </a:xfrm>
+        </p:grpSpPr>
+        <p:sp>
+          <p:nvSpPr>
+            <p:cNvPr id="20" name="Rounded Rectangle 19">
+              <a:extLst>
+                <a:ext uri="{FF2B5EF4-FFF2-40B4-BE49-F238E27FC236}">
+                  <a16:creationId xmlns:a16="http://schemas.microsoft.com/office/drawing/2014/main" id="{88185720-F720-3022-9C7E-4652ED3A8108}"/>
+                </a:ext>
+              </a:extLst>
+            </p:cNvPr>
+            <p:cNvSpPr/>
+            <p:nvPr/>
+          </p:nvSpPr>
+          <p:spPr>
+            <a:xfrm>
+              <a:off x="4307270" y="2661745"/>
+              <a:ext cx="2900856" cy="867542"/>
+            </a:xfrm>
+            <a:prstGeom prst="roundRect">
+              <a:avLst/>
+            </a:prstGeom>
+            <a:solidFill>
+              <a:srgbClr val="6CFFE4"/>
+            </a:solidFill>
+            <a:ln w="12700">
+              <a:solidFill>
+                <a:schemeClr val="tx1"/>
+              </a:solidFill>
+            </a:ln>
+          </p:spPr>
+          <p:style>
+            <a:lnRef idx="2">
+              <a:schemeClr val="accent1">
+                <a:shade val="15000"/>
+              </a:schemeClr>
+            </a:lnRef>
+            <a:fillRef idx="1">
+              <a:schemeClr val="accent1"/>
+            </a:fillRef>
+            <a:effectRef idx="0">
+              <a:schemeClr val="accent1"/>
+            </a:effectRef>
+            <a:fontRef idx="minor">
+              <a:schemeClr val="lt1"/>
+            </a:fontRef>
+          </p:style>
+          <p:txBody>
+            <a:bodyPr rtlCol="0" anchor="t"/>
+            <a:lstStyle/>
+            <a:p>
+              <a:pPr algn="ctr"/>
+              <a:r>
+                <a:rPr lang="en-US" sz="1400" dirty="0">
+                  <a:solidFill>
+                    <a:schemeClr val="tx1"/>
+                  </a:solidFill>
+                  <a:latin typeface="Arial" panose="020B0604020202020204" pitchFamily="34" charset="0"/>
+                  <a:cs typeface="Arial" panose="020B0604020202020204" pitchFamily="34" charset="0"/>
+                </a:rPr>
+                <a:t>Discrepancy calibration</a:t>
+              </a:r>
+            </a:p>
+            <a:p>
+              <a:pPr algn="ctr"/>
+              <a:r>
+                <a:rPr lang="en-US" sz="1400" dirty="0">
+                  <a:solidFill>
+                    <a:schemeClr val="tx1"/>
+                  </a:solidFill>
+                  <a:latin typeface="Arial" panose="020B0604020202020204" pitchFamily="34" charset="0"/>
+                  <a:cs typeface="Arial" panose="020B0604020202020204" pitchFamily="34" charset="0"/>
+                </a:rPr>
+                <a:t>(Bayesian linear regression)</a:t>
+              </a:r>
+            </a:p>
+          </p:txBody>
+        </p:sp>
+        <p:pic>
+          <p:nvPicPr>
+            <p:cNvPr id="32" name="Picture 31">
+              <a:extLst>
+                <a:ext uri="{FF2B5EF4-FFF2-40B4-BE49-F238E27FC236}">
+                  <a16:creationId xmlns:a16="http://schemas.microsoft.com/office/drawing/2014/main" id="{F81002B0-EC80-3F49-E3D5-6B458F77A6B4}"/>
+                </a:ext>
+              </a:extLst>
+            </p:cNvPr>
+            <p:cNvPicPr>
+              <a:picLocks noChangeAspect="1"/>
+            </p:cNvPicPr>
+            <p:nvPr/>
+          </p:nvPicPr>
+          <p:blipFill>
+            <a:blip r:embed="rId4"/>
+            <a:stretch>
+              <a:fillRect/>
+            </a:stretch>
+          </p:blipFill>
+          <p:spPr>
+            <a:xfrm>
+              <a:off x="4951248" y="3231056"/>
+              <a:ext cx="1612900" cy="203200"/>
+            </a:xfrm>
+            <a:prstGeom prst="rect">
+              <a:avLst/>
+            </a:prstGeom>
+          </p:spPr>
+        </p:pic>
+      </p:grpSp>
+      <p:grpSp>
+        <p:nvGrpSpPr>
+          <p:cNvPr id="45" name="Group 44">
+            <a:extLst>
+              <a:ext uri="{FF2B5EF4-FFF2-40B4-BE49-F238E27FC236}">
+                <a16:creationId xmlns:a16="http://schemas.microsoft.com/office/drawing/2014/main" id="{68A6B4D8-6C2E-0CD4-6725-A9371967256B}"/>
+              </a:ext>
+            </a:extLst>
+          </p:cNvPr>
+          <p:cNvGrpSpPr/>
+          <p:nvPr/>
+        </p:nvGrpSpPr>
+        <p:grpSpPr>
+          <a:xfrm>
+            <a:off x="7233854" y="1663116"/>
+            <a:ext cx="2900856" cy="867542"/>
+            <a:chOff x="8513380" y="890750"/>
+            <a:chExt cx="2900856" cy="867542"/>
+          </a:xfrm>
+        </p:grpSpPr>
+        <p:sp>
+          <p:nvSpPr>
+            <p:cNvPr id="23" name="Rounded Rectangle 22">
+              <a:extLst>
+                <a:ext uri="{FF2B5EF4-FFF2-40B4-BE49-F238E27FC236}">
+                  <a16:creationId xmlns:a16="http://schemas.microsoft.com/office/drawing/2014/main" id="{8783946E-4D1F-3375-F99A-086CB7C89EAD}"/>
+                </a:ext>
+              </a:extLst>
+            </p:cNvPr>
+            <p:cNvSpPr/>
+            <p:nvPr/>
+          </p:nvSpPr>
+          <p:spPr>
+            <a:xfrm>
+              <a:off x="8513380" y="890750"/>
+              <a:ext cx="2900856" cy="867542"/>
+            </a:xfrm>
+            <a:prstGeom prst="roundRect">
+              <a:avLst/>
+            </a:prstGeom>
+            <a:solidFill>
+              <a:schemeClr val="bg2">
+                <a:lumMod val="90000"/>
+              </a:schemeClr>
+            </a:solidFill>
+            <a:ln w="12700">
+              <a:solidFill>
+                <a:schemeClr val="tx1"/>
+              </a:solidFill>
+            </a:ln>
+          </p:spPr>
+          <p:style>
+            <a:lnRef idx="2">
+              <a:schemeClr val="accent1">
+                <a:shade val="15000"/>
+              </a:schemeClr>
+            </a:lnRef>
+            <a:fillRef idx="1">
+              <a:schemeClr val="accent1"/>
+            </a:fillRef>
+            <a:effectRef idx="0">
+              <a:schemeClr val="accent1"/>
+            </a:effectRef>
+            <a:fontRef idx="minor">
+              <a:schemeClr val="lt1"/>
+            </a:fontRef>
+          </p:style>
+          <p:txBody>
+            <a:bodyPr rtlCol="0" anchor="t"/>
+            <a:lstStyle/>
+            <a:p>
+              <a:pPr algn="ctr"/>
+              <a:r>
+                <a:rPr lang="en-US" sz="1400" dirty="0">
+                  <a:solidFill>
+                    <a:schemeClr val="tx1"/>
+                  </a:solidFill>
+                  <a:latin typeface="Arial" panose="020B0604020202020204" pitchFamily="34" charset="0"/>
+                  <a:cs typeface="Arial" panose="020B0604020202020204" pitchFamily="34" charset="0"/>
+                </a:rPr>
+                <a:t>Solution to surrogate-constrained optimization problem</a:t>
+              </a:r>
+            </a:p>
+          </p:txBody>
+        </p:sp>
+        <p:pic>
+          <p:nvPicPr>
+            <p:cNvPr id="34" name="Picture 33">
+              <a:extLst>
+                <a:ext uri="{FF2B5EF4-FFF2-40B4-BE49-F238E27FC236}">
+                  <a16:creationId xmlns:a16="http://schemas.microsoft.com/office/drawing/2014/main" id="{AFF7456F-24F1-B86E-8CB5-B126B2ED0C64}"/>
+                </a:ext>
+              </a:extLst>
+            </p:cNvPr>
+            <p:cNvPicPr>
+              <a:picLocks noChangeAspect="1"/>
+            </p:cNvPicPr>
+            <p:nvPr/>
+          </p:nvPicPr>
+          <p:blipFill>
+            <a:blip r:embed="rId5"/>
+            <a:stretch>
+              <a:fillRect/>
+            </a:stretch>
+          </p:blipFill>
+          <p:spPr>
+            <a:xfrm>
+              <a:off x="9722508" y="1480199"/>
+              <a:ext cx="482600" cy="190500"/>
+            </a:xfrm>
+            <a:prstGeom prst="rect">
+              <a:avLst/>
+            </a:prstGeom>
+          </p:spPr>
+        </p:pic>
+      </p:grpSp>
+      <p:grpSp>
+        <p:nvGrpSpPr>
+          <p:cNvPr id="60" name="Group 59">
+            <a:extLst>
+              <a:ext uri="{FF2B5EF4-FFF2-40B4-BE49-F238E27FC236}">
+                <a16:creationId xmlns:a16="http://schemas.microsoft.com/office/drawing/2014/main" id="{470BBDD5-747D-4F96-75D3-BCB2CB003B18}"/>
+              </a:ext>
+            </a:extLst>
+          </p:cNvPr>
+          <p:cNvGrpSpPr/>
+          <p:nvPr/>
+        </p:nvGrpSpPr>
+        <p:grpSpPr>
+          <a:xfrm>
+            <a:off x="7233854" y="4235751"/>
+            <a:ext cx="2900856" cy="867542"/>
+            <a:chOff x="8479791" y="3656070"/>
+            <a:chExt cx="2900856" cy="867542"/>
+          </a:xfrm>
+          <a:solidFill>
+            <a:schemeClr val="bg1"/>
+          </a:solidFill>
+        </p:grpSpPr>
+        <p:sp>
+          <p:nvSpPr>
+            <p:cNvPr id="25" name="Rounded Rectangle 24">
+              <a:extLst>
+                <a:ext uri="{FF2B5EF4-FFF2-40B4-BE49-F238E27FC236}">
+                  <a16:creationId xmlns:a16="http://schemas.microsoft.com/office/drawing/2014/main" id="{ED7EE263-C79A-A267-C699-FB74FB47F8E3}"/>
+                </a:ext>
+              </a:extLst>
+            </p:cNvPr>
+            <p:cNvSpPr/>
+            <p:nvPr/>
+          </p:nvSpPr>
+          <p:spPr>
+            <a:xfrm>
+              <a:off x="8479791" y="3656070"/>
+              <a:ext cx="2900856" cy="867542"/>
+            </a:xfrm>
+            <a:prstGeom prst="roundRect">
+              <a:avLst>
+                <a:gd name="adj" fmla="val 0"/>
+              </a:avLst>
+            </a:prstGeom>
+            <a:solidFill>
+              <a:srgbClr val="FF9A77"/>
+            </a:solidFill>
+            <a:ln w="28575">
+              <a:solidFill>
+                <a:schemeClr val="tx1"/>
+              </a:solidFill>
+            </a:ln>
+          </p:spPr>
+          <p:style>
+            <a:lnRef idx="2">
+              <a:schemeClr val="accent1">
+                <a:shade val="15000"/>
+              </a:schemeClr>
+            </a:lnRef>
+            <a:fillRef idx="1">
+              <a:schemeClr val="accent1"/>
+            </a:fillRef>
+            <a:effectRef idx="0">
+              <a:schemeClr val="accent1"/>
+            </a:effectRef>
+            <a:fontRef idx="minor">
+              <a:schemeClr val="lt1"/>
+            </a:fontRef>
+          </p:style>
+          <p:txBody>
+            <a:bodyPr rtlCol="0" anchor="t"/>
+            <a:lstStyle/>
+            <a:p>
+              <a:pPr algn="ctr">
+                <a:lnSpc>
+                  <a:spcPts val="600"/>
+                </a:lnSpc>
+              </a:pPr>
+              <a:endParaRPr lang="en-US" sz="1400" dirty="0">
+                <a:solidFill>
+                  <a:schemeClr val="tx1"/>
+                </a:solidFill>
+                <a:latin typeface="Arial" panose="020B0604020202020204" pitchFamily="34" charset="0"/>
+                <a:cs typeface="Arial" panose="020B0604020202020204" pitchFamily="34" charset="0"/>
+              </a:endParaRPr>
+            </a:p>
+            <a:p>
+              <a:pPr algn="ctr">
+                <a:lnSpc>
+                  <a:spcPts val="600"/>
+                </a:lnSpc>
+              </a:pPr>
+              <a:endParaRPr lang="en-US" sz="1400" dirty="0">
+                <a:solidFill>
+                  <a:schemeClr val="tx1"/>
+                </a:solidFill>
+                <a:latin typeface="Arial" panose="020B0604020202020204" pitchFamily="34" charset="0"/>
+                <a:cs typeface="Arial" panose="020B0604020202020204" pitchFamily="34" charset="0"/>
+              </a:endParaRPr>
+            </a:p>
+            <a:p>
+              <a:pPr algn="ctr">
+                <a:lnSpc>
+                  <a:spcPts val="600"/>
+                </a:lnSpc>
+              </a:pPr>
+              <a:endParaRPr lang="en-US" sz="1400" dirty="0">
+                <a:solidFill>
+                  <a:schemeClr val="tx1"/>
+                </a:solidFill>
+                <a:latin typeface="Arial" panose="020B0604020202020204" pitchFamily="34" charset="0"/>
+                <a:cs typeface="Arial" panose="020B0604020202020204" pitchFamily="34" charset="0"/>
+              </a:endParaRPr>
+            </a:p>
+            <a:p>
+              <a:pPr algn="ctr">
+                <a:lnSpc>
+                  <a:spcPts val="600"/>
+                </a:lnSpc>
+              </a:pPr>
+              <a:r>
+                <a:rPr lang="en-US" sz="1400" dirty="0">
+                  <a:solidFill>
+                    <a:schemeClr val="tx1"/>
+                  </a:solidFill>
+                  <a:latin typeface="Arial" panose="020B0604020202020204" pitchFamily="34" charset="0"/>
+                  <a:cs typeface="Arial" panose="020B0604020202020204" pitchFamily="34" charset="0"/>
+                </a:rPr>
+                <a:t>Post-optimality sensitivity update</a:t>
+              </a:r>
+            </a:p>
+          </p:txBody>
+        </p:sp>
+        <p:pic>
+          <p:nvPicPr>
+            <p:cNvPr id="36" name="Picture 35">
+              <a:extLst>
+                <a:ext uri="{FF2B5EF4-FFF2-40B4-BE49-F238E27FC236}">
+                  <a16:creationId xmlns:a16="http://schemas.microsoft.com/office/drawing/2014/main" id="{C544E5C9-B31A-5696-6383-EFB6DB64C815}"/>
+                </a:ext>
+              </a:extLst>
+            </p:cNvPr>
+            <p:cNvPicPr>
+              <a:picLocks noChangeAspect="1"/>
+            </p:cNvPicPr>
+            <p:nvPr/>
+          </p:nvPicPr>
+          <p:blipFill>
+            <a:blip r:embed="rId6"/>
+            <a:stretch>
+              <a:fillRect/>
+            </a:stretch>
+          </p:blipFill>
+          <p:spPr>
+            <a:xfrm>
+              <a:off x="9297058" y="4115241"/>
+              <a:ext cx="1333500" cy="165100"/>
+            </a:xfrm>
+            <a:prstGeom prst="rect">
+              <a:avLst/>
+            </a:prstGeom>
+            <a:noFill/>
+          </p:spPr>
+        </p:pic>
+      </p:grpSp>
+      <p:grpSp>
+        <p:nvGrpSpPr>
+          <p:cNvPr id="46" name="Group 45">
+            <a:extLst>
+              <a:ext uri="{FF2B5EF4-FFF2-40B4-BE49-F238E27FC236}">
+                <a16:creationId xmlns:a16="http://schemas.microsoft.com/office/drawing/2014/main" id="{CFD74464-9EA9-2E40-A0D5-B9F74B5702BC}"/>
+              </a:ext>
+            </a:extLst>
+          </p:cNvPr>
+          <p:cNvGrpSpPr/>
+          <p:nvPr/>
+        </p:nvGrpSpPr>
+        <p:grpSpPr>
+          <a:xfrm>
+            <a:off x="7233854" y="2943116"/>
+            <a:ext cx="2900856" cy="867542"/>
+            <a:chOff x="8513380" y="4248531"/>
+            <a:chExt cx="2900856" cy="867542"/>
+          </a:xfrm>
+        </p:grpSpPr>
+        <p:sp>
+          <p:nvSpPr>
+            <p:cNvPr id="26" name="Rounded Rectangle 25">
+              <a:extLst>
+                <a:ext uri="{FF2B5EF4-FFF2-40B4-BE49-F238E27FC236}">
+                  <a16:creationId xmlns:a16="http://schemas.microsoft.com/office/drawing/2014/main" id="{9C8DFE6C-B61D-5DA7-9727-88A6E27E57FC}"/>
+                </a:ext>
+              </a:extLst>
+            </p:cNvPr>
+            <p:cNvSpPr/>
+            <p:nvPr/>
+          </p:nvSpPr>
+          <p:spPr>
+            <a:xfrm>
+              <a:off x="8513380" y="4248531"/>
+              <a:ext cx="2900856" cy="867542"/>
+            </a:xfrm>
+            <a:prstGeom prst="roundRect">
+              <a:avLst/>
+            </a:prstGeom>
+            <a:solidFill>
+              <a:schemeClr val="bg1"/>
+            </a:solidFill>
+            <a:ln w="12700">
+              <a:solidFill>
+                <a:schemeClr val="tx1"/>
+              </a:solidFill>
+            </a:ln>
+          </p:spPr>
+          <p:style>
+            <a:lnRef idx="2">
+              <a:schemeClr val="accent1">
+                <a:shade val="15000"/>
+              </a:schemeClr>
+            </a:lnRef>
+            <a:fillRef idx="1">
+              <a:schemeClr val="accent1"/>
+            </a:fillRef>
+            <a:effectRef idx="0">
+              <a:schemeClr val="accent1"/>
+            </a:effectRef>
+            <a:fontRef idx="minor">
+              <a:schemeClr val="lt1"/>
+            </a:fontRef>
+          </p:style>
+          <p:txBody>
+            <a:bodyPr rtlCol="0" anchor="t"/>
+            <a:lstStyle/>
+            <a:p>
+              <a:pPr algn="ctr">
+                <a:lnSpc>
+                  <a:spcPts val="600"/>
+                </a:lnSpc>
+              </a:pPr>
+              <a:endParaRPr lang="en-US" sz="1400" dirty="0">
+                <a:solidFill>
+                  <a:schemeClr val="tx1"/>
+                </a:solidFill>
+                <a:latin typeface="Arial" panose="020B0604020202020204" pitchFamily="34" charset="0"/>
+                <a:cs typeface="Arial" panose="020B0604020202020204" pitchFamily="34" charset="0"/>
+              </a:endParaRPr>
+            </a:p>
+            <a:p>
+              <a:pPr algn="ctr">
+                <a:lnSpc>
+                  <a:spcPts val="600"/>
+                </a:lnSpc>
+              </a:pPr>
+              <a:endParaRPr lang="en-US" sz="1400" dirty="0">
+                <a:solidFill>
+                  <a:schemeClr val="tx1"/>
+                </a:solidFill>
+                <a:latin typeface="Arial" panose="020B0604020202020204" pitchFamily="34" charset="0"/>
+                <a:cs typeface="Arial" panose="020B0604020202020204" pitchFamily="34" charset="0"/>
+              </a:endParaRPr>
+            </a:p>
+            <a:p>
+              <a:pPr algn="ctr">
+                <a:lnSpc>
+                  <a:spcPts val="600"/>
+                </a:lnSpc>
+              </a:pPr>
+              <a:r>
+                <a:rPr lang="en-US" sz="1400" dirty="0">
+                  <a:solidFill>
+                    <a:schemeClr val="tx1"/>
+                  </a:solidFill>
+                  <a:latin typeface="Arial" panose="020B0604020202020204" pitchFamily="34" charset="0"/>
+                  <a:cs typeface="Arial" panose="020B0604020202020204" pitchFamily="34" charset="0"/>
+                </a:rPr>
+                <a:t>Surrogate problem derivatives</a:t>
+              </a:r>
+            </a:p>
+          </p:txBody>
+        </p:sp>
+        <p:pic>
+          <p:nvPicPr>
+            <p:cNvPr id="39" name="Picture 38">
+              <a:extLst>
+                <a:ext uri="{FF2B5EF4-FFF2-40B4-BE49-F238E27FC236}">
+                  <a16:creationId xmlns:a16="http://schemas.microsoft.com/office/drawing/2014/main" id="{D93B5133-D559-3009-378E-50C72C3384DF}"/>
+                </a:ext>
+              </a:extLst>
+            </p:cNvPr>
+            <p:cNvPicPr>
+              <a:picLocks noChangeAspect="1"/>
+            </p:cNvPicPr>
+            <p:nvPr/>
+          </p:nvPicPr>
+          <p:blipFill>
+            <a:blip r:embed="rId7"/>
+            <a:stretch>
+              <a:fillRect/>
+            </a:stretch>
+          </p:blipFill>
+          <p:spPr>
+            <a:xfrm>
+              <a:off x="8681108" y="4686466"/>
+              <a:ext cx="2565400" cy="215900"/>
+            </a:xfrm>
+            <a:prstGeom prst="rect">
+              <a:avLst/>
+            </a:prstGeom>
+          </p:spPr>
+        </p:pic>
+      </p:grpSp>
+      <p:cxnSp>
+        <p:nvCxnSpPr>
+          <p:cNvPr id="61" name="Straight Arrow Connector 60">
+            <a:extLst>
+              <a:ext uri="{FF2B5EF4-FFF2-40B4-BE49-F238E27FC236}">
+                <a16:creationId xmlns:a16="http://schemas.microsoft.com/office/drawing/2014/main" id="{9FC69269-1251-7B8E-957B-249A0D58D123}"/>
+              </a:ext>
+            </a:extLst>
+          </p:cNvPr>
+          <p:cNvCxnSpPr>
+            <a:cxnSpLocks/>
+            <a:stCxn id="20" idx="3"/>
+            <a:endCxn id="25" idx="1"/>
+          </p:cNvCxnSpPr>
+          <p:nvPr/>
+        </p:nvCxnSpPr>
+        <p:spPr>
+          <a:xfrm>
+            <a:off x="6790338" y="4669522"/>
+            <a:ext cx="443516" cy="0"/>
+          </a:xfrm>
+          <a:prstGeom prst="straightConnector1">
+            <a:avLst/>
+          </a:prstGeom>
+          <a:ln w="12700">
+            <a:solidFill>
+              <a:schemeClr val="tx1"/>
+            </a:solidFill>
+            <a:headEnd type="none" w="med" len="med"/>
+            <a:tailEnd type="arrow" w="med" len="med"/>
+          </a:ln>
+        </p:spPr>
+        <p:style>
+          <a:lnRef idx="2">
+            <a:schemeClr val="accent1"/>
+          </a:lnRef>
+          <a:fillRef idx="0">
+            <a:schemeClr val="accent1"/>
+          </a:fillRef>
+          <a:effectRef idx="1">
+            <a:schemeClr val="accent1"/>
+          </a:effectRef>
+          <a:fontRef idx="minor">
+            <a:schemeClr val="tx1"/>
+          </a:fontRef>
+        </p:style>
+      </p:cxnSp>
+      <p:cxnSp>
+        <p:nvCxnSpPr>
+          <p:cNvPr id="64" name="Straight Arrow Connector 63">
+            <a:extLst>
+              <a:ext uri="{FF2B5EF4-FFF2-40B4-BE49-F238E27FC236}">
+                <a16:creationId xmlns:a16="http://schemas.microsoft.com/office/drawing/2014/main" id="{A3CD1409-F4E6-6A1B-808B-84366072F8B4}"/>
+              </a:ext>
+            </a:extLst>
+          </p:cNvPr>
+          <p:cNvCxnSpPr>
+            <a:cxnSpLocks/>
+            <a:stCxn id="22" idx="2"/>
+            <a:endCxn id="20" idx="0"/>
+          </p:cNvCxnSpPr>
+          <p:nvPr/>
+        </p:nvCxnSpPr>
+        <p:spPr>
+          <a:xfrm>
+            <a:off x="5339910" y="2530658"/>
+            <a:ext cx="0" cy="1705093"/>
+          </a:xfrm>
+          <a:prstGeom prst="straightConnector1">
+            <a:avLst/>
+          </a:prstGeom>
+          <a:ln w="12700">
+            <a:solidFill>
+              <a:schemeClr val="tx1"/>
+            </a:solidFill>
+            <a:headEnd type="none" w="med" len="med"/>
+            <a:tailEnd type="arrow" w="med" len="med"/>
+          </a:ln>
+        </p:spPr>
+        <p:style>
+          <a:lnRef idx="2">
+            <a:schemeClr val="accent1"/>
+          </a:lnRef>
+          <a:fillRef idx="0">
+            <a:schemeClr val="accent1"/>
+          </a:fillRef>
+          <a:effectRef idx="1">
+            <a:schemeClr val="accent1"/>
+          </a:effectRef>
+          <a:fontRef idx="minor">
+            <a:schemeClr val="tx1"/>
+          </a:fontRef>
+        </p:style>
+      </p:cxnSp>
+      <p:sp>
+        <p:nvSpPr>
+          <p:cNvPr id="119" name="TextBox 118">
+            <a:extLst>
+              <a:ext uri="{FF2B5EF4-FFF2-40B4-BE49-F238E27FC236}">
+                <a16:creationId xmlns:a16="http://schemas.microsoft.com/office/drawing/2014/main" id="{A069FCD7-021D-38E8-0B48-ACB230AE1F93}"/>
+              </a:ext>
+            </a:extLst>
+          </p:cNvPr>
+          <p:cNvSpPr txBox="1"/>
+          <p:nvPr/>
+        </p:nvSpPr>
+        <p:spPr>
+          <a:xfrm>
+            <a:off x="700138" y="1203306"/>
+            <a:ext cx="2596801" cy="307777"/>
+          </a:xfrm>
+          <a:prstGeom prst="rect">
+            <a:avLst/>
+          </a:prstGeom>
+          <a:noFill/>
+        </p:spPr>
+        <p:txBody>
+          <a:bodyPr wrap="none" rtlCol="0">
+            <a:spAutoFit/>
+          </a:bodyPr>
+          <a:lstStyle/>
+          <a:p>
+            <a:r>
+              <a:rPr lang="en-US" sz="1400" i="1" dirty="0">
+                <a:latin typeface="Arial" panose="020B0604020202020204" pitchFamily="34" charset="0"/>
+                <a:cs typeface="Arial" panose="020B0604020202020204" pitchFamily="34" charset="0"/>
+              </a:rPr>
+              <a:t>Model discrepancy formulation</a:t>
+            </a:r>
+          </a:p>
+        </p:txBody>
+      </p:sp>
+      <p:sp>
+        <p:nvSpPr>
+          <p:cNvPr id="120" name="TextBox 119">
+            <a:extLst>
+              <a:ext uri="{FF2B5EF4-FFF2-40B4-BE49-F238E27FC236}">
+                <a16:creationId xmlns:a16="http://schemas.microsoft.com/office/drawing/2014/main" id="{7F56BF0D-3878-C025-1AE1-50E5D6AE34F7}"/>
+              </a:ext>
+            </a:extLst>
+          </p:cNvPr>
+          <p:cNvSpPr txBox="1"/>
+          <p:nvPr/>
+        </p:nvSpPr>
+        <p:spPr>
+          <a:xfrm>
+            <a:off x="5400994" y="1203306"/>
+            <a:ext cx="3376245" cy="307777"/>
+          </a:xfrm>
+          <a:prstGeom prst="rect">
+            <a:avLst/>
+          </a:prstGeom>
+          <a:noFill/>
+        </p:spPr>
+        <p:txBody>
+          <a:bodyPr wrap="none" rtlCol="0">
+            <a:spAutoFit/>
+          </a:bodyPr>
+          <a:lstStyle/>
+          <a:p>
+            <a:pPr algn="ctr"/>
+            <a:r>
+              <a:rPr lang="en-US" sz="1400" i="1" dirty="0">
+                <a:solidFill>
+                  <a:schemeClr val="accent4"/>
+                </a:solidFill>
+                <a:latin typeface="Arial" panose="020B0604020202020204" pitchFamily="34" charset="0"/>
+                <a:cs typeface="Arial" panose="020B0604020202020204" pitchFamily="34" charset="0"/>
+              </a:rPr>
+              <a:t>Data and surrogate problem information</a:t>
+            </a:r>
+          </a:p>
+        </p:txBody>
+      </p:sp>
+      <p:cxnSp>
+        <p:nvCxnSpPr>
+          <p:cNvPr id="137" name="Straight Arrow Connector 136">
+            <a:extLst>
+              <a:ext uri="{FF2B5EF4-FFF2-40B4-BE49-F238E27FC236}">
+                <a16:creationId xmlns:a16="http://schemas.microsoft.com/office/drawing/2014/main" id="{842448A2-8F22-93A9-8FEA-DDF32011AE48}"/>
+              </a:ext>
+            </a:extLst>
+          </p:cNvPr>
+          <p:cNvCxnSpPr>
+            <a:cxnSpLocks/>
+            <a:stCxn id="18" idx="3"/>
+            <a:endCxn id="20" idx="1"/>
+          </p:cNvCxnSpPr>
+          <p:nvPr/>
+        </p:nvCxnSpPr>
+        <p:spPr>
+          <a:xfrm>
+            <a:off x="3445966" y="4669522"/>
+            <a:ext cx="443516" cy="0"/>
+          </a:xfrm>
+          <a:prstGeom prst="straightConnector1">
+            <a:avLst/>
+          </a:prstGeom>
+          <a:ln w="12700">
+            <a:solidFill>
+              <a:schemeClr val="tx1"/>
+            </a:solidFill>
+            <a:headEnd type="none" w="med" len="med"/>
+            <a:tailEnd type="arrow" w="med" len="med"/>
+          </a:ln>
+        </p:spPr>
+        <p:style>
+          <a:lnRef idx="2">
+            <a:schemeClr val="accent1"/>
+          </a:lnRef>
+          <a:fillRef idx="0">
+            <a:schemeClr val="accent1"/>
+          </a:fillRef>
+          <a:effectRef idx="1">
+            <a:schemeClr val="accent1"/>
+          </a:effectRef>
+          <a:fontRef idx="minor">
+            <a:schemeClr val="tx1"/>
+          </a:fontRef>
+        </p:style>
+      </p:cxnSp>
+      <p:sp>
+        <p:nvSpPr>
+          <p:cNvPr id="155" name="TextBox 154">
+            <a:extLst>
+              <a:ext uri="{FF2B5EF4-FFF2-40B4-BE49-F238E27FC236}">
+                <a16:creationId xmlns:a16="http://schemas.microsoft.com/office/drawing/2014/main" id="{5D13BBD2-102A-CD15-D54E-836BC9917C7E}"/>
+              </a:ext>
+            </a:extLst>
+          </p:cNvPr>
+          <p:cNvSpPr txBox="1"/>
+          <p:nvPr/>
+        </p:nvSpPr>
+        <p:spPr>
+          <a:xfrm>
+            <a:off x="6021365" y="5269796"/>
+            <a:ext cx="2135521" cy="307777"/>
+          </a:xfrm>
+          <a:prstGeom prst="rect">
+            <a:avLst/>
+          </a:prstGeom>
+          <a:noFill/>
+        </p:spPr>
+        <p:txBody>
+          <a:bodyPr wrap="none" rtlCol="0">
+            <a:spAutoFit/>
+          </a:bodyPr>
+          <a:lstStyle/>
+          <a:p>
+            <a:pPr algn="ctr"/>
+            <a:r>
+              <a:rPr lang="en-US" sz="1400" i="1" dirty="0">
+                <a:solidFill>
+                  <a:schemeClr val="accent5"/>
+                </a:solidFill>
+                <a:latin typeface="Arial" panose="020B0604020202020204" pitchFamily="34" charset="0"/>
+                <a:cs typeface="Arial" panose="020B0604020202020204" pitchFamily="34" charset="0"/>
+              </a:rPr>
+              <a:t>Sensitivity-based update</a:t>
+            </a:r>
+          </a:p>
+        </p:txBody>
+      </p:sp>
+      <p:pic>
+        <p:nvPicPr>
+          <p:cNvPr id="4" name="Picture 3">
+            <a:extLst>
+              <a:ext uri="{FF2B5EF4-FFF2-40B4-BE49-F238E27FC236}">
+                <a16:creationId xmlns:a16="http://schemas.microsoft.com/office/drawing/2014/main" id="{3ED0F1D9-C70C-A223-8B62-7746A69240A7}"/>
+              </a:ext>
+            </a:extLst>
+          </p:cNvPr>
+          <p:cNvPicPr>
+            <a:picLocks noChangeAspect="1"/>
+          </p:cNvPicPr>
+          <p:nvPr/>
+        </p:nvPicPr>
+        <p:blipFill>
+          <a:blip r:embed="rId8"/>
+          <a:stretch>
+            <a:fillRect/>
+          </a:stretch>
+        </p:blipFill>
+        <p:spPr>
+          <a:xfrm>
+            <a:off x="1227188" y="2124481"/>
+            <a:ext cx="1536700" cy="215900"/>
+          </a:xfrm>
+          <a:prstGeom prst="rect">
+            <a:avLst/>
+          </a:prstGeom>
+        </p:spPr>
+      </p:pic>
+      <p:grpSp>
+        <p:nvGrpSpPr>
+          <p:cNvPr id="6" name="Group 5">
+            <a:extLst>
+              <a:ext uri="{FF2B5EF4-FFF2-40B4-BE49-F238E27FC236}">
+                <a16:creationId xmlns:a16="http://schemas.microsoft.com/office/drawing/2014/main" id="{3DA406D4-404B-0A4D-7171-EEFEDAB50236}"/>
+              </a:ext>
+            </a:extLst>
+          </p:cNvPr>
+          <p:cNvGrpSpPr/>
+          <p:nvPr/>
+        </p:nvGrpSpPr>
+        <p:grpSpPr>
+          <a:xfrm>
+            <a:off x="3889482" y="1663116"/>
+            <a:ext cx="2900856" cy="867542"/>
+            <a:chOff x="3889482" y="1663116"/>
+            <a:chExt cx="2900856" cy="867542"/>
+          </a:xfrm>
+        </p:grpSpPr>
+        <p:sp>
+          <p:nvSpPr>
+            <p:cNvPr id="22" name="Rounded Rectangle 21">
+              <a:extLst>
+                <a:ext uri="{FF2B5EF4-FFF2-40B4-BE49-F238E27FC236}">
+                  <a16:creationId xmlns:a16="http://schemas.microsoft.com/office/drawing/2014/main" id="{2953A061-104D-0784-B9C8-CD40198AFE8C}"/>
+                </a:ext>
+              </a:extLst>
+            </p:cNvPr>
+            <p:cNvSpPr/>
+            <p:nvPr/>
+          </p:nvSpPr>
+          <p:spPr>
+            <a:xfrm>
+              <a:off x="3889482" y="1663116"/>
+              <a:ext cx="2900856" cy="867542"/>
+            </a:xfrm>
+            <a:prstGeom prst="roundRect">
+              <a:avLst/>
+            </a:prstGeom>
+            <a:solidFill>
+              <a:srgbClr val="6CFFE4"/>
+            </a:solidFill>
+            <a:ln w="12700">
+              <a:solidFill>
+                <a:schemeClr val="tx1"/>
+              </a:solidFill>
+            </a:ln>
+          </p:spPr>
+          <p:style>
+            <a:lnRef idx="2">
+              <a:schemeClr val="accent1">
+                <a:shade val="15000"/>
+              </a:schemeClr>
+            </a:lnRef>
+            <a:fillRef idx="1">
+              <a:schemeClr val="accent1"/>
+            </a:fillRef>
+            <a:effectRef idx="0">
+              <a:schemeClr val="accent1"/>
+            </a:effectRef>
+            <a:fontRef idx="minor">
+              <a:schemeClr val="lt1"/>
+            </a:fontRef>
+          </p:style>
+          <p:txBody>
+            <a:bodyPr rtlCol="0" anchor="t"/>
+            <a:lstStyle/>
+            <a:p>
+              <a:pPr algn="ctr">
+                <a:lnSpc>
+                  <a:spcPts val="600"/>
+                </a:lnSpc>
+              </a:pPr>
+              <a:endParaRPr lang="en-US" sz="1400" dirty="0">
+                <a:solidFill>
+                  <a:schemeClr val="tx1"/>
+                </a:solidFill>
+                <a:latin typeface="Arial" panose="020B0604020202020204" pitchFamily="34" charset="0"/>
+                <a:cs typeface="Arial" panose="020B0604020202020204" pitchFamily="34" charset="0"/>
+              </a:endParaRPr>
+            </a:p>
+            <a:p>
+              <a:pPr algn="ctr">
+                <a:lnSpc>
+                  <a:spcPts val="600"/>
+                </a:lnSpc>
+              </a:pPr>
+              <a:endParaRPr lang="en-US" sz="1400" dirty="0">
+                <a:solidFill>
+                  <a:schemeClr val="tx1"/>
+                </a:solidFill>
+                <a:latin typeface="Arial" panose="020B0604020202020204" pitchFamily="34" charset="0"/>
+                <a:cs typeface="Arial" panose="020B0604020202020204" pitchFamily="34" charset="0"/>
+              </a:endParaRPr>
+            </a:p>
+            <a:p>
+              <a:pPr algn="ctr">
+                <a:lnSpc>
+                  <a:spcPts val="600"/>
+                </a:lnSpc>
+              </a:pPr>
+              <a:r>
+                <a:rPr lang="en-US" sz="1400" dirty="0">
+                  <a:solidFill>
+                    <a:schemeClr val="tx1"/>
+                  </a:solidFill>
+                  <a:latin typeface="Arial" panose="020B0604020202020204" pitchFamily="34" charset="0"/>
+                  <a:cs typeface="Arial" panose="020B0604020202020204" pitchFamily="34" charset="0"/>
+                </a:rPr>
+                <a:t>Large-scale / surrogate data</a:t>
+              </a:r>
+            </a:p>
+          </p:txBody>
+        </p:sp>
+        <p:pic>
+          <p:nvPicPr>
+            <p:cNvPr id="5" name="Picture 4">
+              <a:extLst>
+                <a:ext uri="{FF2B5EF4-FFF2-40B4-BE49-F238E27FC236}">
+                  <a16:creationId xmlns:a16="http://schemas.microsoft.com/office/drawing/2014/main" id="{561A411F-C594-15B0-DCE6-9716420B88B0}"/>
+                </a:ext>
+              </a:extLst>
+            </p:cNvPr>
+            <p:cNvPicPr>
+              <a:picLocks noChangeAspect="1"/>
+            </p:cNvPicPr>
+            <p:nvPr/>
+          </p:nvPicPr>
+          <p:blipFill>
             <a:blip r:embed="rId9"/>
             <a:stretch>
               <a:fillRect/>
@@ -7409,7 +10505,7 @@
     </p:spTree>
     <p:extLst>
       <p:ext uri="{BB962C8B-B14F-4D97-AF65-F5344CB8AC3E}">
-        <p14:creationId xmlns:p14="http://schemas.microsoft.com/office/powerpoint/2010/main" val="3600111524"/>
+        <p14:creationId xmlns:p14="http://schemas.microsoft.com/office/powerpoint/2010/main" val="70589378"/>
       </p:ext>
     </p:extLst>
   </p:cSld>

</xml_diff>

<commit_message>
paper: update figure 1, surrogate -> approximate, remove old comments
</commit_message>
<xml_diff>
--- a/paper/figures/HDSA_MD_Overview.pptx
+++ b/paper/figures/HDSA_MD_Overview.pptx
@@ -8,7 +8,8 @@
     <p:sldId id="257" r:id="rId2"/>
     <p:sldId id="258" r:id="rId3"/>
     <p:sldId id="261" r:id="rId4"/>
-    <p:sldId id="259" r:id="rId5"/>
+    <p:sldId id="262" r:id="rId5"/>
+    <p:sldId id="259" r:id="rId6"/>
   </p:sldIdLst>
   <p:sldSz cx="12192000" cy="6858000"/>
   <p:notesSz cx="6858000" cy="9144000"/>
@@ -273,7 +274,7 @@
           <a:p>
             <a:fld id="{547A4ACA-080D-2846-BC7A-301AD37AA2EA}" type="datetimeFigureOut">
               <a:rPr lang="en-US" smtClean="0"/>
-              <a:t>6/16/25</a:t>
+              <a:t>6/24/25</a:t>
             </a:fld>
             <a:endParaRPr lang="en-US"/>
           </a:p>
@@ -471,7 +472,7 @@
           <a:p>
             <a:fld id="{547A4ACA-080D-2846-BC7A-301AD37AA2EA}" type="datetimeFigureOut">
               <a:rPr lang="en-US" smtClean="0"/>
-              <a:t>6/16/25</a:t>
+              <a:t>6/24/25</a:t>
             </a:fld>
             <a:endParaRPr lang="en-US"/>
           </a:p>
@@ -679,7 +680,7 @@
           <a:p>
             <a:fld id="{547A4ACA-080D-2846-BC7A-301AD37AA2EA}" type="datetimeFigureOut">
               <a:rPr lang="en-US" smtClean="0"/>
-              <a:t>6/16/25</a:t>
+              <a:t>6/24/25</a:t>
             </a:fld>
             <a:endParaRPr lang="en-US"/>
           </a:p>
@@ -877,7 +878,7 @@
           <a:p>
             <a:fld id="{547A4ACA-080D-2846-BC7A-301AD37AA2EA}" type="datetimeFigureOut">
               <a:rPr lang="en-US" smtClean="0"/>
-              <a:t>6/16/25</a:t>
+              <a:t>6/24/25</a:t>
             </a:fld>
             <a:endParaRPr lang="en-US"/>
           </a:p>
@@ -1152,7 +1153,7 @@
           <a:p>
             <a:fld id="{547A4ACA-080D-2846-BC7A-301AD37AA2EA}" type="datetimeFigureOut">
               <a:rPr lang="en-US" smtClean="0"/>
-              <a:t>6/16/25</a:t>
+              <a:t>6/24/25</a:t>
             </a:fld>
             <a:endParaRPr lang="en-US"/>
           </a:p>
@@ -1417,7 +1418,7 @@
           <a:p>
             <a:fld id="{547A4ACA-080D-2846-BC7A-301AD37AA2EA}" type="datetimeFigureOut">
               <a:rPr lang="en-US" smtClean="0"/>
-              <a:t>6/16/25</a:t>
+              <a:t>6/24/25</a:t>
             </a:fld>
             <a:endParaRPr lang="en-US"/>
           </a:p>
@@ -1829,7 +1830,7 @@
           <a:p>
             <a:fld id="{547A4ACA-080D-2846-BC7A-301AD37AA2EA}" type="datetimeFigureOut">
               <a:rPr lang="en-US" smtClean="0"/>
-              <a:t>6/16/25</a:t>
+              <a:t>6/24/25</a:t>
             </a:fld>
             <a:endParaRPr lang="en-US"/>
           </a:p>
@@ -1970,7 +1971,7 @@
           <a:p>
             <a:fld id="{547A4ACA-080D-2846-BC7A-301AD37AA2EA}" type="datetimeFigureOut">
               <a:rPr lang="en-US" smtClean="0"/>
-              <a:t>6/16/25</a:t>
+              <a:t>6/24/25</a:t>
             </a:fld>
             <a:endParaRPr lang="en-US"/>
           </a:p>
@@ -2083,7 +2084,7 @@
           <a:p>
             <a:fld id="{547A4ACA-080D-2846-BC7A-301AD37AA2EA}" type="datetimeFigureOut">
               <a:rPr lang="en-US" smtClean="0"/>
-              <a:t>6/16/25</a:t>
+              <a:t>6/24/25</a:t>
             </a:fld>
             <a:endParaRPr lang="en-US"/>
           </a:p>
@@ -2394,7 +2395,7 @@
           <a:p>
             <a:fld id="{547A4ACA-080D-2846-BC7A-301AD37AA2EA}" type="datetimeFigureOut">
               <a:rPr lang="en-US" smtClean="0"/>
-              <a:t>6/16/25</a:t>
+              <a:t>6/24/25</a:t>
             </a:fld>
             <a:endParaRPr lang="en-US"/>
           </a:p>
@@ -2682,7 +2683,7 @@
           <a:p>
             <a:fld id="{547A4ACA-080D-2846-BC7A-301AD37AA2EA}" type="datetimeFigureOut">
               <a:rPr lang="en-US" smtClean="0"/>
-              <a:t>6/16/25</a:t>
+              <a:t>6/24/25</a:t>
             </a:fld>
             <a:endParaRPr lang="en-US"/>
           </a:p>
@@ -2923,7 +2924,7 @@
           <a:p>
             <a:fld id="{547A4ACA-080D-2846-BC7A-301AD37AA2EA}" type="datetimeFigureOut">
               <a:rPr lang="en-US" smtClean="0"/>
-              <a:t>6/16/25</a:t>
+              <a:t>6/24/25</a:t>
             </a:fld>
             <a:endParaRPr lang="en-US"/>
           </a:p>
@@ -7421,7 +7422,7 @@
 </file>
 
 <file path=ppt/slides/slide3.xml><?xml version="1.0" encoding="utf-8"?>
-<p:sld xmlns:a="http://schemas.openxmlformats.org/drawingml/2006/main" xmlns:r="http://schemas.openxmlformats.org/officeDocument/2006/relationships" xmlns:p="http://schemas.openxmlformats.org/presentationml/2006/main">
+<p:sld xmlns:a="http://schemas.openxmlformats.org/drawingml/2006/main" xmlns:r="http://schemas.openxmlformats.org/officeDocument/2006/relationships" xmlns:p="http://schemas.openxmlformats.org/presentationml/2006/main" show="0">
   <p:cSld>
     <p:spTree>
       <p:nvGrpSpPr>
@@ -8832,6 +8833,1309 @@
 </file>
 
 <file path=ppt/slides/slide4.xml><?xml version="1.0" encoding="utf-8"?>
+<p:sld xmlns:a="http://schemas.openxmlformats.org/drawingml/2006/main" xmlns:r="http://schemas.openxmlformats.org/officeDocument/2006/relationships" xmlns:p="http://schemas.openxmlformats.org/presentationml/2006/main">
+  <p:cSld>
+    <p:spTree>
+      <p:nvGrpSpPr>
+        <p:cNvPr id="1" name="">
+          <a:extLst>
+            <a:ext uri="{FF2B5EF4-FFF2-40B4-BE49-F238E27FC236}">
+              <a16:creationId xmlns:a16="http://schemas.microsoft.com/office/drawing/2014/main" id="{ED80FA9D-D53D-8511-7550-92E59B1DF637}"/>
+            </a:ext>
+          </a:extLst>
+        </p:cNvPr>
+        <p:cNvGrpSpPr/>
+        <p:nvPr/>
+      </p:nvGrpSpPr>
+      <p:grpSpPr>
+        <a:xfrm>
+          <a:off x="0" y="0"/>
+          <a:ext cx="0" cy="0"/>
+          <a:chOff x="0" y="0"/>
+          <a:chExt cx="0" cy="0"/>
+        </a:xfrm>
+      </p:grpSpPr>
+      <p:sp>
+        <p:nvSpPr>
+          <p:cNvPr id="148" name="Rectangle 147">
+            <a:extLst>
+              <a:ext uri="{FF2B5EF4-FFF2-40B4-BE49-F238E27FC236}">
+                <a16:creationId xmlns:a16="http://schemas.microsoft.com/office/drawing/2014/main" id="{E1881D16-A85F-F9ED-5A30-5506084A571E}"/>
+              </a:ext>
+            </a:extLst>
+          </p:cNvPr>
+          <p:cNvSpPr/>
+          <p:nvPr/>
+        </p:nvSpPr>
+        <p:spPr>
+          <a:xfrm>
+            <a:off x="356051" y="4096297"/>
+            <a:ext cx="9986830" cy="1441812"/>
+          </a:xfrm>
+          <a:prstGeom prst="rect">
+            <a:avLst/>
+          </a:prstGeom>
+          <a:solidFill>
+            <a:schemeClr val="accent5">
+              <a:alpha val="10196"/>
+            </a:schemeClr>
+          </a:solidFill>
+          <a:ln w="12700">
+            <a:noFill/>
+            <a:prstDash val="lgDashDot"/>
+          </a:ln>
+        </p:spPr>
+        <p:style>
+          <a:lnRef idx="2">
+            <a:schemeClr val="accent1">
+              <a:shade val="15000"/>
+            </a:schemeClr>
+          </a:lnRef>
+          <a:fillRef idx="1">
+            <a:schemeClr val="accent1"/>
+          </a:fillRef>
+          <a:effectRef idx="0">
+            <a:schemeClr val="accent1"/>
+          </a:effectRef>
+          <a:fontRef idx="minor">
+            <a:schemeClr val="lt1"/>
+          </a:fontRef>
+        </p:style>
+        <p:txBody>
+          <a:bodyPr rtlCol="0" anchor="ctr"/>
+          <a:lstStyle/>
+          <a:p>
+            <a:pPr algn="ctr"/>
+            <a:endParaRPr lang="en-US"/>
+          </a:p>
+        </p:txBody>
+      </p:sp>
+      <p:sp>
+        <p:nvSpPr>
+          <p:cNvPr id="136" name="Rectangle 135">
+            <a:extLst>
+              <a:ext uri="{FF2B5EF4-FFF2-40B4-BE49-F238E27FC236}">
+                <a16:creationId xmlns:a16="http://schemas.microsoft.com/office/drawing/2014/main" id="{6F3AB9E8-6A71-530F-4687-501EBE57DB65}"/>
+              </a:ext>
+            </a:extLst>
+          </p:cNvPr>
+          <p:cNvSpPr/>
+          <p:nvPr/>
+        </p:nvSpPr>
+        <p:spPr>
+          <a:xfrm>
+            <a:off x="356051" y="2498577"/>
+            <a:ext cx="9986830" cy="1526885"/>
+          </a:xfrm>
+          <a:prstGeom prst="rect">
+            <a:avLst/>
+          </a:prstGeom>
+          <a:solidFill>
+            <a:srgbClr val="0F9ED5">
+              <a:alpha val="10196"/>
+            </a:srgbClr>
+          </a:solidFill>
+          <a:ln w="12700">
+            <a:noFill/>
+            <a:prstDash val="lgDashDot"/>
+          </a:ln>
+        </p:spPr>
+        <p:style>
+          <a:lnRef idx="2">
+            <a:schemeClr val="accent1">
+              <a:shade val="15000"/>
+            </a:schemeClr>
+          </a:lnRef>
+          <a:fillRef idx="1">
+            <a:schemeClr val="accent1"/>
+          </a:fillRef>
+          <a:effectRef idx="0">
+            <a:schemeClr val="accent1"/>
+          </a:effectRef>
+          <a:fontRef idx="minor">
+            <a:schemeClr val="lt1"/>
+          </a:fontRef>
+        </p:style>
+        <p:txBody>
+          <a:bodyPr rtlCol="0" anchor="ctr"/>
+          <a:lstStyle/>
+          <a:p>
+            <a:pPr algn="ctr"/>
+            <a:endParaRPr lang="en-US"/>
+          </a:p>
+        </p:txBody>
+      </p:sp>
+      <p:grpSp>
+        <p:nvGrpSpPr>
+          <p:cNvPr id="60" name="Group 59">
+            <a:extLst>
+              <a:ext uri="{FF2B5EF4-FFF2-40B4-BE49-F238E27FC236}">
+                <a16:creationId xmlns:a16="http://schemas.microsoft.com/office/drawing/2014/main" id="{8757E4CA-6EDC-3F87-0C4C-82079782DA87}"/>
+              </a:ext>
+            </a:extLst>
+          </p:cNvPr>
+          <p:cNvGrpSpPr/>
+          <p:nvPr/>
+        </p:nvGrpSpPr>
+        <p:grpSpPr>
+          <a:xfrm>
+            <a:off x="7233854" y="2933393"/>
+            <a:ext cx="2900856" cy="867542"/>
+            <a:chOff x="8479791" y="3656070"/>
+            <a:chExt cx="2900856" cy="867542"/>
+          </a:xfrm>
+          <a:solidFill>
+            <a:schemeClr val="bg1"/>
+          </a:solidFill>
+        </p:grpSpPr>
+        <p:sp>
+          <p:nvSpPr>
+            <p:cNvPr id="25" name="Rounded Rectangle 24">
+              <a:extLst>
+                <a:ext uri="{FF2B5EF4-FFF2-40B4-BE49-F238E27FC236}">
+                  <a16:creationId xmlns:a16="http://schemas.microsoft.com/office/drawing/2014/main" id="{820640E2-8EA2-267D-9F49-0C415614C034}"/>
+                </a:ext>
+              </a:extLst>
+            </p:cNvPr>
+            <p:cNvSpPr/>
+            <p:nvPr/>
+          </p:nvSpPr>
+          <p:spPr>
+            <a:xfrm>
+              <a:off x="8479791" y="3656070"/>
+              <a:ext cx="2900856" cy="867542"/>
+            </a:xfrm>
+            <a:prstGeom prst="roundRect">
+              <a:avLst>
+                <a:gd name="adj" fmla="val 0"/>
+              </a:avLst>
+            </a:prstGeom>
+            <a:grpFill/>
+            <a:ln w="28575">
+              <a:solidFill>
+                <a:schemeClr val="tx1"/>
+              </a:solidFill>
+            </a:ln>
+          </p:spPr>
+          <p:style>
+            <a:lnRef idx="2">
+              <a:schemeClr val="accent1">
+                <a:shade val="15000"/>
+              </a:schemeClr>
+            </a:lnRef>
+            <a:fillRef idx="1">
+              <a:schemeClr val="accent1"/>
+            </a:fillRef>
+            <a:effectRef idx="0">
+              <a:schemeClr val="accent1"/>
+            </a:effectRef>
+            <a:fontRef idx="minor">
+              <a:schemeClr val="lt1"/>
+            </a:fontRef>
+          </p:style>
+          <p:txBody>
+            <a:bodyPr rtlCol="0" anchor="t"/>
+            <a:lstStyle/>
+            <a:p>
+              <a:pPr algn="ctr">
+                <a:lnSpc>
+                  <a:spcPts val="600"/>
+                </a:lnSpc>
+              </a:pPr>
+              <a:endParaRPr lang="en-US" sz="1400" dirty="0">
+                <a:solidFill>
+                  <a:schemeClr val="tx1"/>
+                </a:solidFill>
+                <a:latin typeface="Arial" panose="020B0604020202020204" pitchFamily="34" charset="0"/>
+                <a:cs typeface="Arial" panose="020B0604020202020204" pitchFamily="34" charset="0"/>
+              </a:endParaRPr>
+            </a:p>
+            <a:p>
+              <a:pPr algn="ctr">
+                <a:lnSpc>
+                  <a:spcPts val="600"/>
+                </a:lnSpc>
+              </a:pPr>
+              <a:endParaRPr lang="en-US" sz="1400" dirty="0">
+                <a:solidFill>
+                  <a:schemeClr val="tx1"/>
+                </a:solidFill>
+                <a:latin typeface="Arial" panose="020B0604020202020204" pitchFamily="34" charset="0"/>
+                <a:cs typeface="Arial" panose="020B0604020202020204" pitchFamily="34" charset="0"/>
+              </a:endParaRPr>
+            </a:p>
+            <a:p>
+              <a:pPr algn="ctr">
+                <a:lnSpc>
+                  <a:spcPts val="600"/>
+                </a:lnSpc>
+              </a:pPr>
+              <a:endParaRPr lang="en-US" sz="1400" dirty="0">
+                <a:solidFill>
+                  <a:schemeClr val="tx1"/>
+                </a:solidFill>
+                <a:latin typeface="Arial" panose="020B0604020202020204" pitchFamily="34" charset="0"/>
+                <a:cs typeface="Arial" panose="020B0604020202020204" pitchFamily="34" charset="0"/>
+              </a:endParaRPr>
+            </a:p>
+            <a:p>
+              <a:pPr algn="ctr">
+                <a:lnSpc>
+                  <a:spcPts val="400"/>
+                </a:lnSpc>
+              </a:pPr>
+              <a:r>
+                <a:rPr lang="en-US" sz="1400" dirty="0">
+                  <a:solidFill>
+                    <a:schemeClr val="tx1"/>
+                  </a:solidFill>
+                  <a:latin typeface="Arial" panose="020B0604020202020204" pitchFamily="34" charset="0"/>
+                  <a:cs typeface="Arial" panose="020B0604020202020204" pitchFamily="34" charset="0"/>
+                </a:rPr>
+                <a:t>Post-optimality sensitivity update</a:t>
+              </a:r>
+            </a:p>
+          </p:txBody>
+        </p:sp>
+        <p:pic>
+          <p:nvPicPr>
+            <p:cNvPr id="36" name="Picture 35">
+              <a:extLst>
+                <a:ext uri="{FF2B5EF4-FFF2-40B4-BE49-F238E27FC236}">
+                  <a16:creationId xmlns:a16="http://schemas.microsoft.com/office/drawing/2014/main" id="{0C2C5945-D6E5-B000-FB14-2DA7716F01C8}"/>
+                </a:ext>
+              </a:extLst>
+            </p:cNvPr>
+            <p:cNvPicPr>
+              <a:picLocks noChangeAspect="1"/>
+            </p:cNvPicPr>
+            <p:nvPr/>
+          </p:nvPicPr>
+          <p:blipFill>
+            <a:blip r:embed="rId2"/>
+            <a:stretch>
+              <a:fillRect/>
+            </a:stretch>
+          </p:blipFill>
+          <p:spPr>
+            <a:xfrm>
+              <a:off x="9297058" y="4115241"/>
+              <a:ext cx="1333500" cy="165100"/>
+            </a:xfrm>
+            <a:prstGeom prst="rect">
+              <a:avLst/>
+            </a:prstGeom>
+            <a:grpFill/>
+          </p:spPr>
+        </p:pic>
+      </p:grpSp>
+      <p:cxnSp>
+        <p:nvCxnSpPr>
+          <p:cNvPr id="64" name="Straight Arrow Connector 63">
+            <a:extLst>
+              <a:ext uri="{FF2B5EF4-FFF2-40B4-BE49-F238E27FC236}">
+                <a16:creationId xmlns:a16="http://schemas.microsoft.com/office/drawing/2014/main" id="{4431FCB6-C55A-2D86-3BD0-204ACE713A03}"/>
+              </a:ext>
+            </a:extLst>
+          </p:cNvPr>
+          <p:cNvCxnSpPr>
+            <a:cxnSpLocks/>
+            <a:stCxn id="22" idx="3"/>
+            <a:endCxn id="20" idx="1"/>
+          </p:cNvCxnSpPr>
+          <p:nvPr/>
+        </p:nvCxnSpPr>
+        <p:spPr>
+          <a:xfrm>
+            <a:off x="3445966" y="4669522"/>
+            <a:ext cx="443516" cy="0"/>
+          </a:xfrm>
+          <a:prstGeom prst="straightConnector1">
+            <a:avLst/>
+          </a:prstGeom>
+          <a:ln w="12700">
+            <a:solidFill>
+              <a:schemeClr val="tx1"/>
+            </a:solidFill>
+            <a:headEnd type="none" w="med" len="med"/>
+            <a:tailEnd type="arrow" w="med" len="med"/>
+          </a:ln>
+        </p:spPr>
+        <p:style>
+          <a:lnRef idx="2">
+            <a:schemeClr val="accent1"/>
+          </a:lnRef>
+          <a:fillRef idx="0">
+            <a:schemeClr val="accent1"/>
+          </a:fillRef>
+          <a:effectRef idx="1">
+            <a:schemeClr val="accent1"/>
+          </a:effectRef>
+          <a:fontRef idx="minor">
+            <a:schemeClr val="tx1"/>
+          </a:fontRef>
+        </p:style>
+      </p:cxnSp>
+      <p:sp>
+        <p:nvSpPr>
+          <p:cNvPr id="120" name="TextBox 119">
+            <a:extLst>
+              <a:ext uri="{FF2B5EF4-FFF2-40B4-BE49-F238E27FC236}">
+                <a16:creationId xmlns:a16="http://schemas.microsoft.com/office/drawing/2014/main" id="{4F1DEEA1-EA3C-B3A8-2EC0-746F1B30970C}"/>
+              </a:ext>
+            </a:extLst>
+          </p:cNvPr>
+          <p:cNvSpPr txBox="1"/>
+          <p:nvPr/>
+        </p:nvSpPr>
+        <p:spPr>
+          <a:xfrm>
+            <a:off x="462072" y="2554977"/>
+            <a:ext cx="1689886" cy="307777"/>
+          </a:xfrm>
+          <a:prstGeom prst="rect">
+            <a:avLst/>
+          </a:prstGeom>
+          <a:noFill/>
+        </p:spPr>
+        <p:txBody>
+          <a:bodyPr wrap="none" rtlCol="0">
+            <a:spAutoFit/>
+          </a:bodyPr>
+          <a:lstStyle/>
+          <a:p>
+            <a:r>
+              <a:rPr lang="en-US" sz="1400" i="1" dirty="0">
+                <a:solidFill>
+                  <a:srgbClr val="0A84B2"/>
+                </a:solidFill>
+                <a:latin typeface="Arial" panose="020B0604020202020204" pitchFamily="34" charset="0"/>
+                <a:cs typeface="Arial" panose="020B0604020202020204" pitchFamily="34" charset="0"/>
+              </a:rPr>
+              <a:t>Sensitivity analysis</a:t>
+            </a:r>
+          </a:p>
+        </p:txBody>
+      </p:sp>
+      <p:cxnSp>
+        <p:nvCxnSpPr>
+          <p:cNvPr id="137" name="Straight Arrow Connector 136">
+            <a:extLst>
+              <a:ext uri="{FF2B5EF4-FFF2-40B4-BE49-F238E27FC236}">
+                <a16:creationId xmlns:a16="http://schemas.microsoft.com/office/drawing/2014/main" id="{B62B1874-03A3-442A-0E73-DA965FF6BD81}"/>
+              </a:ext>
+            </a:extLst>
+          </p:cNvPr>
+          <p:cNvCxnSpPr>
+            <a:cxnSpLocks/>
+            <a:stCxn id="18" idx="3"/>
+          </p:cNvCxnSpPr>
+          <p:nvPr/>
+        </p:nvCxnSpPr>
+        <p:spPr>
+          <a:xfrm flipH="1">
+            <a:off x="6790338" y="4669522"/>
+            <a:ext cx="3344372" cy="0"/>
+          </a:xfrm>
+          <a:prstGeom prst="straightConnector1">
+            <a:avLst/>
+          </a:prstGeom>
+          <a:ln w="12700">
+            <a:solidFill>
+              <a:schemeClr val="tx1"/>
+            </a:solidFill>
+            <a:headEnd type="none" w="med" len="med"/>
+            <a:tailEnd type="arrow" w="med" len="med"/>
+          </a:ln>
+        </p:spPr>
+        <p:style>
+          <a:lnRef idx="2">
+            <a:schemeClr val="accent1"/>
+          </a:lnRef>
+          <a:fillRef idx="0">
+            <a:schemeClr val="accent1"/>
+          </a:fillRef>
+          <a:effectRef idx="1">
+            <a:schemeClr val="accent1"/>
+          </a:effectRef>
+          <a:fontRef idx="minor">
+            <a:schemeClr val="tx1"/>
+          </a:fontRef>
+        </p:style>
+      </p:cxnSp>
+      <p:sp>
+        <p:nvSpPr>
+          <p:cNvPr id="155" name="TextBox 154">
+            <a:extLst>
+              <a:ext uri="{FF2B5EF4-FFF2-40B4-BE49-F238E27FC236}">
+                <a16:creationId xmlns:a16="http://schemas.microsoft.com/office/drawing/2014/main" id="{C81010DD-8458-0529-A834-9756B52ED76C}"/>
+              </a:ext>
+            </a:extLst>
+          </p:cNvPr>
+          <p:cNvSpPr txBox="1"/>
+          <p:nvPr/>
+        </p:nvSpPr>
+        <p:spPr>
+          <a:xfrm>
+            <a:off x="462072" y="5174128"/>
+            <a:ext cx="1787669" cy="307777"/>
+          </a:xfrm>
+          <a:prstGeom prst="rect">
+            <a:avLst/>
+          </a:prstGeom>
+          <a:noFill/>
+        </p:spPr>
+        <p:txBody>
+          <a:bodyPr wrap="none" rtlCol="0">
+            <a:spAutoFit/>
+          </a:bodyPr>
+          <a:lstStyle/>
+          <a:p>
+            <a:r>
+              <a:rPr lang="en-US" sz="1400" i="1" dirty="0">
+                <a:solidFill>
+                  <a:srgbClr val="86227C"/>
+                </a:solidFill>
+                <a:latin typeface="Arial" panose="020B0604020202020204" pitchFamily="34" charset="0"/>
+                <a:cs typeface="Arial" panose="020B0604020202020204" pitchFamily="34" charset="0"/>
+              </a:rPr>
+              <a:t>Bayesian calibration</a:t>
+            </a:r>
+          </a:p>
+        </p:txBody>
+      </p:sp>
+      <p:cxnSp>
+        <p:nvCxnSpPr>
+          <p:cNvPr id="2" name="Straight Arrow Connector 1">
+            <a:extLst>
+              <a:ext uri="{FF2B5EF4-FFF2-40B4-BE49-F238E27FC236}">
+                <a16:creationId xmlns:a16="http://schemas.microsoft.com/office/drawing/2014/main" id="{39614D95-20D1-BC72-D244-6B0F17985783}"/>
+              </a:ext>
+            </a:extLst>
+          </p:cNvPr>
+          <p:cNvCxnSpPr>
+            <a:cxnSpLocks/>
+            <a:stCxn id="16" idx="3"/>
+            <a:endCxn id="25" idx="1"/>
+          </p:cNvCxnSpPr>
+          <p:nvPr/>
+        </p:nvCxnSpPr>
+        <p:spPr>
+          <a:xfrm flipV="1">
+            <a:off x="6790338" y="3367164"/>
+            <a:ext cx="443516" cy="1046"/>
+          </a:xfrm>
+          <a:prstGeom prst="straightConnector1">
+            <a:avLst/>
+          </a:prstGeom>
+          <a:ln w="12700">
+            <a:solidFill>
+              <a:schemeClr val="tx1"/>
+            </a:solidFill>
+            <a:headEnd type="none" w="med" len="med"/>
+            <a:tailEnd type="arrow" w="med" len="med"/>
+          </a:ln>
+        </p:spPr>
+        <p:style>
+          <a:lnRef idx="2">
+            <a:schemeClr val="accent1"/>
+          </a:lnRef>
+          <a:fillRef idx="0">
+            <a:schemeClr val="accent1"/>
+          </a:fillRef>
+          <a:effectRef idx="1">
+            <a:schemeClr val="accent1"/>
+          </a:effectRef>
+          <a:fontRef idx="minor">
+            <a:schemeClr val="tx1"/>
+          </a:fontRef>
+        </p:style>
+      </p:cxnSp>
+      <p:sp>
+        <p:nvSpPr>
+          <p:cNvPr id="22" name="Rounded Rectangle 21">
+            <a:extLst>
+              <a:ext uri="{FF2B5EF4-FFF2-40B4-BE49-F238E27FC236}">
+                <a16:creationId xmlns:a16="http://schemas.microsoft.com/office/drawing/2014/main" id="{FA3C52E9-4E0B-DFCF-3CC0-828E89400B01}"/>
+              </a:ext>
+            </a:extLst>
+          </p:cNvPr>
+          <p:cNvSpPr/>
+          <p:nvPr/>
+        </p:nvSpPr>
+        <p:spPr>
+          <a:xfrm>
+            <a:off x="545110" y="4235751"/>
+            <a:ext cx="2900856" cy="867542"/>
+          </a:xfrm>
+          <a:prstGeom prst="roundRect">
+            <a:avLst/>
+          </a:prstGeom>
+          <a:solidFill>
+            <a:schemeClr val="bg1"/>
+          </a:solidFill>
+          <a:ln w="12700">
+            <a:solidFill>
+              <a:schemeClr val="tx1"/>
+            </a:solidFill>
+          </a:ln>
+        </p:spPr>
+        <p:style>
+          <a:lnRef idx="2">
+            <a:schemeClr val="accent1">
+              <a:shade val="15000"/>
+            </a:schemeClr>
+          </a:lnRef>
+          <a:fillRef idx="1">
+            <a:schemeClr val="accent1"/>
+          </a:fillRef>
+          <a:effectRef idx="0">
+            <a:schemeClr val="accent1"/>
+          </a:effectRef>
+          <a:fontRef idx="minor">
+            <a:schemeClr val="lt1"/>
+          </a:fontRef>
+        </p:style>
+        <p:txBody>
+          <a:bodyPr rtlCol="0" anchor="t"/>
+          <a:lstStyle/>
+          <a:p>
+            <a:pPr algn="ctr">
+              <a:lnSpc>
+                <a:spcPts val="600"/>
+              </a:lnSpc>
+            </a:pPr>
+            <a:endParaRPr lang="en-US" sz="1400" dirty="0">
+              <a:solidFill>
+                <a:schemeClr val="tx1"/>
+              </a:solidFill>
+              <a:latin typeface="Arial" panose="020B0604020202020204" pitchFamily="34" charset="0"/>
+              <a:cs typeface="Arial" panose="020B0604020202020204" pitchFamily="34" charset="0"/>
+            </a:endParaRPr>
+          </a:p>
+          <a:p>
+            <a:pPr algn="ctr">
+              <a:lnSpc>
+                <a:spcPts val="600"/>
+              </a:lnSpc>
+            </a:pPr>
+            <a:endParaRPr lang="en-US" sz="1400" dirty="0">
+              <a:solidFill>
+                <a:schemeClr val="tx1"/>
+              </a:solidFill>
+              <a:latin typeface="Arial" panose="020B0604020202020204" pitchFamily="34" charset="0"/>
+              <a:cs typeface="Arial" panose="020B0604020202020204" pitchFamily="34" charset="0"/>
+            </a:endParaRPr>
+          </a:p>
+          <a:p>
+            <a:pPr algn="ctr">
+              <a:lnSpc>
+                <a:spcPts val="600"/>
+              </a:lnSpc>
+            </a:pPr>
+            <a:r>
+              <a:rPr lang="en-US" sz="1400" dirty="0">
+                <a:solidFill>
+                  <a:schemeClr val="tx1"/>
+                </a:solidFill>
+                <a:latin typeface="Arial" panose="020B0604020202020204" pitchFamily="34" charset="0"/>
+                <a:cs typeface="Arial" panose="020B0604020202020204" pitchFamily="34" charset="0"/>
+              </a:rPr>
+              <a:t>True / approximate model data</a:t>
+            </a:r>
+          </a:p>
+        </p:txBody>
+      </p:sp>
+      <p:cxnSp>
+        <p:nvCxnSpPr>
+          <p:cNvPr id="37" name="Straight Arrow Connector 36">
+            <a:extLst>
+              <a:ext uri="{FF2B5EF4-FFF2-40B4-BE49-F238E27FC236}">
+                <a16:creationId xmlns:a16="http://schemas.microsoft.com/office/drawing/2014/main" id="{8E52ABCC-9D14-67DB-B82D-83796CA186BD}"/>
+              </a:ext>
+            </a:extLst>
+          </p:cNvPr>
+          <p:cNvCxnSpPr>
+            <a:cxnSpLocks/>
+            <a:stCxn id="17" idx="3"/>
+            <a:endCxn id="16" idx="1"/>
+          </p:cNvCxnSpPr>
+          <p:nvPr/>
+        </p:nvCxnSpPr>
+        <p:spPr>
+          <a:xfrm>
+            <a:off x="3445966" y="3367164"/>
+            <a:ext cx="443516" cy="1046"/>
+          </a:xfrm>
+          <a:prstGeom prst="straightConnector1">
+            <a:avLst/>
+          </a:prstGeom>
+          <a:ln w="12700">
+            <a:solidFill>
+              <a:schemeClr val="tx1"/>
+            </a:solidFill>
+            <a:headEnd type="none" w="med" len="med"/>
+            <a:tailEnd type="arrow" w="med" len="med"/>
+          </a:ln>
+        </p:spPr>
+        <p:style>
+          <a:lnRef idx="2">
+            <a:schemeClr val="accent1"/>
+          </a:lnRef>
+          <a:fillRef idx="0">
+            <a:schemeClr val="accent1"/>
+          </a:fillRef>
+          <a:effectRef idx="1">
+            <a:schemeClr val="accent1"/>
+          </a:effectRef>
+          <a:fontRef idx="minor">
+            <a:schemeClr val="tx1"/>
+          </a:fontRef>
+        </p:style>
+      </p:cxnSp>
+      <p:cxnSp>
+        <p:nvCxnSpPr>
+          <p:cNvPr id="41" name="Straight Arrow Connector 40">
+            <a:extLst>
+              <a:ext uri="{FF2B5EF4-FFF2-40B4-BE49-F238E27FC236}">
+                <a16:creationId xmlns:a16="http://schemas.microsoft.com/office/drawing/2014/main" id="{20566089-C836-6044-69A4-6A70CD4D6D44}"/>
+              </a:ext>
+            </a:extLst>
+          </p:cNvPr>
+          <p:cNvCxnSpPr>
+            <a:cxnSpLocks/>
+            <a:stCxn id="20" idx="0"/>
+            <a:endCxn id="16" idx="2"/>
+          </p:cNvCxnSpPr>
+          <p:nvPr/>
+        </p:nvCxnSpPr>
+        <p:spPr>
+          <a:xfrm flipV="1">
+            <a:off x="5339910" y="3801981"/>
+            <a:ext cx="0" cy="433770"/>
+          </a:xfrm>
+          <a:prstGeom prst="straightConnector1">
+            <a:avLst/>
+          </a:prstGeom>
+          <a:ln w="12700">
+            <a:solidFill>
+              <a:schemeClr val="tx1"/>
+            </a:solidFill>
+            <a:headEnd type="none" w="med" len="med"/>
+            <a:tailEnd type="arrow" w="med" len="med"/>
+          </a:ln>
+        </p:spPr>
+        <p:style>
+          <a:lnRef idx="2">
+            <a:schemeClr val="accent1"/>
+          </a:lnRef>
+          <a:fillRef idx="0">
+            <a:schemeClr val="accent1"/>
+          </a:fillRef>
+          <a:effectRef idx="1">
+            <a:schemeClr val="accent1"/>
+          </a:effectRef>
+          <a:fontRef idx="minor">
+            <a:schemeClr val="tx1"/>
+          </a:fontRef>
+        </p:style>
+      </p:cxnSp>
+      <p:grpSp>
+        <p:nvGrpSpPr>
+          <p:cNvPr id="48" name="Group 47">
+            <a:extLst>
+              <a:ext uri="{FF2B5EF4-FFF2-40B4-BE49-F238E27FC236}">
+                <a16:creationId xmlns:a16="http://schemas.microsoft.com/office/drawing/2014/main" id="{02155945-54E3-9D05-9974-EA3F5D664CFC}"/>
+              </a:ext>
+            </a:extLst>
+          </p:cNvPr>
+          <p:cNvGrpSpPr/>
+          <p:nvPr/>
+        </p:nvGrpSpPr>
+        <p:grpSpPr>
+          <a:xfrm>
+            <a:off x="3889482" y="4235751"/>
+            <a:ext cx="2900856" cy="867542"/>
+            <a:chOff x="3889482" y="4235751"/>
+            <a:chExt cx="2900856" cy="867542"/>
+          </a:xfrm>
+        </p:grpSpPr>
+        <p:sp>
+          <p:nvSpPr>
+            <p:cNvPr id="20" name="Rounded Rectangle 19">
+              <a:extLst>
+                <a:ext uri="{FF2B5EF4-FFF2-40B4-BE49-F238E27FC236}">
+                  <a16:creationId xmlns:a16="http://schemas.microsoft.com/office/drawing/2014/main" id="{4816579D-A9B7-24EB-3D79-953EBE870633}"/>
+                </a:ext>
+              </a:extLst>
+            </p:cNvPr>
+            <p:cNvSpPr/>
+            <p:nvPr/>
+          </p:nvSpPr>
+          <p:spPr>
+            <a:xfrm>
+              <a:off x="3889482" y="4235751"/>
+              <a:ext cx="2900856" cy="867542"/>
+            </a:xfrm>
+            <a:prstGeom prst="roundRect">
+              <a:avLst/>
+            </a:prstGeom>
+            <a:solidFill>
+              <a:schemeClr val="bg1"/>
+            </a:solidFill>
+            <a:ln w="12700">
+              <a:solidFill>
+                <a:schemeClr val="tx1"/>
+              </a:solidFill>
+            </a:ln>
+          </p:spPr>
+          <p:style>
+            <a:lnRef idx="2">
+              <a:schemeClr val="accent1">
+                <a:shade val="15000"/>
+              </a:schemeClr>
+            </a:lnRef>
+            <a:fillRef idx="1">
+              <a:schemeClr val="accent1"/>
+            </a:fillRef>
+            <a:effectRef idx="0">
+              <a:schemeClr val="accent1"/>
+            </a:effectRef>
+            <a:fontRef idx="minor">
+              <a:schemeClr val="lt1"/>
+            </a:fontRef>
+          </p:style>
+          <p:txBody>
+            <a:bodyPr rtlCol="0" anchor="t"/>
+            <a:lstStyle/>
+            <a:p>
+              <a:pPr algn="ctr">
+                <a:lnSpc>
+                  <a:spcPts val="600"/>
+                </a:lnSpc>
+              </a:pPr>
+              <a:endParaRPr lang="en-US" sz="1400" dirty="0">
+                <a:solidFill>
+                  <a:schemeClr val="tx1"/>
+                </a:solidFill>
+                <a:latin typeface="Arial" panose="020B0604020202020204" pitchFamily="34" charset="0"/>
+                <a:cs typeface="Arial" panose="020B0604020202020204" pitchFamily="34" charset="0"/>
+              </a:endParaRPr>
+            </a:p>
+            <a:p>
+              <a:pPr algn="ctr">
+                <a:lnSpc>
+                  <a:spcPts val="600"/>
+                </a:lnSpc>
+              </a:pPr>
+              <a:endParaRPr lang="en-US" sz="1400" dirty="0">
+                <a:solidFill>
+                  <a:schemeClr val="tx1"/>
+                </a:solidFill>
+                <a:latin typeface="Arial" panose="020B0604020202020204" pitchFamily="34" charset="0"/>
+                <a:cs typeface="Arial" panose="020B0604020202020204" pitchFamily="34" charset="0"/>
+              </a:endParaRPr>
+            </a:p>
+            <a:p>
+              <a:pPr algn="ctr">
+                <a:lnSpc>
+                  <a:spcPts val="600"/>
+                </a:lnSpc>
+              </a:pPr>
+              <a:r>
+                <a:rPr lang="en-US" sz="1400" dirty="0">
+                  <a:solidFill>
+                    <a:schemeClr val="tx1"/>
+                  </a:solidFill>
+                  <a:latin typeface="Arial" panose="020B0604020202020204" pitchFamily="34" charset="0"/>
+                  <a:cs typeface="Arial" panose="020B0604020202020204" pitchFamily="34" charset="0"/>
+                </a:rPr>
+                <a:t>Bayesian discrepancy calibration</a:t>
+              </a:r>
+            </a:p>
+          </p:txBody>
+        </p:sp>
+        <p:pic>
+          <p:nvPicPr>
+            <p:cNvPr id="47" name="Picture 46">
+              <a:extLst>
+                <a:ext uri="{FF2B5EF4-FFF2-40B4-BE49-F238E27FC236}">
+                  <a16:creationId xmlns:a16="http://schemas.microsoft.com/office/drawing/2014/main" id="{2DD0A152-2A02-1A6F-3560-50209034DF34}"/>
+                </a:ext>
+              </a:extLst>
+            </p:cNvPr>
+            <p:cNvPicPr>
+              <a:picLocks noChangeAspect="1"/>
+            </p:cNvPicPr>
+            <p:nvPr/>
+          </p:nvPicPr>
+          <p:blipFill>
+            <a:blip r:embed="rId3"/>
+            <a:stretch>
+              <a:fillRect/>
+            </a:stretch>
+          </p:blipFill>
+          <p:spPr>
+            <a:xfrm>
+              <a:off x="4317560" y="4715758"/>
+              <a:ext cx="2044700" cy="190500"/>
+            </a:xfrm>
+            <a:prstGeom prst="rect">
+              <a:avLst/>
+            </a:prstGeom>
+          </p:spPr>
+        </p:pic>
+      </p:grpSp>
+      <p:pic>
+        <p:nvPicPr>
+          <p:cNvPr id="50" name="Picture 49">
+            <a:extLst>
+              <a:ext uri="{FF2B5EF4-FFF2-40B4-BE49-F238E27FC236}">
+                <a16:creationId xmlns:a16="http://schemas.microsoft.com/office/drawing/2014/main" id="{D1814286-3A50-8D47-89F6-0C791FA36D25}"/>
+              </a:ext>
+            </a:extLst>
+          </p:cNvPr>
+          <p:cNvPicPr>
+            <a:picLocks noChangeAspect="1"/>
+          </p:cNvPicPr>
+          <p:nvPr/>
+        </p:nvPicPr>
+        <p:blipFill>
+          <a:blip r:embed="rId4"/>
+          <a:stretch>
+            <a:fillRect/>
+          </a:stretch>
+        </p:blipFill>
+        <p:spPr>
+          <a:xfrm>
+            <a:off x="808087" y="4715758"/>
+            <a:ext cx="2374900" cy="190500"/>
+          </a:xfrm>
+          <a:prstGeom prst="rect">
+            <a:avLst/>
+          </a:prstGeom>
+        </p:spPr>
+      </p:pic>
+      <p:grpSp>
+        <p:nvGrpSpPr>
+          <p:cNvPr id="62" name="Group 61">
+            <a:extLst>
+              <a:ext uri="{FF2B5EF4-FFF2-40B4-BE49-F238E27FC236}">
+                <a16:creationId xmlns:a16="http://schemas.microsoft.com/office/drawing/2014/main" id="{88799940-47E3-C472-28C0-2ED9A04700BE}"/>
+              </a:ext>
+            </a:extLst>
+          </p:cNvPr>
+          <p:cNvGrpSpPr/>
+          <p:nvPr/>
+        </p:nvGrpSpPr>
+        <p:grpSpPr>
+          <a:xfrm>
+            <a:off x="3889482" y="2934439"/>
+            <a:ext cx="2900856" cy="867542"/>
+            <a:chOff x="3889482" y="2934439"/>
+            <a:chExt cx="2900856" cy="867542"/>
+          </a:xfrm>
+        </p:grpSpPr>
+        <p:sp>
+          <p:nvSpPr>
+            <p:cNvPr id="16" name="Rounded Rectangle 15">
+              <a:extLst>
+                <a:ext uri="{FF2B5EF4-FFF2-40B4-BE49-F238E27FC236}">
+                  <a16:creationId xmlns:a16="http://schemas.microsoft.com/office/drawing/2014/main" id="{2471237A-5666-C5BA-ECFC-5ADE22290607}"/>
+                </a:ext>
+              </a:extLst>
+            </p:cNvPr>
+            <p:cNvSpPr/>
+            <p:nvPr/>
+          </p:nvSpPr>
+          <p:spPr>
+            <a:xfrm>
+              <a:off x="3889482" y="2934439"/>
+              <a:ext cx="2900856" cy="867542"/>
+            </a:xfrm>
+            <a:prstGeom prst="roundRect">
+              <a:avLst/>
+            </a:prstGeom>
+            <a:solidFill>
+              <a:schemeClr val="bg1"/>
+            </a:solidFill>
+            <a:ln w="12700">
+              <a:solidFill>
+                <a:schemeClr val="tx1"/>
+              </a:solidFill>
+            </a:ln>
+          </p:spPr>
+          <p:style>
+            <a:lnRef idx="2">
+              <a:schemeClr val="accent1">
+                <a:shade val="15000"/>
+              </a:schemeClr>
+            </a:lnRef>
+            <a:fillRef idx="1">
+              <a:schemeClr val="accent1"/>
+            </a:fillRef>
+            <a:effectRef idx="0">
+              <a:schemeClr val="accent1"/>
+            </a:effectRef>
+            <a:fontRef idx="minor">
+              <a:schemeClr val="lt1"/>
+            </a:fontRef>
+          </p:style>
+          <p:txBody>
+            <a:bodyPr rtlCol="0" anchor="t"/>
+            <a:lstStyle/>
+            <a:p>
+              <a:pPr algn="ctr">
+                <a:lnSpc>
+                  <a:spcPts val="600"/>
+                </a:lnSpc>
+              </a:pPr>
+              <a:endParaRPr lang="en-US" sz="1400" dirty="0">
+                <a:solidFill>
+                  <a:schemeClr val="tx1"/>
+                </a:solidFill>
+                <a:latin typeface="Arial" panose="020B0604020202020204" pitchFamily="34" charset="0"/>
+                <a:cs typeface="Arial" panose="020B0604020202020204" pitchFamily="34" charset="0"/>
+              </a:endParaRPr>
+            </a:p>
+            <a:p>
+              <a:pPr algn="ctr">
+                <a:lnSpc>
+                  <a:spcPts val="600"/>
+                </a:lnSpc>
+              </a:pPr>
+              <a:endParaRPr lang="en-US" sz="1400" dirty="0">
+                <a:solidFill>
+                  <a:schemeClr val="tx1"/>
+                </a:solidFill>
+                <a:latin typeface="Arial" panose="020B0604020202020204" pitchFamily="34" charset="0"/>
+                <a:cs typeface="Arial" panose="020B0604020202020204" pitchFamily="34" charset="0"/>
+              </a:endParaRPr>
+            </a:p>
+            <a:p>
+              <a:pPr algn="ctr">
+                <a:lnSpc>
+                  <a:spcPts val="600"/>
+                </a:lnSpc>
+              </a:pPr>
+              <a:r>
+                <a:rPr lang="en-US" sz="1400" dirty="0">
+                  <a:solidFill>
+                    <a:schemeClr val="tx1"/>
+                  </a:solidFill>
+                  <a:latin typeface="Arial" panose="020B0604020202020204" pitchFamily="34" charset="0"/>
+                  <a:cs typeface="Arial" panose="020B0604020202020204" pitchFamily="34" charset="0"/>
+                </a:rPr>
+                <a:t>Post-optimality sensitivities</a:t>
+              </a:r>
+            </a:p>
+          </p:txBody>
+        </p:sp>
+        <p:pic>
+          <p:nvPicPr>
+            <p:cNvPr id="52" name="Picture 51">
+              <a:extLst>
+                <a:ext uri="{FF2B5EF4-FFF2-40B4-BE49-F238E27FC236}">
+                  <a16:creationId xmlns:a16="http://schemas.microsoft.com/office/drawing/2014/main" id="{18733C4D-B9F1-31FA-916E-61B05A8BB422}"/>
+                </a:ext>
+              </a:extLst>
+            </p:cNvPr>
+            <p:cNvPicPr>
+              <a:picLocks noChangeAspect="1"/>
+            </p:cNvPicPr>
+            <p:nvPr/>
+          </p:nvPicPr>
+          <p:blipFill>
+            <a:blip r:embed="rId5"/>
+            <a:stretch>
+              <a:fillRect/>
+            </a:stretch>
+          </p:blipFill>
+          <p:spPr>
+            <a:xfrm>
+              <a:off x="4762060" y="3391878"/>
+              <a:ext cx="1155700" cy="215900"/>
+            </a:xfrm>
+            <a:prstGeom prst="rect">
+              <a:avLst/>
+            </a:prstGeom>
+          </p:spPr>
+        </p:pic>
+      </p:grpSp>
+      <p:grpSp>
+        <p:nvGrpSpPr>
+          <p:cNvPr id="55" name="Group 54">
+            <a:extLst>
+              <a:ext uri="{FF2B5EF4-FFF2-40B4-BE49-F238E27FC236}">
+                <a16:creationId xmlns:a16="http://schemas.microsoft.com/office/drawing/2014/main" id="{58AE0531-3A63-3B93-5AA0-B5C43B894D35}"/>
+              </a:ext>
+            </a:extLst>
+          </p:cNvPr>
+          <p:cNvGrpSpPr/>
+          <p:nvPr/>
+        </p:nvGrpSpPr>
+        <p:grpSpPr>
+          <a:xfrm>
+            <a:off x="545110" y="2933393"/>
+            <a:ext cx="2900856" cy="867542"/>
+            <a:chOff x="545110" y="2933393"/>
+            <a:chExt cx="2900856" cy="867542"/>
+          </a:xfrm>
+        </p:grpSpPr>
+        <p:sp>
+          <p:nvSpPr>
+            <p:cNvPr id="17" name="Rounded Rectangle 16">
+              <a:extLst>
+                <a:ext uri="{FF2B5EF4-FFF2-40B4-BE49-F238E27FC236}">
+                  <a16:creationId xmlns:a16="http://schemas.microsoft.com/office/drawing/2014/main" id="{996D6C08-DD62-5253-3737-6920E28C4383}"/>
+                </a:ext>
+              </a:extLst>
+            </p:cNvPr>
+            <p:cNvSpPr/>
+            <p:nvPr/>
+          </p:nvSpPr>
+          <p:spPr>
+            <a:xfrm>
+              <a:off x="545110" y="2933393"/>
+              <a:ext cx="2900856" cy="867542"/>
+            </a:xfrm>
+            <a:prstGeom prst="roundRect">
+              <a:avLst/>
+            </a:prstGeom>
+            <a:solidFill>
+              <a:schemeClr val="bg1"/>
+            </a:solidFill>
+            <a:ln w="12700">
+              <a:solidFill>
+                <a:schemeClr val="tx1"/>
+              </a:solidFill>
+            </a:ln>
+          </p:spPr>
+          <p:style>
+            <a:lnRef idx="2">
+              <a:schemeClr val="accent1">
+                <a:shade val="15000"/>
+              </a:schemeClr>
+            </a:lnRef>
+            <a:fillRef idx="1">
+              <a:schemeClr val="accent1"/>
+            </a:fillRef>
+            <a:effectRef idx="0">
+              <a:schemeClr val="accent1"/>
+            </a:effectRef>
+            <a:fontRef idx="minor">
+              <a:schemeClr val="lt1"/>
+            </a:fontRef>
+          </p:style>
+          <p:txBody>
+            <a:bodyPr rtlCol="0" anchor="t"/>
+            <a:lstStyle/>
+            <a:p>
+              <a:pPr algn="ctr"/>
+              <a:r>
+                <a:rPr lang="en-US" sz="1400" dirty="0">
+                  <a:solidFill>
+                    <a:schemeClr val="tx1"/>
+                  </a:solidFill>
+                  <a:latin typeface="Arial" panose="020B0604020202020204" pitchFamily="34" charset="0"/>
+                  <a:cs typeface="Arial" panose="020B0604020202020204" pitchFamily="34" charset="0"/>
+                </a:rPr>
+                <a:t>Approximate optimization</a:t>
+              </a:r>
+            </a:p>
+          </p:txBody>
+        </p:sp>
+        <p:pic>
+          <p:nvPicPr>
+            <p:cNvPr id="54" name="Picture 53">
+              <a:extLst>
+                <a:ext uri="{FF2B5EF4-FFF2-40B4-BE49-F238E27FC236}">
+                  <a16:creationId xmlns:a16="http://schemas.microsoft.com/office/drawing/2014/main" id="{D5E4159D-50B3-F730-A3B8-C3BCF95E9D9E}"/>
+                </a:ext>
+              </a:extLst>
+            </p:cNvPr>
+            <p:cNvPicPr>
+              <a:picLocks noChangeAspect="1"/>
+            </p:cNvPicPr>
+            <p:nvPr/>
+          </p:nvPicPr>
+          <p:blipFill>
+            <a:blip r:embed="rId6"/>
+            <a:stretch>
+              <a:fillRect/>
+            </a:stretch>
+          </p:blipFill>
+          <p:spPr>
+            <a:xfrm>
+              <a:off x="730302" y="3291273"/>
+              <a:ext cx="2540000" cy="457200"/>
+            </a:xfrm>
+            <a:prstGeom prst="rect">
+              <a:avLst/>
+            </a:prstGeom>
+          </p:spPr>
+        </p:pic>
+      </p:grpSp>
+      <p:grpSp>
+        <p:nvGrpSpPr>
+          <p:cNvPr id="59" name="Group 58">
+            <a:extLst>
+              <a:ext uri="{FF2B5EF4-FFF2-40B4-BE49-F238E27FC236}">
+                <a16:creationId xmlns:a16="http://schemas.microsoft.com/office/drawing/2014/main" id="{FE46FC42-287F-4305-CC5E-96767FFB9EE1}"/>
+              </a:ext>
+            </a:extLst>
+          </p:cNvPr>
+          <p:cNvGrpSpPr/>
+          <p:nvPr/>
+        </p:nvGrpSpPr>
+        <p:grpSpPr>
+          <a:xfrm>
+            <a:off x="7233854" y="4235751"/>
+            <a:ext cx="2900856" cy="867542"/>
+            <a:chOff x="7233854" y="4235751"/>
+            <a:chExt cx="2900856" cy="867542"/>
+          </a:xfrm>
+        </p:grpSpPr>
+        <p:sp>
+          <p:nvSpPr>
+            <p:cNvPr id="18" name="Rounded Rectangle 17">
+              <a:extLst>
+                <a:ext uri="{FF2B5EF4-FFF2-40B4-BE49-F238E27FC236}">
+                  <a16:creationId xmlns:a16="http://schemas.microsoft.com/office/drawing/2014/main" id="{33175857-17CD-3A49-801F-8E1C23FB94B3}"/>
+                </a:ext>
+              </a:extLst>
+            </p:cNvPr>
+            <p:cNvSpPr/>
+            <p:nvPr/>
+          </p:nvSpPr>
+          <p:spPr>
+            <a:xfrm>
+              <a:off x="7233854" y="4235751"/>
+              <a:ext cx="2900856" cy="867542"/>
+            </a:xfrm>
+            <a:prstGeom prst="roundRect">
+              <a:avLst/>
+            </a:prstGeom>
+            <a:solidFill>
+              <a:schemeClr val="bg1"/>
+            </a:solidFill>
+            <a:ln w="12700">
+              <a:solidFill>
+                <a:schemeClr val="tx1"/>
+              </a:solidFill>
+            </a:ln>
+          </p:spPr>
+          <p:style>
+            <a:lnRef idx="2">
+              <a:schemeClr val="accent1">
+                <a:shade val="15000"/>
+              </a:schemeClr>
+            </a:lnRef>
+            <a:fillRef idx="1">
+              <a:schemeClr val="accent1"/>
+            </a:fillRef>
+            <a:effectRef idx="0">
+              <a:schemeClr val="accent1"/>
+            </a:effectRef>
+            <a:fontRef idx="minor">
+              <a:schemeClr val="lt1"/>
+            </a:fontRef>
+          </p:style>
+          <p:txBody>
+            <a:bodyPr rtlCol="0" anchor="t"/>
+            <a:lstStyle/>
+            <a:p>
+              <a:pPr algn="ctr">
+                <a:lnSpc>
+                  <a:spcPts val="600"/>
+                </a:lnSpc>
+              </a:pPr>
+              <a:endParaRPr lang="en-US" sz="1400" dirty="0">
+                <a:solidFill>
+                  <a:schemeClr val="tx1"/>
+                </a:solidFill>
+                <a:latin typeface="Arial" panose="020B0604020202020204" pitchFamily="34" charset="0"/>
+                <a:cs typeface="Arial" panose="020B0604020202020204" pitchFamily="34" charset="0"/>
+              </a:endParaRPr>
+            </a:p>
+            <a:p>
+              <a:pPr algn="ctr">
+                <a:lnSpc>
+                  <a:spcPts val="600"/>
+                </a:lnSpc>
+              </a:pPr>
+              <a:endParaRPr lang="en-US" sz="1400" dirty="0">
+                <a:solidFill>
+                  <a:schemeClr val="tx1"/>
+                </a:solidFill>
+                <a:latin typeface="Arial" panose="020B0604020202020204" pitchFamily="34" charset="0"/>
+                <a:cs typeface="Arial" panose="020B0604020202020204" pitchFamily="34" charset="0"/>
+              </a:endParaRPr>
+            </a:p>
+            <a:p>
+              <a:pPr algn="ctr">
+                <a:lnSpc>
+                  <a:spcPts val="600"/>
+                </a:lnSpc>
+              </a:pPr>
+              <a:r>
+                <a:rPr lang="en-US" sz="1400" dirty="0">
+                  <a:solidFill>
+                    <a:schemeClr val="tx1"/>
+                  </a:solidFill>
+                  <a:latin typeface="Arial" panose="020B0604020202020204" pitchFamily="34" charset="0"/>
+                  <a:cs typeface="Arial" panose="020B0604020202020204" pitchFamily="34" charset="0"/>
+                </a:rPr>
+                <a:t>Prior and hyperparameters</a:t>
+              </a:r>
+            </a:p>
+          </p:txBody>
+        </p:sp>
+        <p:pic>
+          <p:nvPicPr>
+            <p:cNvPr id="58" name="Picture 57">
+              <a:extLst>
+                <a:ext uri="{FF2B5EF4-FFF2-40B4-BE49-F238E27FC236}">
+                  <a16:creationId xmlns:a16="http://schemas.microsoft.com/office/drawing/2014/main" id="{989A23CB-CC1F-4BE0-F6DB-5F55D7441F84}"/>
+                </a:ext>
+              </a:extLst>
+            </p:cNvPr>
+            <p:cNvPicPr>
+              <a:picLocks noChangeAspect="1"/>
+            </p:cNvPicPr>
+            <p:nvPr/>
+          </p:nvPicPr>
+          <p:blipFill>
+            <a:blip r:embed="rId7"/>
+            <a:stretch>
+              <a:fillRect/>
+            </a:stretch>
+          </p:blipFill>
+          <p:spPr>
+            <a:xfrm>
+              <a:off x="7680982" y="4682145"/>
+              <a:ext cx="2006600" cy="215900"/>
+            </a:xfrm>
+            <a:prstGeom prst="rect">
+              <a:avLst/>
+            </a:prstGeom>
+          </p:spPr>
+        </p:pic>
+      </p:grpSp>
+    </p:spTree>
+    <p:extLst>
+      <p:ext uri="{BB962C8B-B14F-4D97-AF65-F5344CB8AC3E}">
+        <p14:creationId xmlns:p14="http://schemas.microsoft.com/office/powerpoint/2010/main" val="2503150717"/>
+      </p:ext>
+    </p:extLst>
+  </p:cSld>
+  <p:clrMapOvr>
+    <a:masterClrMapping/>
+  </p:clrMapOvr>
+</p:sld>
+</file>
+
+<file path=ppt/slides/slide5.xml><?xml version="1.0" encoding="utf-8"?>
 <p:sld xmlns:a="http://schemas.openxmlformats.org/drawingml/2006/main" xmlns:r="http://schemas.openxmlformats.org/officeDocument/2006/relationships" xmlns:p="http://schemas.openxmlformats.org/presentationml/2006/main" show="0">
   <p:cSld>
     <p:spTree>

</xml_diff>